<commit_message>
Updated Doxygen version and documentation
</commit_message>
<xml_diff>
--- a/documentation/doxygen/general/src/images/overview.pptx
+++ b/documentation/doxygen/general/src/images/overview.pptx
@@ -5,13 +5,15 @@
     <p:sldMasterId id="2147483661" r:id="rId1"/>
   </p:sldMasterIdLst>
   <p:notesMasterIdLst>
-    <p:notesMasterId r:id="rId3"/>
+    <p:notesMasterId r:id="rId5"/>
   </p:notesMasterIdLst>
   <p:handoutMasterIdLst>
-    <p:handoutMasterId r:id="rId4"/>
+    <p:handoutMasterId r:id="rId6"/>
   </p:handoutMasterIdLst>
   <p:sldIdLst>
     <p:sldId id="548" r:id="rId2"/>
+    <p:sldId id="2147479562" r:id="rId3"/>
+    <p:sldId id="549" r:id="rId4"/>
   </p:sldIdLst>
   <p:sldSz cx="12192000" cy="6858000"/>
   <p:notesSz cx="6858000" cy="9144000"/>
@@ -259,7 +261,7 @@
           <a:p>
             <a:fld id="{008FFADC-39A7-449E-8C68-8776E6FB3C1A}" type="datetimeFigureOut">
               <a:rPr lang="en-GB" smtClean="0"/>
-              <a:t>10/06/2026</a:t>
+              <a:t>07/08/2026</a:t>
             </a:fld>
             <a:endParaRPr lang="en-GB"/>
           </a:p>
@@ -436,7 +438,7 @@
           <a:p>
             <a:fld id="{30B9BAAB-B703-4BB5-9D08-B460FC03C23A}" type="datetimeFigureOut">
               <a:rPr lang="en-GB" smtClean="0"/>
-              <a:t>10/06/2026</a:t>
+              <a:t>07/08/2026</a:t>
             </a:fld>
             <a:endParaRPr lang="en-GB"/>
           </a:p>
@@ -702,6 +704,123 @@
     </a:lvl9pPr>
   </p:notesStyle>
 </p:notesMaster>
+</file>
+
+<file path=ppt/notesSlides/notesSlide1.xml><?xml version="1.0" encoding="utf-8"?>
+<p:notes xmlns:a="http://schemas.openxmlformats.org/drawingml/2006/main" xmlns:r="http://schemas.openxmlformats.org/officeDocument/2006/relationships" xmlns:p="http://schemas.openxmlformats.org/presentationml/2006/main">
+  <p:cSld>
+    <p:spTree>
+      <p:nvGrpSpPr>
+        <p:cNvPr id="1" name=""/>
+        <p:cNvGrpSpPr/>
+        <p:nvPr/>
+      </p:nvGrpSpPr>
+      <p:grpSpPr>
+        <a:xfrm>
+          <a:off x="0" y="0"/>
+          <a:ext cx="0" cy="0"/>
+          <a:chOff x="0" y="0"/>
+          <a:chExt cx="0" cy="0"/>
+        </a:xfrm>
+      </p:grpSpPr>
+      <p:sp>
+        <p:nvSpPr>
+          <p:cNvPr id="2" name="Slide Image Placeholder 1"/>
+          <p:cNvSpPr>
+            <a:spLocks noGrp="1" noRot="1" noChangeAspect="1"/>
+          </p:cNvSpPr>
+          <p:nvPr>
+            <p:ph type="sldImg"/>
+          </p:nvPr>
+        </p:nvSpPr>
+        <p:spPr/>
+        <p:txBody>
+          <a:bodyPr/>
+          <a:lstStyle/>
+          <a:p>
+            <a:endParaRPr lang="en-US"/>
+          </a:p>
+        </p:txBody>
+      </p:sp>
+      <p:sp>
+        <p:nvSpPr>
+          <p:cNvPr id="3" name="Notes Placeholder 2"/>
+          <p:cNvSpPr>
+            <a:spLocks noGrp="1"/>
+          </p:cNvSpPr>
+          <p:nvPr>
+            <p:ph type="body" idx="1"/>
+          </p:nvPr>
+        </p:nvSpPr>
+        <p:spPr/>
+        <p:txBody>
+          <a:bodyPr/>
+          <a:lstStyle/>
+          <a:p>
+            <a:r>
+              <a:rPr lang="en-US" dirty="0"/>
+              <a:t>ML models from ecosystem partners or open-source model zoos such as Hugging Face are quantized and optimized for embedded deployment. CMSIS-NN executes these optimized models on Cortex-M processors. For Ethos-U NPU targets, Vela converts model operations for NPU acceleration, while operations that cannot be converted continue to run on Cortex-M via CMSIS-NN.</a:t>
+            </a:r>
+          </a:p>
+          <a:p>
+            <a:endParaRPr lang="en-US" dirty="0"/>
+          </a:p>
+          <a:p>
+            <a:r>
+              <a:rPr lang="en-US" dirty="0"/>
+              <a:t>Using these workflows, developers can deploy trained models from </a:t>
+            </a:r>
+            <a:r>
+              <a:rPr lang="en-US" dirty="0" err="1"/>
+              <a:t>PyTorch</a:t>
+            </a:r>
+            <a:r>
+              <a:rPr lang="en-US" dirty="0"/>
+              <a:t>, TensorFlow, and other frameworks onto Arm targets with optimal performance and energy efficiency, enabling intelligent capabilities in IoT devices, wearables, industrial sensors, and other edge computing applications.</a:t>
+            </a:r>
+          </a:p>
+        </p:txBody>
+      </p:sp>
+      <p:sp>
+        <p:nvSpPr>
+          <p:cNvPr id="4" name="Slide Number Placeholder 3"/>
+          <p:cNvSpPr>
+            <a:spLocks noGrp="1"/>
+          </p:cNvSpPr>
+          <p:nvPr>
+            <p:ph type="sldNum" sz="quarter" idx="5"/>
+          </p:nvPr>
+        </p:nvSpPr>
+        <p:spPr/>
+        <p:txBody>
+          <a:bodyPr/>
+          <a:lstStyle/>
+          <a:p>
+            <a:pPr>
+              <a:defRPr/>
+            </a:pPr>
+            <a:fld id="{3B16354E-6974-4833-AB87-3220A0835E84}" type="slidenum">
+              <a:rPr lang="en-US" altLang="en-US" smtClean="0"/>
+              <a:pPr>
+                <a:defRPr/>
+              </a:pPr>
+              <a:t>2</a:t>
+            </a:fld>
+            <a:endParaRPr lang="en-US" altLang="en-US"/>
+          </a:p>
+        </p:txBody>
+      </p:sp>
+    </p:spTree>
+    <p:extLst>
+      <p:ext uri="{BB962C8B-B14F-4D97-AF65-F5344CB8AC3E}">
+        <p14:creationId xmlns:p14="http://schemas.microsoft.com/office/powerpoint/2010/main" val="1343268853"/>
+      </p:ext>
+    </p:extLst>
+  </p:cSld>
+  <p:clrMapOvr>
+    <a:masterClrMapping/>
+  </p:clrMapOvr>
+</p:notes>
 </file>
 
 <file path=ppt/slideLayouts/slideLayout1.xml><?xml version="1.0" encoding="utf-8"?>
@@ -8513,6 +8632,1883 @@
     <p:extLst>
       <p:ext uri="{BB962C8B-B14F-4D97-AF65-F5344CB8AC3E}">
         <p14:creationId xmlns:p14="http://schemas.microsoft.com/office/powerpoint/2010/main" val="3891785370"/>
+      </p:ext>
+    </p:extLst>
+  </p:cSld>
+  <p:clrMapOvr>
+    <a:masterClrMapping/>
+  </p:clrMapOvr>
+</p:sld>
+</file>
+
+<file path=ppt/slides/slide2.xml><?xml version="1.0" encoding="utf-8"?>
+<p:sld xmlns:a="http://schemas.openxmlformats.org/drawingml/2006/main" xmlns:r="http://schemas.openxmlformats.org/officeDocument/2006/relationships" xmlns:p="http://schemas.openxmlformats.org/presentationml/2006/main">
+  <p:cSld>
+    <p:spTree>
+      <p:nvGrpSpPr>
+        <p:cNvPr id="1" name="">
+          <a:extLst>
+            <a:ext uri="{FF2B5EF4-FFF2-40B4-BE49-F238E27FC236}">
+              <a16:creationId xmlns:a16="http://schemas.microsoft.com/office/drawing/2014/main" id="{7FE8CB31-D479-813F-1133-4DB5A2F61AE3}"/>
+            </a:ext>
+          </a:extLst>
+        </p:cNvPr>
+        <p:cNvGrpSpPr/>
+        <p:nvPr/>
+      </p:nvGrpSpPr>
+      <p:grpSpPr>
+        <a:xfrm>
+          <a:off x="0" y="0"/>
+          <a:ext cx="0" cy="0"/>
+          <a:chOff x="0" y="0"/>
+          <a:chExt cx="0" cy="0"/>
+        </a:xfrm>
+      </p:grpSpPr>
+      <p:sp>
+        <p:nvSpPr>
+          <p:cNvPr id="4" name="Process 1">
+            <a:extLst>
+              <a:ext uri="{FF2B5EF4-FFF2-40B4-BE49-F238E27FC236}">
+                <a16:creationId xmlns:a16="http://schemas.microsoft.com/office/drawing/2014/main" id="{4FCF63CE-1B35-24F1-B1FD-F082296A3DE8}"/>
+              </a:ext>
+            </a:extLst>
+          </p:cNvPr>
+          <p:cNvSpPr>
+            <a:spLocks/>
+          </p:cNvSpPr>
+          <p:nvPr/>
+        </p:nvSpPr>
+        <p:spPr>
+          <a:xfrm>
+            <a:off x="1311874" y="2099558"/>
+            <a:ext cx="3313741" cy="3125586"/>
+          </a:xfrm>
+          <a:prstGeom prst="flowChartProcess">
+            <a:avLst/>
+          </a:prstGeom>
+          <a:solidFill>
+            <a:schemeClr val="tx1">
+              <a:lumMod val="50000"/>
+              <a:lumOff val="50000"/>
+            </a:schemeClr>
+          </a:solidFill>
+          <a:ln w="15875">
+            <a:solidFill>
+              <a:schemeClr val="bg1"/>
+            </a:solidFill>
+          </a:ln>
+        </p:spPr>
+        <p:style>
+          <a:lnRef idx="2">
+            <a:schemeClr val="accent1">
+              <a:shade val="50000"/>
+            </a:schemeClr>
+          </a:lnRef>
+          <a:fillRef idx="1">
+            <a:schemeClr val="accent1"/>
+          </a:fillRef>
+          <a:effectRef idx="0">
+            <a:schemeClr val="accent1"/>
+          </a:effectRef>
+          <a:fontRef idx="minor">
+            <a:schemeClr val="lt1"/>
+          </a:fontRef>
+        </p:style>
+        <p:txBody>
+          <a:bodyPr tIns="108000" rtlCol="0" anchor="t"/>
+          <a:lstStyle/>
+          <a:p>
+            <a:pPr algn="ctr" defTabSz="1219170">
+              <a:defRPr/>
+            </a:pPr>
+            <a:r>
+              <a:rPr lang="en-US" b="1" spc="400">
+                <a:solidFill>
+                  <a:srgbClr val="FFFFFF"/>
+                </a:solidFill>
+                <a:latin typeface="Arial" panose="020B0604020202020204" pitchFamily="34" charset="0"/>
+                <a:ea typeface="ＭＳ Ｐゴシック" charset="0"/>
+                <a:cs typeface="Arial" panose="020B0604020202020204" pitchFamily="34" charset="0"/>
+              </a:rPr>
+              <a:t>HOST (OFFLINE)</a:t>
+            </a:r>
+          </a:p>
+        </p:txBody>
+      </p:sp>
+      <p:sp>
+        <p:nvSpPr>
+          <p:cNvPr id="2" name="Title 1">
+            <a:extLst>
+              <a:ext uri="{FF2B5EF4-FFF2-40B4-BE49-F238E27FC236}">
+                <a16:creationId xmlns:a16="http://schemas.microsoft.com/office/drawing/2014/main" id="{FDC469D0-27D4-7479-20B3-B424DE886CDE}"/>
+              </a:ext>
+            </a:extLst>
+          </p:cNvPr>
+          <p:cNvSpPr>
+            <a:spLocks noGrp="1"/>
+          </p:cNvSpPr>
+          <p:nvPr>
+            <p:ph type="title"/>
+          </p:nvPr>
+        </p:nvSpPr>
+        <p:spPr/>
+        <p:txBody>
+          <a:bodyPr/>
+          <a:lstStyle/>
+          <a:p>
+            <a:r>
+              <a:rPr lang="en-US"/>
+              <a:t>Ethos-U Optimized Software Flow for </a:t>
+            </a:r>
+            <a:r>
+              <a:rPr lang="en-US" err="1"/>
+              <a:t>Tensorflow</a:t>
+            </a:r>
+            <a:r>
+              <a:rPr lang="en-US"/>
+              <a:t>/</a:t>
+            </a:r>
+            <a:r>
+              <a:rPr lang="en-US" err="1"/>
+              <a:t>PyTorch</a:t>
+            </a:r>
+            <a:endParaRPr lang="en-US"/>
+          </a:p>
+        </p:txBody>
+      </p:sp>
+      <p:sp>
+        <p:nvSpPr>
+          <p:cNvPr id="29" name="Text Placeholder 28">
+            <a:extLst>
+              <a:ext uri="{FF2B5EF4-FFF2-40B4-BE49-F238E27FC236}">
+                <a16:creationId xmlns:a16="http://schemas.microsoft.com/office/drawing/2014/main" id="{9932E99C-CFB9-B2EB-9766-774541C1F639}"/>
+              </a:ext>
+            </a:extLst>
+          </p:cNvPr>
+          <p:cNvSpPr>
+            <a:spLocks noGrp="1"/>
+          </p:cNvSpPr>
+          <p:nvPr>
+            <p:ph type="body" sz="quarter" idx="13"/>
+          </p:nvPr>
+        </p:nvSpPr>
+        <p:spPr/>
+        <p:txBody>
+          <a:bodyPr/>
+          <a:lstStyle/>
+          <a:p>
+            <a:r>
+              <a:rPr lang="en-US">
+                <a:hlinkClick r:id="rId3"/>
+              </a:rPr>
+              <a:t>github.com/Arm-Examples#edge-ai-and-machine-learning</a:t>
+            </a:r>
+            <a:endParaRPr lang="en-US"/>
+          </a:p>
+        </p:txBody>
+      </p:sp>
+      <p:sp>
+        <p:nvSpPr>
+          <p:cNvPr id="11" name="Process 65">
+            <a:extLst>
+              <a:ext uri="{FF2B5EF4-FFF2-40B4-BE49-F238E27FC236}">
+                <a16:creationId xmlns:a16="http://schemas.microsoft.com/office/drawing/2014/main" id="{2A273938-131D-99FA-670C-949235DE00D4}"/>
+              </a:ext>
+            </a:extLst>
+          </p:cNvPr>
+          <p:cNvSpPr>
+            <a:spLocks/>
+          </p:cNvSpPr>
+          <p:nvPr/>
+        </p:nvSpPr>
+        <p:spPr>
+          <a:xfrm>
+            <a:off x="4769708" y="2094471"/>
+            <a:ext cx="6110417" cy="3125586"/>
+          </a:xfrm>
+          <a:prstGeom prst="flowChartProcess">
+            <a:avLst/>
+          </a:prstGeom>
+          <a:solidFill>
+            <a:schemeClr val="bg2">
+              <a:lumMod val="50000"/>
+            </a:schemeClr>
+          </a:solidFill>
+          <a:ln w="0">
+            <a:solidFill>
+              <a:schemeClr val="bg1"/>
+            </a:solidFill>
+          </a:ln>
+        </p:spPr>
+        <p:style>
+          <a:lnRef idx="2">
+            <a:schemeClr val="accent1">
+              <a:shade val="50000"/>
+            </a:schemeClr>
+          </a:lnRef>
+          <a:fillRef idx="1">
+            <a:schemeClr val="accent1"/>
+          </a:fillRef>
+          <a:effectRef idx="0">
+            <a:schemeClr val="accent1"/>
+          </a:effectRef>
+          <a:fontRef idx="minor">
+            <a:schemeClr val="lt1"/>
+          </a:fontRef>
+        </p:style>
+        <p:txBody>
+          <a:bodyPr tIns="108000" rtlCol="0" anchor="t"/>
+          <a:lstStyle/>
+          <a:p>
+            <a:pPr algn="ctr" defTabSz="1219170">
+              <a:defRPr/>
+            </a:pPr>
+            <a:r>
+              <a:rPr lang="en-US" b="1" spc="400" dirty="0">
+                <a:solidFill>
+                  <a:srgbClr val="FFFFFF"/>
+                </a:solidFill>
+                <a:latin typeface="Arial" panose="020B0604020202020204" pitchFamily="34" charset="0"/>
+                <a:ea typeface="ＭＳ Ｐゴシック" charset="0"/>
+                <a:cs typeface="Arial" panose="020B0604020202020204" pitchFamily="34" charset="0"/>
+              </a:rPr>
+              <a:t>DEVICE with Ethos-U</a:t>
+            </a:r>
+          </a:p>
+        </p:txBody>
+      </p:sp>
+      <p:sp>
+        <p:nvSpPr>
+          <p:cNvPr id="14" name="角丸四角形 7">
+            <a:extLst>
+              <a:ext uri="{FF2B5EF4-FFF2-40B4-BE49-F238E27FC236}">
+                <a16:creationId xmlns:a16="http://schemas.microsoft.com/office/drawing/2014/main" id="{4A4BEEB3-6ABA-56BD-435A-F8B37D701949}"/>
+              </a:ext>
+            </a:extLst>
+          </p:cNvPr>
+          <p:cNvSpPr>
+            <a:spLocks/>
+          </p:cNvSpPr>
+          <p:nvPr/>
+        </p:nvSpPr>
+        <p:spPr>
+          <a:xfrm>
+            <a:off x="7497538" y="2576367"/>
+            <a:ext cx="1238946" cy="1007207"/>
+          </a:xfrm>
+          <a:prstGeom prst="roundRect">
+            <a:avLst>
+              <a:gd name="adj" fmla="val 0"/>
+            </a:avLst>
+          </a:prstGeom>
+          <a:solidFill>
+            <a:schemeClr val="accent1"/>
+          </a:solidFill>
+          <a:ln>
+            <a:noFill/>
+          </a:ln>
+        </p:spPr>
+        <p:style>
+          <a:lnRef idx="0">
+            <a:scrgbClr r="0" g="0" b="0"/>
+          </a:lnRef>
+          <a:fillRef idx="0">
+            <a:scrgbClr r="0" g="0" b="0"/>
+          </a:fillRef>
+          <a:effectRef idx="0">
+            <a:scrgbClr r="0" g="0" b="0"/>
+          </a:effectRef>
+          <a:fontRef idx="minor">
+            <a:schemeClr val="lt1"/>
+          </a:fontRef>
+        </p:style>
+        <p:txBody>
+          <a:bodyPr rtlCol="0" anchor="ctr" anchorCtr="1"/>
+          <a:lstStyle/>
+          <a:p>
+            <a:pPr marL="0" marR="0" lvl="0" indent="0" algn="ctr" defTabSz="1218804" rtl="0" eaLnBrk="0" fontAlgn="base" latinLnBrk="0" hangingPunct="0">
+              <a:lnSpc>
+                <a:spcPct val="100000"/>
+              </a:lnSpc>
+              <a:spcBef>
+                <a:spcPct val="0"/>
+              </a:spcBef>
+              <a:spcAft>
+                <a:spcPct val="0"/>
+              </a:spcAft>
+              <a:buClrTx/>
+              <a:buSzTx/>
+              <a:buFontTx/>
+              <a:buNone/>
+              <a:tabLst/>
+              <a:defRPr/>
+            </a:pPr>
+            <a:r>
+              <a:rPr kumimoji="1" lang="sv-SE" altLang="ja-JP" sz="1600" b="0" i="0" u="none" strike="noStrike" kern="1200" cap="none" spc="0" normalizeH="0" baseline="0" noProof="0" dirty="0">
+                <a:ln>
+                  <a:noFill/>
+                </a:ln>
+                <a:solidFill>
+                  <a:prstClr val="white"/>
+                </a:solidFill>
+                <a:effectLst/>
+                <a:uLnTx/>
+                <a:uFillTx/>
+                <a:latin typeface="Arial" panose="020B0604020202020204" pitchFamily="34" charset="0"/>
+                <a:ea typeface="Lato Light" panose="020F0502020204030203" pitchFamily="34" charset="0"/>
+                <a:cs typeface="Arial" panose="020B0604020202020204" pitchFamily="34" charset="0"/>
+              </a:rPr>
+              <a:t>CMSIS-NN</a:t>
+            </a:r>
+            <a:endParaRPr kumimoji="0" lang="en-US" sz="1600" b="0" i="0" u="none" strike="noStrike" kern="1200" cap="none" spc="0" normalizeH="0" baseline="0" noProof="0" dirty="0">
+              <a:ln>
+                <a:noFill/>
+              </a:ln>
+              <a:solidFill>
+                <a:prstClr val="white"/>
+              </a:solidFill>
+              <a:effectLst/>
+              <a:uLnTx/>
+              <a:uFillTx/>
+              <a:latin typeface="Arial" panose="020B0604020202020204" pitchFamily="34" charset="0"/>
+              <a:ea typeface="Lato Light" panose="020F0502020204030203" pitchFamily="34" charset="0"/>
+              <a:cs typeface="Arial" panose="020B0604020202020204" pitchFamily="34" charset="0"/>
+            </a:endParaRPr>
+          </a:p>
+          <a:p>
+            <a:pPr marL="0" marR="0" lvl="0" indent="0" algn="ctr" defTabSz="1218804" rtl="0" eaLnBrk="0" fontAlgn="base" latinLnBrk="0" hangingPunct="0">
+              <a:lnSpc>
+                <a:spcPct val="100000"/>
+              </a:lnSpc>
+              <a:spcBef>
+                <a:spcPct val="0"/>
+              </a:spcBef>
+              <a:spcAft>
+                <a:spcPct val="0"/>
+              </a:spcAft>
+              <a:buClrTx/>
+              <a:buSzTx/>
+              <a:buFontTx/>
+              <a:buNone/>
+              <a:tabLst/>
+              <a:defRPr/>
+            </a:pPr>
+            <a:r>
+              <a:rPr kumimoji="1" lang="sv-SE" altLang="ja-JP" sz="1600" b="0" i="0" u="none" strike="noStrike" kern="1200" cap="none" spc="0" normalizeH="0" baseline="0" noProof="0" dirty="0">
+                <a:ln>
+                  <a:noFill/>
+                </a:ln>
+                <a:solidFill>
+                  <a:prstClr val="white"/>
+                </a:solidFill>
+                <a:effectLst/>
+                <a:uLnTx/>
+                <a:uFillTx/>
+                <a:latin typeface="Arial" panose="020B0604020202020204" pitchFamily="34" charset="0"/>
+                <a:ea typeface="Lato Light" panose="020F0502020204030203" pitchFamily="34" charset="0"/>
+                <a:cs typeface="Arial" panose="020B0604020202020204" pitchFamily="34" charset="0"/>
+              </a:rPr>
+              <a:t>Optimized Kernels</a:t>
+            </a:r>
+            <a:endParaRPr kumimoji="0" lang="en-US" altLang="ja-JP" sz="1600" b="0" i="0" u="none" strike="noStrike" kern="1200" cap="none" spc="0" normalizeH="0" baseline="0" noProof="0" dirty="0">
+              <a:ln>
+                <a:noFill/>
+              </a:ln>
+              <a:solidFill>
+                <a:prstClr val="white"/>
+              </a:solidFill>
+              <a:effectLst/>
+              <a:uLnTx/>
+              <a:uFillTx/>
+              <a:latin typeface="Arial" panose="020B0604020202020204" pitchFamily="34" charset="0"/>
+              <a:ea typeface="Lato Light" panose="020F0502020204030203" pitchFamily="34" charset="0"/>
+              <a:cs typeface="Arial" panose="020B0604020202020204" pitchFamily="34" charset="0"/>
+            </a:endParaRPr>
+          </a:p>
+        </p:txBody>
+      </p:sp>
+      <p:sp>
+        <p:nvSpPr>
+          <p:cNvPr id="15" name="Rectangle 14">
+            <a:extLst>
+              <a:ext uri="{FF2B5EF4-FFF2-40B4-BE49-F238E27FC236}">
+                <a16:creationId xmlns:a16="http://schemas.microsoft.com/office/drawing/2014/main" id="{E4FAB7E5-0E21-B079-B67A-C8A4D53F3621}"/>
+              </a:ext>
+            </a:extLst>
+          </p:cNvPr>
+          <p:cNvSpPr>
+            <a:spLocks/>
+          </p:cNvSpPr>
+          <p:nvPr/>
+        </p:nvSpPr>
+        <p:spPr>
+          <a:xfrm>
+            <a:off x="9196335" y="2582562"/>
+            <a:ext cx="1238946" cy="991024"/>
+          </a:xfrm>
+          <a:prstGeom prst="rect">
+            <a:avLst/>
+          </a:prstGeom>
+          <a:solidFill>
+            <a:schemeClr val="accent1"/>
+          </a:solidFill>
+          <a:ln>
+            <a:noFill/>
+          </a:ln>
+        </p:spPr>
+        <p:style>
+          <a:lnRef idx="0">
+            <a:scrgbClr r="0" g="0" b="0"/>
+          </a:lnRef>
+          <a:fillRef idx="0">
+            <a:scrgbClr r="0" g="0" b="0"/>
+          </a:fillRef>
+          <a:effectRef idx="0">
+            <a:scrgbClr r="0" g="0" b="0"/>
+          </a:effectRef>
+          <a:fontRef idx="minor">
+            <a:schemeClr val="lt1"/>
+          </a:fontRef>
+        </p:style>
+        <p:txBody>
+          <a:bodyPr rtlCol="0" anchor="ctr"/>
+          <a:lstStyle/>
+          <a:p>
+            <a:pPr marL="0" marR="0" lvl="0" indent="0" algn="ctr" defTabSz="1218804" rtl="0" eaLnBrk="0" fontAlgn="base" latinLnBrk="0" hangingPunct="0">
+              <a:lnSpc>
+                <a:spcPct val="100000"/>
+              </a:lnSpc>
+              <a:spcBef>
+                <a:spcPct val="0"/>
+              </a:spcBef>
+              <a:spcAft>
+                <a:spcPct val="0"/>
+              </a:spcAft>
+              <a:buClrTx/>
+              <a:buSzTx/>
+              <a:buFontTx/>
+              <a:buNone/>
+              <a:tabLst/>
+              <a:defRPr/>
+            </a:pPr>
+            <a:r>
+              <a:rPr kumimoji="0" lang="en-GB" sz="1600" b="0" i="0" u="none" strike="noStrike" kern="1200" cap="none" spc="0" normalizeH="0" baseline="0" noProof="0">
+                <a:ln>
+                  <a:noFill/>
+                </a:ln>
+                <a:solidFill>
+                  <a:prstClr val="white"/>
+                </a:solidFill>
+                <a:effectLst/>
+                <a:uLnTx/>
+                <a:uFillTx/>
+                <a:latin typeface="Arial" panose="020B0604020202020204" pitchFamily="34" charset="0"/>
+                <a:ea typeface="Lato Light" panose="020F0502020204030203" pitchFamily="34" charset="0"/>
+                <a:cs typeface="Arial" panose="020B0604020202020204" pitchFamily="34" charset="0"/>
+              </a:rPr>
+              <a:t>Cortex-M</a:t>
+            </a:r>
+          </a:p>
+          <a:p>
+            <a:pPr marL="0" marR="0" lvl="0" indent="0" algn="ctr" defTabSz="1218804" rtl="0" eaLnBrk="0" fontAlgn="base" latinLnBrk="0" hangingPunct="0">
+              <a:lnSpc>
+                <a:spcPct val="100000"/>
+              </a:lnSpc>
+              <a:spcBef>
+                <a:spcPct val="0"/>
+              </a:spcBef>
+              <a:spcAft>
+                <a:spcPct val="0"/>
+              </a:spcAft>
+              <a:buClrTx/>
+              <a:buSzTx/>
+              <a:buFontTx/>
+              <a:buNone/>
+              <a:tabLst/>
+              <a:defRPr/>
+            </a:pPr>
+            <a:r>
+              <a:rPr kumimoji="0" lang="en-GB" sz="1600" b="0" i="0" u="none" strike="noStrike" kern="1200" cap="none" spc="0" normalizeH="0" baseline="0" noProof="0">
+                <a:ln>
+                  <a:noFill/>
+                </a:ln>
+                <a:solidFill>
+                  <a:prstClr val="white"/>
+                </a:solidFill>
+                <a:effectLst/>
+                <a:uLnTx/>
+                <a:uFillTx/>
+                <a:latin typeface="Arial" panose="020B0604020202020204" pitchFamily="34" charset="0"/>
+                <a:ea typeface="Lato Light" panose="020F0502020204030203" pitchFamily="34" charset="0"/>
+                <a:cs typeface="Arial" panose="020B0604020202020204" pitchFamily="34" charset="0"/>
+              </a:rPr>
+              <a:t>CPU</a:t>
+            </a:r>
+          </a:p>
+        </p:txBody>
+      </p:sp>
+      <p:sp>
+        <p:nvSpPr>
+          <p:cNvPr id="18" name="角丸四角形 7">
+            <a:extLst>
+              <a:ext uri="{FF2B5EF4-FFF2-40B4-BE49-F238E27FC236}">
+                <a16:creationId xmlns:a16="http://schemas.microsoft.com/office/drawing/2014/main" id="{308DED3E-3A0C-74DA-7E1C-9AA424063B8D}"/>
+              </a:ext>
+            </a:extLst>
+          </p:cNvPr>
+          <p:cNvSpPr>
+            <a:spLocks/>
+          </p:cNvSpPr>
+          <p:nvPr/>
+        </p:nvSpPr>
+        <p:spPr>
+          <a:xfrm>
+            <a:off x="7504050" y="4050495"/>
+            <a:ext cx="1238946" cy="991024"/>
+          </a:xfrm>
+          <a:prstGeom prst="roundRect">
+            <a:avLst>
+              <a:gd name="adj" fmla="val 0"/>
+            </a:avLst>
+          </a:prstGeom>
+          <a:solidFill>
+            <a:schemeClr val="accent1">
+              <a:lumMod val="75000"/>
+            </a:schemeClr>
+          </a:solidFill>
+          <a:ln>
+            <a:noFill/>
+          </a:ln>
+        </p:spPr>
+        <p:style>
+          <a:lnRef idx="0">
+            <a:scrgbClr r="0" g="0" b="0"/>
+          </a:lnRef>
+          <a:fillRef idx="0">
+            <a:scrgbClr r="0" g="0" b="0"/>
+          </a:fillRef>
+          <a:effectRef idx="0">
+            <a:scrgbClr r="0" g="0" b="0"/>
+          </a:effectRef>
+          <a:fontRef idx="minor">
+            <a:schemeClr val="lt1"/>
+          </a:fontRef>
+        </p:style>
+        <p:txBody>
+          <a:bodyPr rtlCol="0" anchor="ctr" anchorCtr="1"/>
+          <a:lstStyle/>
+          <a:p>
+            <a:pPr marL="0" marR="0" lvl="0" indent="0" algn="ctr" defTabSz="1218804" rtl="0" eaLnBrk="0" fontAlgn="base" latinLnBrk="0" hangingPunct="0">
+              <a:lnSpc>
+                <a:spcPct val="100000"/>
+              </a:lnSpc>
+              <a:spcBef>
+                <a:spcPct val="0"/>
+              </a:spcBef>
+              <a:spcAft>
+                <a:spcPct val="0"/>
+              </a:spcAft>
+              <a:buClrTx/>
+              <a:buSzTx/>
+              <a:buFontTx/>
+              <a:buNone/>
+              <a:tabLst/>
+              <a:defRPr/>
+            </a:pPr>
+            <a:r>
+              <a:rPr kumimoji="1" lang="sv-SE" altLang="ja-JP" sz="1600" b="0" i="0" u="none" strike="noStrike" kern="1200" cap="none" spc="0" normalizeH="0" baseline="0" noProof="0">
+                <a:ln>
+                  <a:noFill/>
+                </a:ln>
+                <a:solidFill>
+                  <a:prstClr val="white"/>
+                </a:solidFill>
+                <a:effectLst/>
+                <a:uLnTx/>
+                <a:uFillTx/>
+                <a:latin typeface="Arial" panose="020B0604020202020204" pitchFamily="34" charset="0"/>
+                <a:ea typeface="Lato Light" panose="020F0502020204030203" pitchFamily="34" charset="0"/>
+                <a:cs typeface="Arial" panose="020B0604020202020204" pitchFamily="34" charset="0"/>
+              </a:rPr>
+              <a:t>Ethos-U Driver</a:t>
+            </a:r>
+            <a:endParaRPr kumimoji="0" lang="en-US" altLang="ja-JP" sz="1600" b="0" i="0" u="none" strike="noStrike" kern="1200" cap="none" spc="0" normalizeH="0" baseline="0" noProof="0">
+              <a:ln>
+                <a:noFill/>
+              </a:ln>
+              <a:solidFill>
+                <a:prstClr val="white"/>
+              </a:solidFill>
+              <a:effectLst/>
+              <a:uLnTx/>
+              <a:uFillTx/>
+              <a:latin typeface="Arial" panose="020B0604020202020204" pitchFamily="34" charset="0"/>
+              <a:ea typeface="Lato Light" panose="020F0502020204030203" pitchFamily="34" charset="0"/>
+              <a:cs typeface="Arial" panose="020B0604020202020204" pitchFamily="34" charset="0"/>
+            </a:endParaRPr>
+          </a:p>
+        </p:txBody>
+      </p:sp>
+      <p:sp>
+        <p:nvSpPr>
+          <p:cNvPr id="20" name="角丸四角形 6">
+            <a:extLst>
+              <a:ext uri="{FF2B5EF4-FFF2-40B4-BE49-F238E27FC236}">
+                <a16:creationId xmlns:a16="http://schemas.microsoft.com/office/drawing/2014/main" id="{E6453D9D-7C8A-4615-4482-436DC263D8B6}"/>
+              </a:ext>
+            </a:extLst>
+          </p:cNvPr>
+          <p:cNvSpPr>
+            <a:spLocks/>
+          </p:cNvSpPr>
+          <p:nvPr/>
+        </p:nvSpPr>
+        <p:spPr>
+          <a:xfrm>
+            <a:off x="3241807" y="3293081"/>
+            <a:ext cx="1240452" cy="1054166"/>
+          </a:xfrm>
+          <a:prstGeom prst="roundRect">
+            <a:avLst>
+              <a:gd name="adj" fmla="val 0"/>
+            </a:avLst>
+          </a:prstGeom>
+          <a:solidFill>
+            <a:schemeClr val="accent1">
+              <a:lumMod val="75000"/>
+            </a:schemeClr>
+          </a:solidFill>
+          <a:ln w="15875">
+            <a:noFill/>
+          </a:ln>
+        </p:spPr>
+        <p:style>
+          <a:lnRef idx="2">
+            <a:schemeClr val="accent4"/>
+          </a:lnRef>
+          <a:fillRef idx="1">
+            <a:schemeClr val="lt1"/>
+          </a:fillRef>
+          <a:effectRef idx="0">
+            <a:schemeClr val="accent4"/>
+          </a:effectRef>
+          <a:fontRef idx="minor">
+            <a:schemeClr val="dk1"/>
+          </a:fontRef>
+        </p:style>
+        <p:txBody>
+          <a:bodyPr lIns="0" rIns="0" rtlCol="0" anchor="ctr" anchorCtr="1"/>
+          <a:lstStyle/>
+          <a:p>
+            <a:pPr marL="0" marR="0" lvl="0" indent="0" algn="ctr" defTabSz="1218804" rtl="0" eaLnBrk="0" fontAlgn="base" latinLnBrk="0" hangingPunct="0">
+              <a:lnSpc>
+                <a:spcPct val="100000"/>
+              </a:lnSpc>
+              <a:spcBef>
+                <a:spcPct val="0"/>
+              </a:spcBef>
+              <a:spcAft>
+                <a:spcPct val="0"/>
+              </a:spcAft>
+              <a:buClrTx/>
+              <a:buSzTx/>
+              <a:buFontTx/>
+              <a:buNone/>
+              <a:tabLst/>
+              <a:defRPr/>
+            </a:pPr>
+            <a:r>
+              <a:rPr kumimoji="1" lang="sv-SE" altLang="ja-JP" sz="1600" b="0" i="0" u="none" strike="noStrike" kern="1200" cap="none" spc="0" normalizeH="0" baseline="0" noProof="0" dirty="0">
+                <a:ln>
+                  <a:noFill/>
+                </a:ln>
+                <a:solidFill>
+                  <a:srgbClr val="FFFFFF"/>
+                </a:solidFill>
+                <a:effectLst/>
+                <a:uLnTx/>
+                <a:uFillTx/>
+                <a:latin typeface="Arial" panose="020B0604020202020204" pitchFamily="34" charset="0"/>
+                <a:ea typeface="Lato" panose="020F0502020204030203" pitchFamily="34" charset="0"/>
+                <a:cs typeface="Arial" panose="020B0604020202020204" pitchFamily="34" charset="0"/>
+              </a:rPr>
+              <a:t>Vela</a:t>
+            </a:r>
+            <a:br>
+              <a:rPr kumimoji="1" lang="sv-SE" altLang="ja-JP" sz="1600" b="0" i="0" u="none" strike="noStrike" kern="1200" cap="none" spc="0" normalizeH="0" baseline="0" noProof="0" dirty="0">
+                <a:ln>
+                  <a:noFill/>
+                </a:ln>
+                <a:solidFill>
+                  <a:srgbClr val="FFFFFF"/>
+                </a:solidFill>
+                <a:effectLst/>
+                <a:uLnTx/>
+                <a:uFillTx/>
+                <a:latin typeface="Arial" panose="020B0604020202020204" pitchFamily="34" charset="0"/>
+                <a:ea typeface="Lato" panose="020F0502020204030203" pitchFamily="34" charset="0"/>
+                <a:cs typeface="Arial" panose="020B0604020202020204" pitchFamily="34" charset="0"/>
+              </a:rPr>
+            </a:br>
+            <a:r>
+              <a:rPr kumimoji="1" lang="sv-SE" altLang="ja-JP" sz="1600" b="0" i="0" u="none" strike="noStrike" kern="1200" cap="none" spc="0" normalizeH="0" baseline="0" noProof="0" dirty="0">
+                <a:ln>
+                  <a:noFill/>
+                </a:ln>
+                <a:solidFill>
+                  <a:srgbClr val="FFFFFF"/>
+                </a:solidFill>
+                <a:effectLst/>
+                <a:uLnTx/>
+                <a:uFillTx/>
+                <a:latin typeface="Arial" panose="020B0604020202020204" pitchFamily="34" charset="0"/>
+                <a:ea typeface="Lato" panose="020F0502020204030203" pitchFamily="34" charset="0"/>
+                <a:cs typeface="Arial" panose="020B0604020202020204" pitchFamily="34" charset="0"/>
+              </a:rPr>
+              <a:t>Compiler</a:t>
+            </a:r>
+          </a:p>
+        </p:txBody>
+      </p:sp>
+      <p:sp>
+        <p:nvSpPr>
+          <p:cNvPr id="35" name="Right Arrow 34">
+            <a:extLst>
+              <a:ext uri="{FF2B5EF4-FFF2-40B4-BE49-F238E27FC236}">
+                <a16:creationId xmlns:a16="http://schemas.microsoft.com/office/drawing/2014/main" id="{A1D85C2F-7060-6370-50A6-5ED2EDF5FE19}"/>
+              </a:ext>
+            </a:extLst>
+          </p:cNvPr>
+          <p:cNvSpPr>
+            <a:spLocks/>
+          </p:cNvSpPr>
+          <p:nvPr/>
+        </p:nvSpPr>
+        <p:spPr>
+          <a:xfrm>
+            <a:off x="8746015" y="2836039"/>
+            <a:ext cx="450320" cy="535780"/>
+          </a:xfrm>
+          <a:prstGeom prst="rightArrow">
+            <a:avLst/>
+          </a:prstGeom>
+          <a:solidFill>
+            <a:schemeClr val="bg1"/>
+          </a:solidFill>
+          <a:ln>
+            <a:solidFill>
+              <a:schemeClr val="tx2">
+                <a:lumMod val="40000"/>
+                <a:lumOff val="60000"/>
+              </a:schemeClr>
+            </a:solidFill>
+          </a:ln>
+        </p:spPr>
+        <p:style>
+          <a:lnRef idx="2">
+            <a:schemeClr val="accent1">
+              <a:shade val="50000"/>
+            </a:schemeClr>
+          </a:lnRef>
+          <a:fillRef idx="1">
+            <a:schemeClr val="accent1"/>
+          </a:fillRef>
+          <a:effectRef idx="0">
+            <a:schemeClr val="accent1"/>
+          </a:effectRef>
+          <a:fontRef idx="minor">
+            <a:schemeClr val="lt1"/>
+          </a:fontRef>
+        </p:style>
+        <p:txBody>
+          <a:bodyPr rtlCol="0" anchor="ctr"/>
+          <a:lstStyle/>
+          <a:p>
+            <a:pPr algn="ctr"/>
+            <a:endParaRPr lang="en-DE">
+              <a:latin typeface="Arial" panose="020B0604020202020204" pitchFamily="34" charset="0"/>
+              <a:cs typeface="Arial" panose="020B0604020202020204" pitchFamily="34" charset="0"/>
+            </a:endParaRPr>
+          </a:p>
+        </p:txBody>
+      </p:sp>
+      <p:sp>
+        <p:nvSpPr>
+          <p:cNvPr id="3" name="角丸四角形 7">
+            <a:extLst>
+              <a:ext uri="{FF2B5EF4-FFF2-40B4-BE49-F238E27FC236}">
+                <a16:creationId xmlns:a16="http://schemas.microsoft.com/office/drawing/2014/main" id="{57BCF680-F5F7-7238-5EDB-E56AF1DFA5A8}"/>
+              </a:ext>
+            </a:extLst>
+          </p:cNvPr>
+          <p:cNvSpPr>
+            <a:spLocks/>
+          </p:cNvSpPr>
+          <p:nvPr/>
+        </p:nvSpPr>
+        <p:spPr>
+          <a:xfrm>
+            <a:off x="9196335" y="4050495"/>
+            <a:ext cx="1238946" cy="991024"/>
+          </a:xfrm>
+          <a:prstGeom prst="roundRect">
+            <a:avLst>
+              <a:gd name="adj" fmla="val 0"/>
+            </a:avLst>
+          </a:prstGeom>
+          <a:solidFill>
+            <a:schemeClr val="accent1">
+              <a:lumMod val="75000"/>
+            </a:schemeClr>
+          </a:solidFill>
+          <a:ln>
+            <a:noFill/>
+          </a:ln>
+        </p:spPr>
+        <p:style>
+          <a:lnRef idx="0">
+            <a:scrgbClr r="0" g="0" b="0"/>
+          </a:lnRef>
+          <a:fillRef idx="0">
+            <a:scrgbClr r="0" g="0" b="0"/>
+          </a:fillRef>
+          <a:effectRef idx="0">
+            <a:scrgbClr r="0" g="0" b="0"/>
+          </a:effectRef>
+          <a:fontRef idx="minor">
+            <a:schemeClr val="lt1"/>
+          </a:fontRef>
+        </p:style>
+        <p:txBody>
+          <a:bodyPr rtlCol="0" anchor="ctr" anchorCtr="1"/>
+          <a:lstStyle/>
+          <a:p>
+            <a:pPr marL="0" marR="0" lvl="0" indent="0" algn="ctr" defTabSz="1218804" rtl="0" eaLnBrk="0" fontAlgn="base" latinLnBrk="0" hangingPunct="0">
+              <a:lnSpc>
+                <a:spcPct val="100000"/>
+              </a:lnSpc>
+              <a:spcBef>
+                <a:spcPct val="0"/>
+              </a:spcBef>
+              <a:spcAft>
+                <a:spcPct val="0"/>
+              </a:spcAft>
+              <a:buClrTx/>
+              <a:buSzTx/>
+              <a:buFontTx/>
+              <a:buNone/>
+              <a:tabLst/>
+              <a:defRPr/>
+            </a:pPr>
+            <a:r>
+              <a:rPr kumimoji="1" lang="sv-SE" altLang="ja-JP" sz="1600" b="0" i="0" u="none" strike="noStrike" kern="1200" cap="none" spc="0" normalizeH="0" baseline="0" noProof="0" dirty="0">
+                <a:ln>
+                  <a:noFill/>
+                </a:ln>
+                <a:solidFill>
+                  <a:prstClr val="white"/>
+                </a:solidFill>
+                <a:effectLst/>
+                <a:uLnTx/>
+                <a:uFillTx/>
+                <a:latin typeface="Arial" panose="020B0604020202020204" pitchFamily="34" charset="0"/>
+                <a:ea typeface="Lato Light" panose="020F0502020204030203" pitchFamily="34" charset="0"/>
+                <a:cs typeface="Arial" panose="020B0604020202020204" pitchFamily="34" charset="0"/>
+              </a:rPr>
+              <a:t>Ethos-U</a:t>
+            </a:r>
+            <a:br>
+              <a:rPr kumimoji="1" lang="sv-SE" altLang="ja-JP" sz="1600" b="0" i="0" u="none" strike="noStrike" kern="1200" cap="none" spc="0" normalizeH="0" baseline="0" noProof="0" dirty="0">
+                <a:ln>
+                  <a:noFill/>
+                </a:ln>
+                <a:solidFill>
+                  <a:prstClr val="white"/>
+                </a:solidFill>
+                <a:effectLst/>
+                <a:uLnTx/>
+                <a:uFillTx/>
+                <a:latin typeface="Arial" panose="020B0604020202020204" pitchFamily="34" charset="0"/>
+                <a:ea typeface="Lato Light" panose="020F0502020204030203" pitchFamily="34" charset="0"/>
+                <a:cs typeface="Arial" panose="020B0604020202020204" pitchFamily="34" charset="0"/>
+              </a:rPr>
+            </a:br>
+            <a:r>
+              <a:rPr kumimoji="1" lang="sv-SE" altLang="ja-JP" sz="1600" b="0" i="0" u="none" strike="noStrike" kern="1200" cap="none" spc="0" normalizeH="0" baseline="0" noProof="0" dirty="0">
+                <a:ln>
+                  <a:noFill/>
+                </a:ln>
+                <a:solidFill>
+                  <a:prstClr val="white"/>
+                </a:solidFill>
+                <a:effectLst/>
+                <a:uLnTx/>
+                <a:uFillTx/>
+                <a:latin typeface="Arial" panose="020B0604020202020204" pitchFamily="34" charset="0"/>
+                <a:ea typeface="Lato Light" panose="020F0502020204030203" pitchFamily="34" charset="0"/>
+                <a:cs typeface="Arial" panose="020B0604020202020204" pitchFamily="34" charset="0"/>
+              </a:rPr>
+              <a:t>NPU</a:t>
+            </a:r>
+            <a:endParaRPr kumimoji="0" lang="en-US" altLang="ja-JP" sz="1600" b="0" i="0" u="none" strike="noStrike" kern="1200" cap="none" spc="0" normalizeH="0" baseline="0" noProof="0" dirty="0">
+              <a:ln>
+                <a:noFill/>
+              </a:ln>
+              <a:solidFill>
+                <a:prstClr val="white"/>
+              </a:solidFill>
+              <a:effectLst/>
+              <a:uLnTx/>
+              <a:uFillTx/>
+              <a:latin typeface="Arial" panose="020B0604020202020204" pitchFamily="34" charset="0"/>
+              <a:ea typeface="Lato Light" panose="020F0502020204030203" pitchFamily="34" charset="0"/>
+              <a:cs typeface="Arial" panose="020B0604020202020204" pitchFamily="34" charset="0"/>
+            </a:endParaRPr>
+          </a:p>
+        </p:txBody>
+      </p:sp>
+      <p:sp>
+        <p:nvSpPr>
+          <p:cNvPr id="5" name="Right Arrow 4">
+            <a:extLst>
+              <a:ext uri="{FF2B5EF4-FFF2-40B4-BE49-F238E27FC236}">
+                <a16:creationId xmlns:a16="http://schemas.microsoft.com/office/drawing/2014/main" id="{E79C218D-32B5-55A0-FFEE-D0A945A2B352}"/>
+              </a:ext>
+            </a:extLst>
+          </p:cNvPr>
+          <p:cNvSpPr>
+            <a:spLocks/>
+          </p:cNvSpPr>
+          <p:nvPr/>
+        </p:nvSpPr>
+        <p:spPr>
+          <a:xfrm>
+            <a:off x="8752527" y="4280854"/>
+            <a:ext cx="443808" cy="535780"/>
+          </a:xfrm>
+          <a:prstGeom prst="rightArrow">
+            <a:avLst/>
+          </a:prstGeom>
+          <a:solidFill>
+            <a:schemeClr val="bg1"/>
+          </a:solidFill>
+          <a:ln>
+            <a:solidFill>
+              <a:schemeClr val="tx2">
+                <a:lumMod val="40000"/>
+                <a:lumOff val="60000"/>
+              </a:schemeClr>
+            </a:solidFill>
+          </a:ln>
+        </p:spPr>
+        <p:style>
+          <a:lnRef idx="2">
+            <a:schemeClr val="accent1">
+              <a:shade val="50000"/>
+            </a:schemeClr>
+          </a:lnRef>
+          <a:fillRef idx="1">
+            <a:schemeClr val="accent1"/>
+          </a:fillRef>
+          <a:effectRef idx="0">
+            <a:schemeClr val="accent1"/>
+          </a:effectRef>
+          <a:fontRef idx="minor">
+            <a:schemeClr val="lt1"/>
+          </a:fontRef>
+        </p:style>
+        <p:txBody>
+          <a:bodyPr rtlCol="0" anchor="ctr"/>
+          <a:lstStyle/>
+          <a:p>
+            <a:pPr algn="ctr"/>
+            <a:endParaRPr lang="en-DE">
+              <a:latin typeface="Arial" panose="020B0604020202020204" pitchFamily="34" charset="0"/>
+              <a:cs typeface="Arial" panose="020B0604020202020204" pitchFamily="34" charset="0"/>
+            </a:endParaRPr>
+          </a:p>
+        </p:txBody>
+      </p:sp>
+      <p:sp>
+        <p:nvSpPr>
+          <p:cNvPr id="6" name="Right Arrow 5">
+            <a:extLst>
+              <a:ext uri="{FF2B5EF4-FFF2-40B4-BE49-F238E27FC236}">
+                <a16:creationId xmlns:a16="http://schemas.microsoft.com/office/drawing/2014/main" id="{C11D9685-00CB-8327-9BB0-5AA82FB2CD9D}"/>
+              </a:ext>
+            </a:extLst>
+          </p:cNvPr>
+          <p:cNvSpPr>
+            <a:spLocks/>
+          </p:cNvSpPr>
+          <p:nvPr/>
+        </p:nvSpPr>
+        <p:spPr>
+          <a:xfrm>
+            <a:off x="7046273" y="2836040"/>
+            <a:ext cx="450320" cy="535780"/>
+          </a:xfrm>
+          <a:prstGeom prst="rightArrow">
+            <a:avLst/>
+          </a:prstGeom>
+          <a:solidFill>
+            <a:schemeClr val="bg1"/>
+          </a:solidFill>
+          <a:ln>
+            <a:solidFill>
+              <a:schemeClr val="tx2">
+                <a:lumMod val="40000"/>
+                <a:lumOff val="60000"/>
+              </a:schemeClr>
+            </a:solidFill>
+          </a:ln>
+        </p:spPr>
+        <p:style>
+          <a:lnRef idx="2">
+            <a:schemeClr val="accent1">
+              <a:shade val="50000"/>
+            </a:schemeClr>
+          </a:lnRef>
+          <a:fillRef idx="1">
+            <a:schemeClr val="accent1"/>
+          </a:fillRef>
+          <a:effectRef idx="0">
+            <a:schemeClr val="accent1"/>
+          </a:effectRef>
+          <a:fontRef idx="minor">
+            <a:schemeClr val="lt1"/>
+          </a:fontRef>
+        </p:style>
+        <p:txBody>
+          <a:bodyPr rtlCol="0" anchor="ctr"/>
+          <a:lstStyle/>
+          <a:p>
+            <a:pPr algn="ctr"/>
+            <a:endParaRPr lang="en-DE">
+              <a:latin typeface="Arial" panose="020B0604020202020204" pitchFamily="34" charset="0"/>
+              <a:cs typeface="Arial" panose="020B0604020202020204" pitchFamily="34" charset="0"/>
+            </a:endParaRPr>
+          </a:p>
+        </p:txBody>
+      </p:sp>
+      <p:sp>
+        <p:nvSpPr>
+          <p:cNvPr id="7" name="Right Arrow 6">
+            <a:extLst>
+              <a:ext uri="{FF2B5EF4-FFF2-40B4-BE49-F238E27FC236}">
+                <a16:creationId xmlns:a16="http://schemas.microsoft.com/office/drawing/2014/main" id="{39B6F44B-4D74-73EA-34D9-FC17C4F50EFA}"/>
+              </a:ext>
+            </a:extLst>
+          </p:cNvPr>
+          <p:cNvSpPr>
+            <a:spLocks/>
+          </p:cNvSpPr>
+          <p:nvPr/>
+        </p:nvSpPr>
+        <p:spPr>
+          <a:xfrm>
+            <a:off x="7046273" y="4280855"/>
+            <a:ext cx="450320" cy="535780"/>
+          </a:xfrm>
+          <a:prstGeom prst="rightArrow">
+            <a:avLst/>
+          </a:prstGeom>
+          <a:solidFill>
+            <a:schemeClr val="bg1"/>
+          </a:solidFill>
+          <a:ln>
+            <a:solidFill>
+              <a:schemeClr val="tx2">
+                <a:lumMod val="40000"/>
+                <a:lumOff val="60000"/>
+              </a:schemeClr>
+            </a:solidFill>
+          </a:ln>
+        </p:spPr>
+        <p:style>
+          <a:lnRef idx="2">
+            <a:schemeClr val="accent1">
+              <a:shade val="50000"/>
+            </a:schemeClr>
+          </a:lnRef>
+          <a:fillRef idx="1">
+            <a:schemeClr val="accent1"/>
+          </a:fillRef>
+          <a:effectRef idx="0">
+            <a:schemeClr val="accent1"/>
+          </a:effectRef>
+          <a:fontRef idx="minor">
+            <a:schemeClr val="lt1"/>
+          </a:fontRef>
+        </p:style>
+        <p:txBody>
+          <a:bodyPr rtlCol="0" anchor="ctr"/>
+          <a:lstStyle/>
+          <a:p>
+            <a:pPr algn="ctr"/>
+            <a:endParaRPr lang="en-DE">
+              <a:latin typeface="Arial" panose="020B0604020202020204" pitchFamily="34" charset="0"/>
+              <a:cs typeface="Arial" panose="020B0604020202020204" pitchFamily="34" charset="0"/>
+            </a:endParaRPr>
+          </a:p>
+        </p:txBody>
+      </p:sp>
+      <p:sp>
+        <p:nvSpPr>
+          <p:cNvPr id="13" name="角丸四角形 6">
+            <a:extLst>
+              <a:ext uri="{FF2B5EF4-FFF2-40B4-BE49-F238E27FC236}">
+                <a16:creationId xmlns:a16="http://schemas.microsoft.com/office/drawing/2014/main" id="{A60B54B0-3725-80A8-C9F3-40CB43AA62DE}"/>
+              </a:ext>
+            </a:extLst>
+          </p:cNvPr>
+          <p:cNvSpPr>
+            <a:spLocks/>
+          </p:cNvSpPr>
+          <p:nvPr/>
+        </p:nvSpPr>
+        <p:spPr>
+          <a:xfrm rot="16200000">
+            <a:off x="5536241" y="3538943"/>
+            <a:ext cx="2465152" cy="540000"/>
+          </a:xfrm>
+          <a:prstGeom prst="roundRect">
+            <a:avLst>
+              <a:gd name="adj" fmla="val 0"/>
+            </a:avLst>
+          </a:prstGeom>
+          <a:solidFill>
+            <a:schemeClr val="accent4"/>
+          </a:solidFill>
+          <a:ln w="15875">
+            <a:solidFill>
+              <a:schemeClr val="accent4"/>
+            </a:solidFill>
+          </a:ln>
+        </p:spPr>
+        <p:style>
+          <a:lnRef idx="2">
+            <a:schemeClr val="accent4"/>
+          </a:lnRef>
+          <a:fillRef idx="1">
+            <a:schemeClr val="lt1"/>
+          </a:fillRef>
+          <a:effectRef idx="0">
+            <a:schemeClr val="accent4"/>
+          </a:effectRef>
+          <a:fontRef idx="minor">
+            <a:schemeClr val="dk1"/>
+          </a:fontRef>
+        </p:style>
+        <p:txBody>
+          <a:bodyPr rtlCol="0" anchor="ctr" anchorCtr="1"/>
+          <a:lstStyle/>
+          <a:p>
+            <a:pPr marL="0" marR="0" lvl="0" indent="0" algn="ctr" defTabSz="1218804" rtl="0" eaLnBrk="0" fontAlgn="base" latinLnBrk="0" hangingPunct="0">
+              <a:lnSpc>
+                <a:spcPct val="100000"/>
+              </a:lnSpc>
+              <a:spcBef>
+                <a:spcPct val="0"/>
+              </a:spcBef>
+              <a:spcAft>
+                <a:spcPct val="0"/>
+              </a:spcAft>
+              <a:buClrTx/>
+              <a:buSzTx/>
+              <a:buFontTx/>
+              <a:buNone/>
+              <a:tabLst/>
+              <a:defRPr/>
+            </a:pPr>
+            <a:r>
+              <a:rPr kumimoji="1" lang="sv-SE" altLang="ja-JP" sz="1600">
+                <a:solidFill>
+                  <a:sysClr val="windowText" lastClr="000000"/>
+                </a:solidFill>
+                <a:latin typeface="Arial" panose="020B0604020202020204" pitchFamily="34" charset="0"/>
+                <a:ea typeface="Lato Light" panose="020F0502020204030203" pitchFamily="34" charset="0"/>
+                <a:cs typeface="Arial" panose="020B0604020202020204" pitchFamily="34" charset="0"/>
+              </a:rPr>
+              <a:t>ML </a:t>
+            </a:r>
+            <a:r>
+              <a:rPr kumimoji="1" lang="sv-SE" altLang="ja-JP" sz="1600" err="1">
+                <a:solidFill>
+                  <a:sysClr val="windowText" lastClr="000000"/>
+                </a:solidFill>
+                <a:latin typeface="Arial" panose="020B0604020202020204" pitchFamily="34" charset="0"/>
+                <a:ea typeface="Lato Light" panose="020F0502020204030203" pitchFamily="34" charset="0"/>
+                <a:cs typeface="Arial" panose="020B0604020202020204" pitchFamily="34" charset="0"/>
+              </a:rPr>
+              <a:t>Runtime</a:t>
+            </a:r>
+            <a:endParaRPr kumimoji="1" lang="ja-JP" altLang="en-US" sz="1600" b="0" i="0" u="none" strike="noStrike" kern="1200" cap="none" spc="0" normalizeH="0" baseline="0" noProof="0">
+              <a:ln>
+                <a:noFill/>
+              </a:ln>
+              <a:solidFill>
+                <a:sysClr val="windowText" lastClr="000000"/>
+              </a:solidFill>
+              <a:effectLst/>
+              <a:uLnTx/>
+              <a:uFillTx/>
+              <a:latin typeface="Arial" panose="020B0604020202020204" pitchFamily="34" charset="0"/>
+              <a:ea typeface="游ゴシック" panose="020B0400000000000000" pitchFamily="34" charset="-128"/>
+              <a:cs typeface="Arial" panose="020B0604020202020204" pitchFamily="34" charset="0"/>
+            </a:endParaRPr>
+          </a:p>
+        </p:txBody>
+      </p:sp>
+      <p:sp>
+        <p:nvSpPr>
+          <p:cNvPr id="10" name="Right Arrow 9">
+            <a:extLst>
+              <a:ext uri="{FF2B5EF4-FFF2-40B4-BE49-F238E27FC236}">
+                <a16:creationId xmlns:a16="http://schemas.microsoft.com/office/drawing/2014/main" id="{7BC23331-C66C-40E8-E23E-80B78E80BFFC}"/>
+              </a:ext>
+            </a:extLst>
+          </p:cNvPr>
+          <p:cNvSpPr>
+            <a:spLocks/>
+          </p:cNvSpPr>
+          <p:nvPr/>
+        </p:nvSpPr>
+        <p:spPr>
+          <a:xfrm>
+            <a:off x="6087419" y="3573392"/>
+            <a:ext cx="411398" cy="535780"/>
+          </a:xfrm>
+          <a:prstGeom prst="rightArrow">
+            <a:avLst/>
+          </a:prstGeom>
+          <a:solidFill>
+            <a:schemeClr val="bg1"/>
+          </a:solidFill>
+          <a:ln>
+            <a:solidFill>
+              <a:schemeClr val="tx2">
+                <a:lumMod val="40000"/>
+                <a:lumOff val="60000"/>
+              </a:schemeClr>
+            </a:solidFill>
+          </a:ln>
+        </p:spPr>
+        <p:style>
+          <a:lnRef idx="2">
+            <a:schemeClr val="accent1">
+              <a:shade val="50000"/>
+            </a:schemeClr>
+          </a:lnRef>
+          <a:fillRef idx="1">
+            <a:schemeClr val="accent1"/>
+          </a:fillRef>
+          <a:effectRef idx="0">
+            <a:schemeClr val="accent1"/>
+          </a:effectRef>
+          <a:fontRef idx="minor">
+            <a:schemeClr val="lt1"/>
+          </a:fontRef>
+        </p:style>
+        <p:txBody>
+          <a:bodyPr rtlCol="0" anchor="ctr"/>
+          <a:lstStyle/>
+          <a:p>
+            <a:pPr algn="ctr"/>
+            <a:endParaRPr lang="en-DE">
+              <a:latin typeface="Arial" panose="020B0604020202020204" pitchFamily="34" charset="0"/>
+              <a:cs typeface="Arial" panose="020B0604020202020204" pitchFamily="34" charset="0"/>
+            </a:endParaRPr>
+          </a:p>
+        </p:txBody>
+      </p:sp>
+      <p:sp>
+        <p:nvSpPr>
+          <p:cNvPr id="21" name="角丸四角形 6">
+            <a:extLst>
+              <a:ext uri="{FF2B5EF4-FFF2-40B4-BE49-F238E27FC236}">
+                <a16:creationId xmlns:a16="http://schemas.microsoft.com/office/drawing/2014/main" id="{FB2A90DC-6C77-EC71-6DB5-BD3632869C43}"/>
+              </a:ext>
+            </a:extLst>
+          </p:cNvPr>
+          <p:cNvSpPr>
+            <a:spLocks/>
+          </p:cNvSpPr>
+          <p:nvPr/>
+        </p:nvSpPr>
+        <p:spPr>
+          <a:xfrm>
+            <a:off x="4927348" y="3320008"/>
+            <a:ext cx="1155305" cy="977868"/>
+          </a:xfrm>
+          <a:prstGeom prst="roundRect">
+            <a:avLst>
+              <a:gd name="adj" fmla="val 0"/>
+            </a:avLst>
+          </a:prstGeom>
+          <a:solidFill>
+            <a:schemeClr val="accent1"/>
+          </a:solidFill>
+          <a:ln w="15875">
+            <a:noFill/>
+          </a:ln>
+        </p:spPr>
+        <p:style>
+          <a:lnRef idx="2">
+            <a:schemeClr val="accent4"/>
+          </a:lnRef>
+          <a:fillRef idx="1">
+            <a:schemeClr val="lt1"/>
+          </a:fillRef>
+          <a:effectRef idx="0">
+            <a:schemeClr val="accent4"/>
+          </a:effectRef>
+          <a:fontRef idx="minor">
+            <a:schemeClr val="dk1"/>
+          </a:fontRef>
+        </p:style>
+        <p:txBody>
+          <a:bodyPr lIns="0" tIns="60960" rIns="0" bIns="60960" rtlCol="0" anchor="ctr" anchorCtr="1"/>
+          <a:lstStyle/>
+          <a:p>
+            <a:pPr marL="0" marR="0" lvl="0" indent="0" algn="ctr" defTabSz="1218804" rtl="0" eaLnBrk="0" fontAlgn="base" latinLnBrk="0" hangingPunct="0">
+              <a:lnSpc>
+                <a:spcPct val="100000"/>
+              </a:lnSpc>
+              <a:spcBef>
+                <a:spcPct val="0"/>
+              </a:spcBef>
+              <a:spcAft>
+                <a:spcPct val="0"/>
+              </a:spcAft>
+              <a:buClrTx/>
+              <a:buSzTx/>
+              <a:buFontTx/>
+              <a:buNone/>
+              <a:tabLst/>
+              <a:defRPr/>
+            </a:pPr>
+            <a:r>
+              <a:rPr kumimoji="1" lang="sv-SE" altLang="ja-JP" sz="1600" dirty="0">
+                <a:solidFill>
+                  <a:srgbClr val="FFFFFF"/>
+                </a:solidFill>
+                <a:latin typeface="Arial" panose="020B0604020202020204" pitchFamily="34" charset="0"/>
+                <a:ea typeface="Lato Light"/>
+                <a:cs typeface="Arial" panose="020B0604020202020204" pitchFamily="34" charset="0"/>
+              </a:rPr>
+              <a:t>Optimized</a:t>
+            </a:r>
+            <a:br>
+              <a:rPr kumimoji="1" lang="sv-SE" altLang="ja-JP" sz="1600" b="0" i="0" u="none" strike="noStrike" kern="1200" cap="none" spc="0" normalizeH="0" baseline="0" noProof="0" dirty="0">
+                <a:ln>
+                  <a:noFill/>
+                </a:ln>
+                <a:solidFill>
+                  <a:srgbClr val="FFFFFF"/>
+                </a:solidFill>
+                <a:effectLst/>
+                <a:uLnTx/>
+                <a:uFillTx/>
+                <a:latin typeface="Arial" panose="020B0604020202020204" pitchFamily="34" charset="0"/>
+                <a:ea typeface="Lato Light"/>
+                <a:cs typeface="Arial" panose="020B0604020202020204" pitchFamily="34" charset="0"/>
+              </a:rPr>
+            </a:br>
+            <a:r>
+              <a:rPr kumimoji="1" lang="sv-SE" altLang="ja-JP" sz="1600" b="0" i="0" u="none" strike="noStrike" kern="1200" cap="none" spc="0" normalizeH="0" baseline="0" noProof="0" dirty="0">
+                <a:ln>
+                  <a:noFill/>
+                </a:ln>
+                <a:solidFill>
+                  <a:srgbClr val="FFFFFF"/>
+                </a:solidFill>
+                <a:effectLst/>
+                <a:uLnTx/>
+                <a:uFillTx/>
+                <a:latin typeface="Arial" panose="020B0604020202020204" pitchFamily="34" charset="0"/>
+                <a:ea typeface="Lato Light"/>
+                <a:cs typeface="Arial" panose="020B0604020202020204" pitchFamily="34" charset="0"/>
+              </a:rPr>
+              <a:t>ML Model</a:t>
+            </a:r>
+            <a:endParaRPr kumimoji="0" lang="sv-SE" altLang="ja-JP" sz="1600" b="0" i="0" u="none" strike="noStrike" kern="1200" cap="none" spc="0" normalizeH="0" baseline="0" noProof="0" dirty="0">
+              <a:ln>
+                <a:noFill/>
+              </a:ln>
+              <a:solidFill>
+                <a:srgbClr val="FFFFFF"/>
+              </a:solidFill>
+              <a:effectLst/>
+              <a:uLnTx/>
+              <a:uFillTx/>
+              <a:latin typeface="Arial" panose="020B0604020202020204" pitchFamily="34" charset="0"/>
+              <a:ea typeface="Lato Light"/>
+              <a:cs typeface="Arial" panose="020B0604020202020204" pitchFamily="34" charset="0"/>
+            </a:endParaRPr>
+          </a:p>
+        </p:txBody>
+      </p:sp>
+      <p:sp>
+        <p:nvSpPr>
+          <p:cNvPr id="22" name="Right Arrow 9">
+            <a:extLst>
+              <a:ext uri="{FF2B5EF4-FFF2-40B4-BE49-F238E27FC236}">
+                <a16:creationId xmlns:a16="http://schemas.microsoft.com/office/drawing/2014/main" id="{CE681839-96C8-ECC2-5DC3-5CE8B441E008}"/>
+              </a:ext>
+            </a:extLst>
+          </p:cNvPr>
+          <p:cNvSpPr>
+            <a:spLocks/>
+          </p:cNvSpPr>
+          <p:nvPr/>
+        </p:nvSpPr>
+        <p:spPr>
+          <a:xfrm>
+            <a:off x="4491963" y="3541052"/>
+            <a:ext cx="435385" cy="535780"/>
+          </a:xfrm>
+          <a:prstGeom prst="rightArrow">
+            <a:avLst/>
+          </a:prstGeom>
+          <a:solidFill>
+            <a:schemeClr val="bg1"/>
+          </a:solidFill>
+          <a:ln>
+            <a:solidFill>
+              <a:schemeClr val="tx2">
+                <a:lumMod val="40000"/>
+                <a:lumOff val="60000"/>
+              </a:schemeClr>
+            </a:solidFill>
+          </a:ln>
+        </p:spPr>
+        <p:style>
+          <a:lnRef idx="2">
+            <a:schemeClr val="accent1">
+              <a:shade val="50000"/>
+            </a:schemeClr>
+          </a:lnRef>
+          <a:fillRef idx="1">
+            <a:schemeClr val="accent1"/>
+          </a:fillRef>
+          <a:effectRef idx="0">
+            <a:schemeClr val="accent1"/>
+          </a:effectRef>
+          <a:fontRef idx="minor">
+            <a:schemeClr val="lt1"/>
+          </a:fontRef>
+        </p:style>
+        <p:txBody>
+          <a:bodyPr rtlCol="0" anchor="ctr"/>
+          <a:lstStyle/>
+          <a:p>
+            <a:pPr algn="ctr"/>
+            <a:endParaRPr lang="en-DE">
+              <a:latin typeface="Arial" panose="020B0604020202020204" pitchFamily="34" charset="0"/>
+              <a:cs typeface="Arial" panose="020B0604020202020204" pitchFamily="34" charset="0"/>
+            </a:endParaRPr>
+          </a:p>
+        </p:txBody>
+      </p:sp>
+      <p:cxnSp>
+        <p:nvCxnSpPr>
+          <p:cNvPr id="25" name="Straight Arrow Connector 24">
+            <a:extLst>
+              <a:ext uri="{FF2B5EF4-FFF2-40B4-BE49-F238E27FC236}">
+                <a16:creationId xmlns:a16="http://schemas.microsoft.com/office/drawing/2014/main" id="{895D14C4-1C67-E8C5-CC30-2A24D101B209}"/>
+              </a:ext>
+            </a:extLst>
+          </p:cNvPr>
+          <p:cNvCxnSpPr>
+            <a:cxnSpLocks/>
+          </p:cNvCxnSpPr>
+          <p:nvPr/>
+        </p:nvCxnSpPr>
+        <p:spPr>
+          <a:xfrm>
+            <a:off x="2652601" y="3078074"/>
+            <a:ext cx="571872" cy="495318"/>
+          </a:xfrm>
+          <a:prstGeom prst="straightConnector1">
+            <a:avLst/>
+          </a:prstGeom>
+          <a:ln w="53975">
+            <a:solidFill>
+              <a:schemeClr val="bg1"/>
+            </a:solidFill>
+            <a:tailEnd type="triangle"/>
+          </a:ln>
+        </p:spPr>
+        <p:style>
+          <a:lnRef idx="1">
+            <a:schemeClr val="accent1"/>
+          </a:lnRef>
+          <a:fillRef idx="0">
+            <a:schemeClr val="accent1"/>
+          </a:fillRef>
+          <a:effectRef idx="0">
+            <a:schemeClr val="accent1"/>
+          </a:effectRef>
+          <a:fontRef idx="minor">
+            <a:schemeClr val="tx1"/>
+          </a:fontRef>
+        </p:style>
+      </p:cxnSp>
+      <p:cxnSp>
+        <p:nvCxnSpPr>
+          <p:cNvPr id="27" name="Straight Arrow Connector 26">
+            <a:extLst>
+              <a:ext uri="{FF2B5EF4-FFF2-40B4-BE49-F238E27FC236}">
+                <a16:creationId xmlns:a16="http://schemas.microsoft.com/office/drawing/2014/main" id="{0BB29EEB-C831-0FCF-B2A9-F37C9067320D}"/>
+              </a:ext>
+            </a:extLst>
+          </p:cNvPr>
+          <p:cNvCxnSpPr>
+            <a:cxnSpLocks/>
+          </p:cNvCxnSpPr>
+          <p:nvPr/>
+        </p:nvCxnSpPr>
+        <p:spPr>
+          <a:xfrm flipV="1">
+            <a:off x="2845826" y="3949959"/>
+            <a:ext cx="386277" cy="412710"/>
+          </a:xfrm>
+          <a:prstGeom prst="straightConnector1">
+            <a:avLst/>
+          </a:prstGeom>
+          <a:ln w="53975">
+            <a:solidFill>
+              <a:schemeClr val="bg1"/>
+            </a:solidFill>
+            <a:tailEnd type="triangle"/>
+          </a:ln>
+        </p:spPr>
+        <p:style>
+          <a:lnRef idx="1">
+            <a:schemeClr val="accent1"/>
+          </a:lnRef>
+          <a:fillRef idx="0">
+            <a:schemeClr val="accent1"/>
+          </a:fillRef>
+          <a:effectRef idx="0">
+            <a:schemeClr val="accent1"/>
+          </a:effectRef>
+          <a:fontRef idx="minor">
+            <a:schemeClr val="tx1"/>
+          </a:fontRef>
+        </p:style>
+      </p:cxnSp>
+      <p:sp>
+        <p:nvSpPr>
+          <p:cNvPr id="9" name="角丸四角形 6">
+            <a:extLst>
+              <a:ext uri="{FF2B5EF4-FFF2-40B4-BE49-F238E27FC236}">
+                <a16:creationId xmlns:a16="http://schemas.microsoft.com/office/drawing/2014/main" id="{82936832-DE0D-BA67-8E68-B672BE7EFE4C}"/>
+              </a:ext>
+            </a:extLst>
+          </p:cNvPr>
+          <p:cNvSpPr>
+            <a:spLocks/>
+          </p:cNvSpPr>
+          <p:nvPr/>
+        </p:nvSpPr>
+        <p:spPr>
+          <a:xfrm>
+            <a:off x="1690521" y="2675403"/>
+            <a:ext cx="1155305" cy="977868"/>
+          </a:xfrm>
+          <a:prstGeom prst="roundRect">
+            <a:avLst>
+              <a:gd name="adj" fmla="val 0"/>
+            </a:avLst>
+          </a:prstGeom>
+          <a:solidFill>
+            <a:schemeClr val="accent1"/>
+          </a:solidFill>
+          <a:ln w="15875">
+            <a:noFill/>
+          </a:ln>
+        </p:spPr>
+        <p:style>
+          <a:lnRef idx="2">
+            <a:schemeClr val="accent4"/>
+          </a:lnRef>
+          <a:fillRef idx="1">
+            <a:schemeClr val="lt1"/>
+          </a:fillRef>
+          <a:effectRef idx="0">
+            <a:schemeClr val="accent4"/>
+          </a:effectRef>
+          <a:fontRef idx="minor">
+            <a:schemeClr val="dk1"/>
+          </a:fontRef>
+        </p:style>
+        <p:txBody>
+          <a:bodyPr lIns="0" tIns="60960" rIns="0" bIns="60960" rtlCol="0" anchor="ctr" anchorCtr="1"/>
+          <a:lstStyle/>
+          <a:p>
+            <a:pPr marL="0" marR="0" lvl="0" indent="0" algn="ctr" defTabSz="1218804" rtl="0" eaLnBrk="0" fontAlgn="base" latinLnBrk="0" hangingPunct="0">
+              <a:lnSpc>
+                <a:spcPct val="100000"/>
+              </a:lnSpc>
+              <a:spcBef>
+                <a:spcPct val="0"/>
+              </a:spcBef>
+              <a:spcAft>
+                <a:spcPct val="0"/>
+              </a:spcAft>
+              <a:buClrTx/>
+              <a:buSzTx/>
+              <a:buFontTx/>
+              <a:buNone/>
+              <a:tabLst/>
+              <a:defRPr/>
+            </a:pPr>
+            <a:r>
+              <a:rPr kumimoji="1" lang="sv-SE" altLang="ja-JP" sz="1600" b="0" i="0" u="none" strike="noStrike" kern="1200" cap="none" spc="0" normalizeH="0" baseline="0" noProof="0" dirty="0">
+                <a:ln>
+                  <a:noFill/>
+                </a:ln>
+                <a:solidFill>
+                  <a:srgbClr val="FFFFFF"/>
+                </a:solidFill>
+                <a:effectLst/>
+                <a:uLnTx/>
+                <a:uFillTx/>
+                <a:latin typeface="Arial" panose="020B0604020202020204" pitchFamily="34" charset="0"/>
+                <a:ea typeface="Lato Light"/>
+                <a:cs typeface="Arial" panose="020B0604020202020204" pitchFamily="34" charset="0"/>
+              </a:rPr>
+              <a:t>Quantized</a:t>
+            </a:r>
+            <a:br>
+              <a:rPr kumimoji="1" lang="sv-SE" altLang="ja-JP" sz="1600" b="0" i="0" u="none" strike="noStrike" kern="1200" cap="none" spc="0" normalizeH="0" baseline="0" noProof="0" dirty="0">
+                <a:ln>
+                  <a:noFill/>
+                </a:ln>
+                <a:solidFill>
+                  <a:srgbClr val="FFFFFF"/>
+                </a:solidFill>
+                <a:effectLst/>
+                <a:uLnTx/>
+                <a:uFillTx/>
+                <a:latin typeface="Arial" panose="020B0604020202020204" pitchFamily="34" charset="0"/>
+                <a:ea typeface="Lato Light"/>
+                <a:cs typeface="Arial" panose="020B0604020202020204" pitchFamily="34" charset="0"/>
+              </a:rPr>
+            </a:br>
+            <a:r>
+              <a:rPr kumimoji="1" lang="sv-SE" altLang="ja-JP" sz="1600" b="0" i="0" u="none" strike="noStrike" kern="1200" cap="none" spc="0" normalizeH="0" baseline="0" noProof="0" dirty="0">
+                <a:ln>
+                  <a:noFill/>
+                </a:ln>
+                <a:solidFill>
+                  <a:srgbClr val="FFFFFF"/>
+                </a:solidFill>
+                <a:effectLst/>
+                <a:uLnTx/>
+                <a:uFillTx/>
+                <a:latin typeface="Arial" panose="020B0604020202020204" pitchFamily="34" charset="0"/>
+                <a:ea typeface="Lato Light"/>
+                <a:cs typeface="Arial" panose="020B0604020202020204" pitchFamily="34" charset="0"/>
+              </a:rPr>
+              <a:t>ML Model</a:t>
+            </a:r>
+            <a:endParaRPr kumimoji="0" lang="sv-SE" altLang="ja-JP" sz="1600" b="0" i="0" u="none" strike="noStrike" kern="1200" cap="none" spc="0" normalizeH="0" baseline="0" noProof="0" dirty="0">
+              <a:ln>
+                <a:noFill/>
+              </a:ln>
+              <a:solidFill>
+                <a:srgbClr val="FFFFFF"/>
+              </a:solidFill>
+              <a:effectLst/>
+              <a:uLnTx/>
+              <a:uFillTx/>
+              <a:latin typeface="Arial" panose="020B0604020202020204" pitchFamily="34" charset="0"/>
+              <a:ea typeface="Lato Light"/>
+              <a:cs typeface="Arial" panose="020B0604020202020204" pitchFamily="34" charset="0"/>
+            </a:endParaRPr>
+          </a:p>
+        </p:txBody>
+      </p:sp>
+      <p:sp>
+        <p:nvSpPr>
+          <p:cNvPr id="23" name="角丸四角形 6">
+            <a:extLst>
+              <a:ext uri="{FF2B5EF4-FFF2-40B4-BE49-F238E27FC236}">
+                <a16:creationId xmlns:a16="http://schemas.microsoft.com/office/drawing/2014/main" id="{47935825-0EE0-9F16-CBB9-78D6714F99C6}"/>
+              </a:ext>
+            </a:extLst>
+          </p:cNvPr>
+          <p:cNvSpPr>
+            <a:spLocks/>
+          </p:cNvSpPr>
+          <p:nvPr/>
+        </p:nvSpPr>
+        <p:spPr>
+          <a:xfrm>
+            <a:off x="1575379" y="3844693"/>
+            <a:ext cx="1385590" cy="1242000"/>
+          </a:xfrm>
+          <a:prstGeom prst="roundRect">
+            <a:avLst>
+              <a:gd name="adj" fmla="val 0"/>
+            </a:avLst>
+          </a:prstGeom>
+          <a:solidFill>
+            <a:schemeClr val="tx2"/>
+          </a:solidFill>
+          <a:ln w="15875">
+            <a:solidFill>
+              <a:srgbClr val="00C1DE"/>
+            </a:solidFill>
+          </a:ln>
+        </p:spPr>
+        <p:style>
+          <a:lnRef idx="2">
+            <a:schemeClr val="accent1">
+              <a:shade val="50000"/>
+            </a:schemeClr>
+          </a:lnRef>
+          <a:fillRef idx="1">
+            <a:schemeClr val="accent1"/>
+          </a:fillRef>
+          <a:effectRef idx="0">
+            <a:schemeClr val="accent1"/>
+          </a:effectRef>
+          <a:fontRef idx="minor">
+            <a:schemeClr val="lt1"/>
+          </a:fontRef>
+        </p:style>
+        <p:txBody>
+          <a:bodyPr rtlCol="0" anchor="ctr"/>
+          <a:lstStyle/>
+          <a:p>
+            <a:pPr algn="ctr" defTabSz="1219170"/>
+            <a:r>
+              <a:rPr lang="en-US" sz="1600" dirty="0"/>
+              <a:t>Ethos-U target system &amp; memory description</a:t>
+            </a:r>
+            <a:endParaRPr kumimoji="1" lang="sv-SE" altLang="ja-JP" sz="1400" dirty="0">
+              <a:solidFill>
+                <a:srgbClr val="FFFFFF"/>
+              </a:solidFill>
+              <a:latin typeface="Arial" panose="020B0604020202020204" pitchFamily="34" charset="0"/>
+              <a:cs typeface="Arial" panose="020B0604020202020204" pitchFamily="34" charset="0"/>
+            </a:endParaRPr>
+          </a:p>
+        </p:txBody>
+      </p:sp>
+    </p:spTree>
+    <p:extLst>
+      <p:ext uri="{BB962C8B-B14F-4D97-AF65-F5344CB8AC3E}">
+        <p14:creationId xmlns:p14="http://schemas.microsoft.com/office/powerpoint/2010/main" val="3449616423"/>
+      </p:ext>
+    </p:extLst>
+  </p:cSld>
+  <p:clrMapOvr>
+    <a:masterClrMapping/>
+  </p:clrMapOvr>
+</p:sld>
+</file>
+
+<file path=ppt/slides/slide3.xml><?xml version="1.0" encoding="utf-8"?>
+<p:sld xmlns:a="http://schemas.openxmlformats.org/drawingml/2006/main" xmlns:r="http://schemas.openxmlformats.org/officeDocument/2006/relationships" xmlns:p="http://schemas.openxmlformats.org/presentationml/2006/main">
+  <p:cSld>
+    <p:spTree>
+      <p:nvGrpSpPr>
+        <p:cNvPr id="1" name=""/>
+        <p:cNvGrpSpPr/>
+        <p:nvPr/>
+      </p:nvGrpSpPr>
+      <p:grpSpPr>
+        <a:xfrm>
+          <a:off x="0" y="0"/>
+          <a:ext cx="0" cy="0"/>
+          <a:chOff x="0" y="0"/>
+          <a:chExt cx="0" cy="0"/>
+        </a:xfrm>
+      </p:grpSpPr>
+      <p:sp>
+        <p:nvSpPr>
+          <p:cNvPr id="2" name="Title 1">
+            <a:extLst>
+              <a:ext uri="{FF2B5EF4-FFF2-40B4-BE49-F238E27FC236}">
+                <a16:creationId xmlns:a16="http://schemas.microsoft.com/office/drawing/2014/main" id="{CEEF4016-9082-286D-629A-6EC1004915CD}"/>
+              </a:ext>
+            </a:extLst>
+          </p:cNvPr>
+          <p:cNvSpPr>
+            <a:spLocks noGrp="1"/>
+          </p:cNvSpPr>
+          <p:nvPr>
+            <p:ph type="title"/>
+          </p:nvPr>
+        </p:nvSpPr>
+        <p:spPr/>
+        <p:txBody>
+          <a:bodyPr/>
+          <a:lstStyle/>
+          <a:p>
+            <a:endParaRPr lang="en-US"/>
+          </a:p>
+        </p:txBody>
+      </p:sp>
+      <p:sp>
+        <p:nvSpPr>
+          <p:cNvPr id="3" name="Text Placeholder 2">
+            <a:extLst>
+              <a:ext uri="{FF2B5EF4-FFF2-40B4-BE49-F238E27FC236}">
+                <a16:creationId xmlns:a16="http://schemas.microsoft.com/office/drawing/2014/main" id="{DC07EB29-3B33-4E20-229D-ECA79F3BEA79}"/>
+              </a:ext>
+            </a:extLst>
+          </p:cNvPr>
+          <p:cNvSpPr>
+            <a:spLocks noGrp="1"/>
+          </p:cNvSpPr>
+          <p:nvPr>
+            <p:ph type="body" sz="quarter" idx="13"/>
+          </p:nvPr>
+        </p:nvSpPr>
+        <p:spPr/>
+        <p:txBody>
+          <a:bodyPr/>
+          <a:lstStyle/>
+          <a:p>
+            <a:endParaRPr lang="en-US"/>
+          </a:p>
+        </p:txBody>
+      </p:sp>
+      <p:sp>
+        <p:nvSpPr>
+          <p:cNvPr id="4" name="Content Placeholder 3">
+            <a:extLst>
+              <a:ext uri="{FF2B5EF4-FFF2-40B4-BE49-F238E27FC236}">
+                <a16:creationId xmlns:a16="http://schemas.microsoft.com/office/drawing/2014/main" id="{FC77706E-165A-E28E-6340-97057BBBCBB0}"/>
+              </a:ext>
+            </a:extLst>
+          </p:cNvPr>
+          <p:cNvSpPr>
+            <a:spLocks noGrp="1"/>
+          </p:cNvSpPr>
+          <p:nvPr>
+            <p:ph idx="1"/>
+          </p:nvPr>
+        </p:nvSpPr>
+        <p:spPr/>
+        <p:txBody>
+          <a:bodyPr/>
+          <a:lstStyle/>
+          <a:p>
+            <a:endParaRPr lang="en-US"/>
+          </a:p>
+        </p:txBody>
+      </p:sp>
+    </p:spTree>
+    <p:extLst>
+      <p:ext uri="{BB962C8B-B14F-4D97-AF65-F5344CB8AC3E}">
+        <p14:creationId xmlns:p14="http://schemas.microsoft.com/office/powerpoint/2010/main" val="405019737"/>
       </p:ext>
     </p:extLst>
   </p:cSld>

</xml_diff>

<commit_message>
Updated Doxygen version and documentation (#1)
* Updated Doxygen version and documentation

* links reverted

* each label in a separate line
</commit_message>
<xml_diff>
--- a/documentation/doxygen/general/src/images/overview.pptx
+++ b/documentation/doxygen/general/src/images/overview.pptx
@@ -5,13 +5,15 @@
     <p:sldMasterId id="2147483661" r:id="rId1"/>
   </p:sldMasterIdLst>
   <p:notesMasterIdLst>
-    <p:notesMasterId r:id="rId3"/>
+    <p:notesMasterId r:id="rId5"/>
   </p:notesMasterIdLst>
   <p:handoutMasterIdLst>
-    <p:handoutMasterId r:id="rId4"/>
+    <p:handoutMasterId r:id="rId6"/>
   </p:handoutMasterIdLst>
   <p:sldIdLst>
     <p:sldId id="548" r:id="rId2"/>
+    <p:sldId id="2147479562" r:id="rId3"/>
+    <p:sldId id="549" r:id="rId4"/>
   </p:sldIdLst>
   <p:sldSz cx="12192000" cy="6858000"/>
   <p:notesSz cx="6858000" cy="9144000"/>
@@ -259,7 +261,7 @@
           <a:p>
             <a:fld id="{008FFADC-39A7-449E-8C68-8776E6FB3C1A}" type="datetimeFigureOut">
               <a:rPr lang="en-GB" smtClean="0"/>
-              <a:t>10/06/2026</a:t>
+              <a:t>07/08/2026</a:t>
             </a:fld>
             <a:endParaRPr lang="en-GB"/>
           </a:p>
@@ -436,7 +438,7 @@
           <a:p>
             <a:fld id="{30B9BAAB-B703-4BB5-9D08-B460FC03C23A}" type="datetimeFigureOut">
               <a:rPr lang="en-GB" smtClean="0"/>
-              <a:t>10/06/2026</a:t>
+              <a:t>07/08/2026</a:t>
             </a:fld>
             <a:endParaRPr lang="en-GB"/>
           </a:p>
@@ -702,6 +704,123 @@
     </a:lvl9pPr>
   </p:notesStyle>
 </p:notesMaster>
+</file>
+
+<file path=ppt/notesSlides/notesSlide1.xml><?xml version="1.0" encoding="utf-8"?>
+<p:notes xmlns:a="http://schemas.openxmlformats.org/drawingml/2006/main" xmlns:r="http://schemas.openxmlformats.org/officeDocument/2006/relationships" xmlns:p="http://schemas.openxmlformats.org/presentationml/2006/main">
+  <p:cSld>
+    <p:spTree>
+      <p:nvGrpSpPr>
+        <p:cNvPr id="1" name=""/>
+        <p:cNvGrpSpPr/>
+        <p:nvPr/>
+      </p:nvGrpSpPr>
+      <p:grpSpPr>
+        <a:xfrm>
+          <a:off x="0" y="0"/>
+          <a:ext cx="0" cy="0"/>
+          <a:chOff x="0" y="0"/>
+          <a:chExt cx="0" cy="0"/>
+        </a:xfrm>
+      </p:grpSpPr>
+      <p:sp>
+        <p:nvSpPr>
+          <p:cNvPr id="2" name="Slide Image Placeholder 1"/>
+          <p:cNvSpPr>
+            <a:spLocks noGrp="1" noRot="1" noChangeAspect="1"/>
+          </p:cNvSpPr>
+          <p:nvPr>
+            <p:ph type="sldImg"/>
+          </p:nvPr>
+        </p:nvSpPr>
+        <p:spPr/>
+        <p:txBody>
+          <a:bodyPr/>
+          <a:lstStyle/>
+          <a:p>
+            <a:endParaRPr lang="en-US"/>
+          </a:p>
+        </p:txBody>
+      </p:sp>
+      <p:sp>
+        <p:nvSpPr>
+          <p:cNvPr id="3" name="Notes Placeholder 2"/>
+          <p:cNvSpPr>
+            <a:spLocks noGrp="1"/>
+          </p:cNvSpPr>
+          <p:nvPr>
+            <p:ph type="body" idx="1"/>
+          </p:nvPr>
+        </p:nvSpPr>
+        <p:spPr/>
+        <p:txBody>
+          <a:bodyPr/>
+          <a:lstStyle/>
+          <a:p>
+            <a:r>
+              <a:rPr lang="en-US" dirty="0"/>
+              <a:t>ML models from ecosystem partners or open-source model zoos such as Hugging Face are quantized and optimized for embedded deployment. CMSIS-NN executes these optimized models on Cortex-M processors. For Ethos-U NPU targets, Vela converts model operations for NPU acceleration, while operations that cannot be converted continue to run on Cortex-M via CMSIS-NN.</a:t>
+            </a:r>
+          </a:p>
+          <a:p>
+            <a:endParaRPr lang="en-US" dirty="0"/>
+          </a:p>
+          <a:p>
+            <a:r>
+              <a:rPr lang="en-US" dirty="0"/>
+              <a:t>Using these workflows, developers can deploy trained models from </a:t>
+            </a:r>
+            <a:r>
+              <a:rPr lang="en-US" dirty="0" err="1"/>
+              <a:t>PyTorch</a:t>
+            </a:r>
+            <a:r>
+              <a:rPr lang="en-US" dirty="0"/>
+              <a:t>, TensorFlow, and other frameworks onto Arm targets with optimal performance and energy efficiency, enabling intelligent capabilities in IoT devices, wearables, industrial sensors, and other edge computing applications.</a:t>
+            </a:r>
+          </a:p>
+        </p:txBody>
+      </p:sp>
+      <p:sp>
+        <p:nvSpPr>
+          <p:cNvPr id="4" name="Slide Number Placeholder 3"/>
+          <p:cNvSpPr>
+            <a:spLocks noGrp="1"/>
+          </p:cNvSpPr>
+          <p:nvPr>
+            <p:ph type="sldNum" sz="quarter" idx="5"/>
+          </p:nvPr>
+        </p:nvSpPr>
+        <p:spPr/>
+        <p:txBody>
+          <a:bodyPr/>
+          <a:lstStyle/>
+          <a:p>
+            <a:pPr>
+              <a:defRPr/>
+            </a:pPr>
+            <a:fld id="{3B16354E-6974-4833-AB87-3220A0835E84}" type="slidenum">
+              <a:rPr lang="en-US" altLang="en-US" smtClean="0"/>
+              <a:pPr>
+                <a:defRPr/>
+              </a:pPr>
+              <a:t>2</a:t>
+            </a:fld>
+            <a:endParaRPr lang="en-US" altLang="en-US"/>
+          </a:p>
+        </p:txBody>
+      </p:sp>
+    </p:spTree>
+    <p:extLst>
+      <p:ext uri="{BB962C8B-B14F-4D97-AF65-F5344CB8AC3E}">
+        <p14:creationId xmlns:p14="http://schemas.microsoft.com/office/powerpoint/2010/main" val="1343268853"/>
+      </p:ext>
+    </p:extLst>
+  </p:cSld>
+  <p:clrMapOvr>
+    <a:masterClrMapping/>
+  </p:clrMapOvr>
+</p:notes>
 </file>
 
 <file path=ppt/slideLayouts/slideLayout1.xml><?xml version="1.0" encoding="utf-8"?>
@@ -8513,6 +8632,1883 @@
     <p:extLst>
       <p:ext uri="{BB962C8B-B14F-4D97-AF65-F5344CB8AC3E}">
         <p14:creationId xmlns:p14="http://schemas.microsoft.com/office/powerpoint/2010/main" val="3891785370"/>
+      </p:ext>
+    </p:extLst>
+  </p:cSld>
+  <p:clrMapOvr>
+    <a:masterClrMapping/>
+  </p:clrMapOvr>
+</p:sld>
+</file>
+
+<file path=ppt/slides/slide2.xml><?xml version="1.0" encoding="utf-8"?>
+<p:sld xmlns:a="http://schemas.openxmlformats.org/drawingml/2006/main" xmlns:r="http://schemas.openxmlformats.org/officeDocument/2006/relationships" xmlns:p="http://schemas.openxmlformats.org/presentationml/2006/main">
+  <p:cSld>
+    <p:spTree>
+      <p:nvGrpSpPr>
+        <p:cNvPr id="1" name="">
+          <a:extLst>
+            <a:ext uri="{FF2B5EF4-FFF2-40B4-BE49-F238E27FC236}">
+              <a16:creationId xmlns:a16="http://schemas.microsoft.com/office/drawing/2014/main" id="{7FE8CB31-D479-813F-1133-4DB5A2F61AE3}"/>
+            </a:ext>
+          </a:extLst>
+        </p:cNvPr>
+        <p:cNvGrpSpPr/>
+        <p:nvPr/>
+      </p:nvGrpSpPr>
+      <p:grpSpPr>
+        <a:xfrm>
+          <a:off x="0" y="0"/>
+          <a:ext cx="0" cy="0"/>
+          <a:chOff x="0" y="0"/>
+          <a:chExt cx="0" cy="0"/>
+        </a:xfrm>
+      </p:grpSpPr>
+      <p:sp>
+        <p:nvSpPr>
+          <p:cNvPr id="4" name="Process 1">
+            <a:extLst>
+              <a:ext uri="{FF2B5EF4-FFF2-40B4-BE49-F238E27FC236}">
+                <a16:creationId xmlns:a16="http://schemas.microsoft.com/office/drawing/2014/main" id="{4FCF63CE-1B35-24F1-B1FD-F082296A3DE8}"/>
+              </a:ext>
+            </a:extLst>
+          </p:cNvPr>
+          <p:cNvSpPr>
+            <a:spLocks/>
+          </p:cNvSpPr>
+          <p:nvPr/>
+        </p:nvSpPr>
+        <p:spPr>
+          <a:xfrm>
+            <a:off x="1311874" y="2099558"/>
+            <a:ext cx="3313741" cy="3125586"/>
+          </a:xfrm>
+          <a:prstGeom prst="flowChartProcess">
+            <a:avLst/>
+          </a:prstGeom>
+          <a:solidFill>
+            <a:schemeClr val="tx1">
+              <a:lumMod val="50000"/>
+              <a:lumOff val="50000"/>
+            </a:schemeClr>
+          </a:solidFill>
+          <a:ln w="15875">
+            <a:solidFill>
+              <a:schemeClr val="bg1"/>
+            </a:solidFill>
+          </a:ln>
+        </p:spPr>
+        <p:style>
+          <a:lnRef idx="2">
+            <a:schemeClr val="accent1">
+              <a:shade val="50000"/>
+            </a:schemeClr>
+          </a:lnRef>
+          <a:fillRef idx="1">
+            <a:schemeClr val="accent1"/>
+          </a:fillRef>
+          <a:effectRef idx="0">
+            <a:schemeClr val="accent1"/>
+          </a:effectRef>
+          <a:fontRef idx="minor">
+            <a:schemeClr val="lt1"/>
+          </a:fontRef>
+        </p:style>
+        <p:txBody>
+          <a:bodyPr tIns="108000" rtlCol="0" anchor="t"/>
+          <a:lstStyle/>
+          <a:p>
+            <a:pPr algn="ctr" defTabSz="1219170">
+              <a:defRPr/>
+            </a:pPr>
+            <a:r>
+              <a:rPr lang="en-US" b="1" spc="400">
+                <a:solidFill>
+                  <a:srgbClr val="FFFFFF"/>
+                </a:solidFill>
+                <a:latin typeface="Arial" panose="020B0604020202020204" pitchFamily="34" charset="0"/>
+                <a:ea typeface="ＭＳ Ｐゴシック" charset="0"/>
+                <a:cs typeface="Arial" panose="020B0604020202020204" pitchFamily="34" charset="0"/>
+              </a:rPr>
+              <a:t>HOST (OFFLINE)</a:t>
+            </a:r>
+          </a:p>
+        </p:txBody>
+      </p:sp>
+      <p:sp>
+        <p:nvSpPr>
+          <p:cNvPr id="2" name="Title 1">
+            <a:extLst>
+              <a:ext uri="{FF2B5EF4-FFF2-40B4-BE49-F238E27FC236}">
+                <a16:creationId xmlns:a16="http://schemas.microsoft.com/office/drawing/2014/main" id="{FDC469D0-27D4-7479-20B3-B424DE886CDE}"/>
+              </a:ext>
+            </a:extLst>
+          </p:cNvPr>
+          <p:cNvSpPr>
+            <a:spLocks noGrp="1"/>
+          </p:cNvSpPr>
+          <p:nvPr>
+            <p:ph type="title"/>
+          </p:nvPr>
+        </p:nvSpPr>
+        <p:spPr/>
+        <p:txBody>
+          <a:bodyPr/>
+          <a:lstStyle/>
+          <a:p>
+            <a:r>
+              <a:rPr lang="en-US"/>
+              <a:t>Ethos-U Optimized Software Flow for </a:t>
+            </a:r>
+            <a:r>
+              <a:rPr lang="en-US" err="1"/>
+              <a:t>Tensorflow</a:t>
+            </a:r>
+            <a:r>
+              <a:rPr lang="en-US"/>
+              <a:t>/</a:t>
+            </a:r>
+            <a:r>
+              <a:rPr lang="en-US" err="1"/>
+              <a:t>PyTorch</a:t>
+            </a:r>
+            <a:endParaRPr lang="en-US"/>
+          </a:p>
+        </p:txBody>
+      </p:sp>
+      <p:sp>
+        <p:nvSpPr>
+          <p:cNvPr id="29" name="Text Placeholder 28">
+            <a:extLst>
+              <a:ext uri="{FF2B5EF4-FFF2-40B4-BE49-F238E27FC236}">
+                <a16:creationId xmlns:a16="http://schemas.microsoft.com/office/drawing/2014/main" id="{9932E99C-CFB9-B2EB-9766-774541C1F639}"/>
+              </a:ext>
+            </a:extLst>
+          </p:cNvPr>
+          <p:cNvSpPr>
+            <a:spLocks noGrp="1"/>
+          </p:cNvSpPr>
+          <p:nvPr>
+            <p:ph type="body" sz="quarter" idx="13"/>
+          </p:nvPr>
+        </p:nvSpPr>
+        <p:spPr/>
+        <p:txBody>
+          <a:bodyPr/>
+          <a:lstStyle/>
+          <a:p>
+            <a:r>
+              <a:rPr lang="en-US">
+                <a:hlinkClick r:id="rId3"/>
+              </a:rPr>
+              <a:t>github.com/Arm-Examples#edge-ai-and-machine-learning</a:t>
+            </a:r>
+            <a:endParaRPr lang="en-US"/>
+          </a:p>
+        </p:txBody>
+      </p:sp>
+      <p:sp>
+        <p:nvSpPr>
+          <p:cNvPr id="11" name="Process 65">
+            <a:extLst>
+              <a:ext uri="{FF2B5EF4-FFF2-40B4-BE49-F238E27FC236}">
+                <a16:creationId xmlns:a16="http://schemas.microsoft.com/office/drawing/2014/main" id="{2A273938-131D-99FA-670C-949235DE00D4}"/>
+              </a:ext>
+            </a:extLst>
+          </p:cNvPr>
+          <p:cNvSpPr>
+            <a:spLocks/>
+          </p:cNvSpPr>
+          <p:nvPr/>
+        </p:nvSpPr>
+        <p:spPr>
+          <a:xfrm>
+            <a:off x="4769708" y="2094471"/>
+            <a:ext cx="6110417" cy="3125586"/>
+          </a:xfrm>
+          <a:prstGeom prst="flowChartProcess">
+            <a:avLst/>
+          </a:prstGeom>
+          <a:solidFill>
+            <a:schemeClr val="bg2">
+              <a:lumMod val="50000"/>
+            </a:schemeClr>
+          </a:solidFill>
+          <a:ln w="0">
+            <a:solidFill>
+              <a:schemeClr val="bg1"/>
+            </a:solidFill>
+          </a:ln>
+        </p:spPr>
+        <p:style>
+          <a:lnRef idx="2">
+            <a:schemeClr val="accent1">
+              <a:shade val="50000"/>
+            </a:schemeClr>
+          </a:lnRef>
+          <a:fillRef idx="1">
+            <a:schemeClr val="accent1"/>
+          </a:fillRef>
+          <a:effectRef idx="0">
+            <a:schemeClr val="accent1"/>
+          </a:effectRef>
+          <a:fontRef idx="minor">
+            <a:schemeClr val="lt1"/>
+          </a:fontRef>
+        </p:style>
+        <p:txBody>
+          <a:bodyPr tIns="108000" rtlCol="0" anchor="t"/>
+          <a:lstStyle/>
+          <a:p>
+            <a:pPr algn="ctr" defTabSz="1219170">
+              <a:defRPr/>
+            </a:pPr>
+            <a:r>
+              <a:rPr lang="en-US" b="1" spc="400" dirty="0">
+                <a:solidFill>
+                  <a:srgbClr val="FFFFFF"/>
+                </a:solidFill>
+                <a:latin typeface="Arial" panose="020B0604020202020204" pitchFamily="34" charset="0"/>
+                <a:ea typeface="ＭＳ Ｐゴシック" charset="0"/>
+                <a:cs typeface="Arial" panose="020B0604020202020204" pitchFamily="34" charset="0"/>
+              </a:rPr>
+              <a:t>DEVICE with Ethos-U</a:t>
+            </a:r>
+          </a:p>
+        </p:txBody>
+      </p:sp>
+      <p:sp>
+        <p:nvSpPr>
+          <p:cNvPr id="14" name="角丸四角形 7">
+            <a:extLst>
+              <a:ext uri="{FF2B5EF4-FFF2-40B4-BE49-F238E27FC236}">
+                <a16:creationId xmlns:a16="http://schemas.microsoft.com/office/drawing/2014/main" id="{4A4BEEB3-6ABA-56BD-435A-F8B37D701949}"/>
+              </a:ext>
+            </a:extLst>
+          </p:cNvPr>
+          <p:cNvSpPr>
+            <a:spLocks/>
+          </p:cNvSpPr>
+          <p:nvPr/>
+        </p:nvSpPr>
+        <p:spPr>
+          <a:xfrm>
+            <a:off x="7497538" y="2576367"/>
+            <a:ext cx="1238946" cy="1007207"/>
+          </a:xfrm>
+          <a:prstGeom prst="roundRect">
+            <a:avLst>
+              <a:gd name="adj" fmla="val 0"/>
+            </a:avLst>
+          </a:prstGeom>
+          <a:solidFill>
+            <a:schemeClr val="accent1"/>
+          </a:solidFill>
+          <a:ln>
+            <a:noFill/>
+          </a:ln>
+        </p:spPr>
+        <p:style>
+          <a:lnRef idx="0">
+            <a:scrgbClr r="0" g="0" b="0"/>
+          </a:lnRef>
+          <a:fillRef idx="0">
+            <a:scrgbClr r="0" g="0" b="0"/>
+          </a:fillRef>
+          <a:effectRef idx="0">
+            <a:scrgbClr r="0" g="0" b="0"/>
+          </a:effectRef>
+          <a:fontRef idx="minor">
+            <a:schemeClr val="lt1"/>
+          </a:fontRef>
+        </p:style>
+        <p:txBody>
+          <a:bodyPr rtlCol="0" anchor="ctr" anchorCtr="1"/>
+          <a:lstStyle/>
+          <a:p>
+            <a:pPr marL="0" marR="0" lvl="0" indent="0" algn="ctr" defTabSz="1218804" rtl="0" eaLnBrk="0" fontAlgn="base" latinLnBrk="0" hangingPunct="0">
+              <a:lnSpc>
+                <a:spcPct val="100000"/>
+              </a:lnSpc>
+              <a:spcBef>
+                <a:spcPct val="0"/>
+              </a:spcBef>
+              <a:spcAft>
+                <a:spcPct val="0"/>
+              </a:spcAft>
+              <a:buClrTx/>
+              <a:buSzTx/>
+              <a:buFontTx/>
+              <a:buNone/>
+              <a:tabLst/>
+              <a:defRPr/>
+            </a:pPr>
+            <a:r>
+              <a:rPr kumimoji="1" lang="sv-SE" altLang="ja-JP" sz="1600" b="0" i="0" u="none" strike="noStrike" kern="1200" cap="none" spc="0" normalizeH="0" baseline="0" noProof="0" dirty="0">
+                <a:ln>
+                  <a:noFill/>
+                </a:ln>
+                <a:solidFill>
+                  <a:prstClr val="white"/>
+                </a:solidFill>
+                <a:effectLst/>
+                <a:uLnTx/>
+                <a:uFillTx/>
+                <a:latin typeface="Arial" panose="020B0604020202020204" pitchFamily="34" charset="0"/>
+                <a:ea typeface="Lato Light" panose="020F0502020204030203" pitchFamily="34" charset="0"/>
+                <a:cs typeface="Arial" panose="020B0604020202020204" pitchFamily="34" charset="0"/>
+              </a:rPr>
+              <a:t>CMSIS-NN</a:t>
+            </a:r>
+            <a:endParaRPr kumimoji="0" lang="en-US" sz="1600" b="0" i="0" u="none" strike="noStrike" kern="1200" cap="none" spc="0" normalizeH="0" baseline="0" noProof="0" dirty="0">
+              <a:ln>
+                <a:noFill/>
+              </a:ln>
+              <a:solidFill>
+                <a:prstClr val="white"/>
+              </a:solidFill>
+              <a:effectLst/>
+              <a:uLnTx/>
+              <a:uFillTx/>
+              <a:latin typeface="Arial" panose="020B0604020202020204" pitchFamily="34" charset="0"/>
+              <a:ea typeface="Lato Light" panose="020F0502020204030203" pitchFamily="34" charset="0"/>
+              <a:cs typeface="Arial" panose="020B0604020202020204" pitchFamily="34" charset="0"/>
+            </a:endParaRPr>
+          </a:p>
+          <a:p>
+            <a:pPr marL="0" marR="0" lvl="0" indent="0" algn="ctr" defTabSz="1218804" rtl="0" eaLnBrk="0" fontAlgn="base" latinLnBrk="0" hangingPunct="0">
+              <a:lnSpc>
+                <a:spcPct val="100000"/>
+              </a:lnSpc>
+              <a:spcBef>
+                <a:spcPct val="0"/>
+              </a:spcBef>
+              <a:spcAft>
+                <a:spcPct val="0"/>
+              </a:spcAft>
+              <a:buClrTx/>
+              <a:buSzTx/>
+              <a:buFontTx/>
+              <a:buNone/>
+              <a:tabLst/>
+              <a:defRPr/>
+            </a:pPr>
+            <a:r>
+              <a:rPr kumimoji="1" lang="sv-SE" altLang="ja-JP" sz="1600" b="0" i="0" u="none" strike="noStrike" kern="1200" cap="none" spc="0" normalizeH="0" baseline="0" noProof="0" dirty="0">
+                <a:ln>
+                  <a:noFill/>
+                </a:ln>
+                <a:solidFill>
+                  <a:prstClr val="white"/>
+                </a:solidFill>
+                <a:effectLst/>
+                <a:uLnTx/>
+                <a:uFillTx/>
+                <a:latin typeface="Arial" panose="020B0604020202020204" pitchFamily="34" charset="0"/>
+                <a:ea typeface="Lato Light" panose="020F0502020204030203" pitchFamily="34" charset="0"/>
+                <a:cs typeface="Arial" panose="020B0604020202020204" pitchFamily="34" charset="0"/>
+              </a:rPr>
+              <a:t>Optimized Kernels</a:t>
+            </a:r>
+            <a:endParaRPr kumimoji="0" lang="en-US" altLang="ja-JP" sz="1600" b="0" i="0" u="none" strike="noStrike" kern="1200" cap="none" spc="0" normalizeH="0" baseline="0" noProof="0" dirty="0">
+              <a:ln>
+                <a:noFill/>
+              </a:ln>
+              <a:solidFill>
+                <a:prstClr val="white"/>
+              </a:solidFill>
+              <a:effectLst/>
+              <a:uLnTx/>
+              <a:uFillTx/>
+              <a:latin typeface="Arial" panose="020B0604020202020204" pitchFamily="34" charset="0"/>
+              <a:ea typeface="Lato Light" panose="020F0502020204030203" pitchFamily="34" charset="0"/>
+              <a:cs typeface="Arial" panose="020B0604020202020204" pitchFamily="34" charset="0"/>
+            </a:endParaRPr>
+          </a:p>
+        </p:txBody>
+      </p:sp>
+      <p:sp>
+        <p:nvSpPr>
+          <p:cNvPr id="15" name="Rectangle 14">
+            <a:extLst>
+              <a:ext uri="{FF2B5EF4-FFF2-40B4-BE49-F238E27FC236}">
+                <a16:creationId xmlns:a16="http://schemas.microsoft.com/office/drawing/2014/main" id="{E4FAB7E5-0E21-B079-B67A-C8A4D53F3621}"/>
+              </a:ext>
+            </a:extLst>
+          </p:cNvPr>
+          <p:cNvSpPr>
+            <a:spLocks/>
+          </p:cNvSpPr>
+          <p:nvPr/>
+        </p:nvSpPr>
+        <p:spPr>
+          <a:xfrm>
+            <a:off x="9196335" y="2582562"/>
+            <a:ext cx="1238946" cy="991024"/>
+          </a:xfrm>
+          <a:prstGeom prst="rect">
+            <a:avLst/>
+          </a:prstGeom>
+          <a:solidFill>
+            <a:schemeClr val="accent1"/>
+          </a:solidFill>
+          <a:ln>
+            <a:noFill/>
+          </a:ln>
+        </p:spPr>
+        <p:style>
+          <a:lnRef idx="0">
+            <a:scrgbClr r="0" g="0" b="0"/>
+          </a:lnRef>
+          <a:fillRef idx="0">
+            <a:scrgbClr r="0" g="0" b="0"/>
+          </a:fillRef>
+          <a:effectRef idx="0">
+            <a:scrgbClr r="0" g="0" b="0"/>
+          </a:effectRef>
+          <a:fontRef idx="minor">
+            <a:schemeClr val="lt1"/>
+          </a:fontRef>
+        </p:style>
+        <p:txBody>
+          <a:bodyPr rtlCol="0" anchor="ctr"/>
+          <a:lstStyle/>
+          <a:p>
+            <a:pPr marL="0" marR="0" lvl="0" indent="0" algn="ctr" defTabSz="1218804" rtl="0" eaLnBrk="0" fontAlgn="base" latinLnBrk="0" hangingPunct="0">
+              <a:lnSpc>
+                <a:spcPct val="100000"/>
+              </a:lnSpc>
+              <a:spcBef>
+                <a:spcPct val="0"/>
+              </a:spcBef>
+              <a:spcAft>
+                <a:spcPct val="0"/>
+              </a:spcAft>
+              <a:buClrTx/>
+              <a:buSzTx/>
+              <a:buFontTx/>
+              <a:buNone/>
+              <a:tabLst/>
+              <a:defRPr/>
+            </a:pPr>
+            <a:r>
+              <a:rPr kumimoji="0" lang="en-GB" sz="1600" b="0" i="0" u="none" strike="noStrike" kern="1200" cap="none" spc="0" normalizeH="0" baseline="0" noProof="0">
+                <a:ln>
+                  <a:noFill/>
+                </a:ln>
+                <a:solidFill>
+                  <a:prstClr val="white"/>
+                </a:solidFill>
+                <a:effectLst/>
+                <a:uLnTx/>
+                <a:uFillTx/>
+                <a:latin typeface="Arial" panose="020B0604020202020204" pitchFamily="34" charset="0"/>
+                <a:ea typeface="Lato Light" panose="020F0502020204030203" pitchFamily="34" charset="0"/>
+                <a:cs typeface="Arial" panose="020B0604020202020204" pitchFamily="34" charset="0"/>
+              </a:rPr>
+              <a:t>Cortex-M</a:t>
+            </a:r>
+          </a:p>
+          <a:p>
+            <a:pPr marL="0" marR="0" lvl="0" indent="0" algn="ctr" defTabSz="1218804" rtl="0" eaLnBrk="0" fontAlgn="base" latinLnBrk="0" hangingPunct="0">
+              <a:lnSpc>
+                <a:spcPct val="100000"/>
+              </a:lnSpc>
+              <a:spcBef>
+                <a:spcPct val="0"/>
+              </a:spcBef>
+              <a:spcAft>
+                <a:spcPct val="0"/>
+              </a:spcAft>
+              <a:buClrTx/>
+              <a:buSzTx/>
+              <a:buFontTx/>
+              <a:buNone/>
+              <a:tabLst/>
+              <a:defRPr/>
+            </a:pPr>
+            <a:r>
+              <a:rPr kumimoji="0" lang="en-GB" sz="1600" b="0" i="0" u="none" strike="noStrike" kern="1200" cap="none" spc="0" normalizeH="0" baseline="0" noProof="0">
+                <a:ln>
+                  <a:noFill/>
+                </a:ln>
+                <a:solidFill>
+                  <a:prstClr val="white"/>
+                </a:solidFill>
+                <a:effectLst/>
+                <a:uLnTx/>
+                <a:uFillTx/>
+                <a:latin typeface="Arial" panose="020B0604020202020204" pitchFamily="34" charset="0"/>
+                <a:ea typeface="Lato Light" panose="020F0502020204030203" pitchFamily="34" charset="0"/>
+                <a:cs typeface="Arial" panose="020B0604020202020204" pitchFamily="34" charset="0"/>
+              </a:rPr>
+              <a:t>CPU</a:t>
+            </a:r>
+          </a:p>
+        </p:txBody>
+      </p:sp>
+      <p:sp>
+        <p:nvSpPr>
+          <p:cNvPr id="18" name="角丸四角形 7">
+            <a:extLst>
+              <a:ext uri="{FF2B5EF4-FFF2-40B4-BE49-F238E27FC236}">
+                <a16:creationId xmlns:a16="http://schemas.microsoft.com/office/drawing/2014/main" id="{308DED3E-3A0C-74DA-7E1C-9AA424063B8D}"/>
+              </a:ext>
+            </a:extLst>
+          </p:cNvPr>
+          <p:cNvSpPr>
+            <a:spLocks/>
+          </p:cNvSpPr>
+          <p:nvPr/>
+        </p:nvSpPr>
+        <p:spPr>
+          <a:xfrm>
+            <a:off x="7504050" y="4050495"/>
+            <a:ext cx="1238946" cy="991024"/>
+          </a:xfrm>
+          <a:prstGeom prst="roundRect">
+            <a:avLst>
+              <a:gd name="adj" fmla="val 0"/>
+            </a:avLst>
+          </a:prstGeom>
+          <a:solidFill>
+            <a:schemeClr val="accent1">
+              <a:lumMod val="75000"/>
+            </a:schemeClr>
+          </a:solidFill>
+          <a:ln>
+            <a:noFill/>
+          </a:ln>
+        </p:spPr>
+        <p:style>
+          <a:lnRef idx="0">
+            <a:scrgbClr r="0" g="0" b="0"/>
+          </a:lnRef>
+          <a:fillRef idx="0">
+            <a:scrgbClr r="0" g="0" b="0"/>
+          </a:fillRef>
+          <a:effectRef idx="0">
+            <a:scrgbClr r="0" g="0" b="0"/>
+          </a:effectRef>
+          <a:fontRef idx="minor">
+            <a:schemeClr val="lt1"/>
+          </a:fontRef>
+        </p:style>
+        <p:txBody>
+          <a:bodyPr rtlCol="0" anchor="ctr" anchorCtr="1"/>
+          <a:lstStyle/>
+          <a:p>
+            <a:pPr marL="0" marR="0" lvl="0" indent="0" algn="ctr" defTabSz="1218804" rtl="0" eaLnBrk="0" fontAlgn="base" latinLnBrk="0" hangingPunct="0">
+              <a:lnSpc>
+                <a:spcPct val="100000"/>
+              </a:lnSpc>
+              <a:spcBef>
+                <a:spcPct val="0"/>
+              </a:spcBef>
+              <a:spcAft>
+                <a:spcPct val="0"/>
+              </a:spcAft>
+              <a:buClrTx/>
+              <a:buSzTx/>
+              <a:buFontTx/>
+              <a:buNone/>
+              <a:tabLst/>
+              <a:defRPr/>
+            </a:pPr>
+            <a:r>
+              <a:rPr kumimoji="1" lang="sv-SE" altLang="ja-JP" sz="1600" b="0" i="0" u="none" strike="noStrike" kern="1200" cap="none" spc="0" normalizeH="0" baseline="0" noProof="0">
+                <a:ln>
+                  <a:noFill/>
+                </a:ln>
+                <a:solidFill>
+                  <a:prstClr val="white"/>
+                </a:solidFill>
+                <a:effectLst/>
+                <a:uLnTx/>
+                <a:uFillTx/>
+                <a:latin typeface="Arial" panose="020B0604020202020204" pitchFamily="34" charset="0"/>
+                <a:ea typeface="Lato Light" panose="020F0502020204030203" pitchFamily="34" charset="0"/>
+                <a:cs typeface="Arial" panose="020B0604020202020204" pitchFamily="34" charset="0"/>
+              </a:rPr>
+              <a:t>Ethos-U Driver</a:t>
+            </a:r>
+            <a:endParaRPr kumimoji="0" lang="en-US" altLang="ja-JP" sz="1600" b="0" i="0" u="none" strike="noStrike" kern="1200" cap="none" spc="0" normalizeH="0" baseline="0" noProof="0">
+              <a:ln>
+                <a:noFill/>
+              </a:ln>
+              <a:solidFill>
+                <a:prstClr val="white"/>
+              </a:solidFill>
+              <a:effectLst/>
+              <a:uLnTx/>
+              <a:uFillTx/>
+              <a:latin typeface="Arial" panose="020B0604020202020204" pitchFamily="34" charset="0"/>
+              <a:ea typeface="Lato Light" panose="020F0502020204030203" pitchFamily="34" charset="0"/>
+              <a:cs typeface="Arial" panose="020B0604020202020204" pitchFamily="34" charset="0"/>
+            </a:endParaRPr>
+          </a:p>
+        </p:txBody>
+      </p:sp>
+      <p:sp>
+        <p:nvSpPr>
+          <p:cNvPr id="20" name="角丸四角形 6">
+            <a:extLst>
+              <a:ext uri="{FF2B5EF4-FFF2-40B4-BE49-F238E27FC236}">
+                <a16:creationId xmlns:a16="http://schemas.microsoft.com/office/drawing/2014/main" id="{E6453D9D-7C8A-4615-4482-436DC263D8B6}"/>
+              </a:ext>
+            </a:extLst>
+          </p:cNvPr>
+          <p:cNvSpPr>
+            <a:spLocks/>
+          </p:cNvSpPr>
+          <p:nvPr/>
+        </p:nvSpPr>
+        <p:spPr>
+          <a:xfrm>
+            <a:off x="3241807" y="3293081"/>
+            <a:ext cx="1240452" cy="1054166"/>
+          </a:xfrm>
+          <a:prstGeom prst="roundRect">
+            <a:avLst>
+              <a:gd name="adj" fmla="val 0"/>
+            </a:avLst>
+          </a:prstGeom>
+          <a:solidFill>
+            <a:schemeClr val="accent1">
+              <a:lumMod val="75000"/>
+            </a:schemeClr>
+          </a:solidFill>
+          <a:ln w="15875">
+            <a:noFill/>
+          </a:ln>
+        </p:spPr>
+        <p:style>
+          <a:lnRef idx="2">
+            <a:schemeClr val="accent4"/>
+          </a:lnRef>
+          <a:fillRef idx="1">
+            <a:schemeClr val="lt1"/>
+          </a:fillRef>
+          <a:effectRef idx="0">
+            <a:schemeClr val="accent4"/>
+          </a:effectRef>
+          <a:fontRef idx="minor">
+            <a:schemeClr val="dk1"/>
+          </a:fontRef>
+        </p:style>
+        <p:txBody>
+          <a:bodyPr lIns="0" rIns="0" rtlCol="0" anchor="ctr" anchorCtr="1"/>
+          <a:lstStyle/>
+          <a:p>
+            <a:pPr marL="0" marR="0" lvl="0" indent="0" algn="ctr" defTabSz="1218804" rtl="0" eaLnBrk="0" fontAlgn="base" latinLnBrk="0" hangingPunct="0">
+              <a:lnSpc>
+                <a:spcPct val="100000"/>
+              </a:lnSpc>
+              <a:spcBef>
+                <a:spcPct val="0"/>
+              </a:spcBef>
+              <a:spcAft>
+                <a:spcPct val="0"/>
+              </a:spcAft>
+              <a:buClrTx/>
+              <a:buSzTx/>
+              <a:buFontTx/>
+              <a:buNone/>
+              <a:tabLst/>
+              <a:defRPr/>
+            </a:pPr>
+            <a:r>
+              <a:rPr kumimoji="1" lang="sv-SE" altLang="ja-JP" sz="1600" b="0" i="0" u="none" strike="noStrike" kern="1200" cap="none" spc="0" normalizeH="0" baseline="0" noProof="0" dirty="0">
+                <a:ln>
+                  <a:noFill/>
+                </a:ln>
+                <a:solidFill>
+                  <a:srgbClr val="FFFFFF"/>
+                </a:solidFill>
+                <a:effectLst/>
+                <a:uLnTx/>
+                <a:uFillTx/>
+                <a:latin typeface="Arial" panose="020B0604020202020204" pitchFamily="34" charset="0"/>
+                <a:ea typeface="Lato" panose="020F0502020204030203" pitchFamily="34" charset="0"/>
+                <a:cs typeface="Arial" panose="020B0604020202020204" pitchFamily="34" charset="0"/>
+              </a:rPr>
+              <a:t>Vela</a:t>
+            </a:r>
+            <a:br>
+              <a:rPr kumimoji="1" lang="sv-SE" altLang="ja-JP" sz="1600" b="0" i="0" u="none" strike="noStrike" kern="1200" cap="none" spc="0" normalizeH="0" baseline="0" noProof="0" dirty="0">
+                <a:ln>
+                  <a:noFill/>
+                </a:ln>
+                <a:solidFill>
+                  <a:srgbClr val="FFFFFF"/>
+                </a:solidFill>
+                <a:effectLst/>
+                <a:uLnTx/>
+                <a:uFillTx/>
+                <a:latin typeface="Arial" panose="020B0604020202020204" pitchFamily="34" charset="0"/>
+                <a:ea typeface="Lato" panose="020F0502020204030203" pitchFamily="34" charset="0"/>
+                <a:cs typeface="Arial" panose="020B0604020202020204" pitchFamily="34" charset="0"/>
+              </a:rPr>
+            </a:br>
+            <a:r>
+              <a:rPr kumimoji="1" lang="sv-SE" altLang="ja-JP" sz="1600" b="0" i="0" u="none" strike="noStrike" kern="1200" cap="none" spc="0" normalizeH="0" baseline="0" noProof="0" dirty="0">
+                <a:ln>
+                  <a:noFill/>
+                </a:ln>
+                <a:solidFill>
+                  <a:srgbClr val="FFFFFF"/>
+                </a:solidFill>
+                <a:effectLst/>
+                <a:uLnTx/>
+                <a:uFillTx/>
+                <a:latin typeface="Arial" panose="020B0604020202020204" pitchFamily="34" charset="0"/>
+                <a:ea typeface="Lato" panose="020F0502020204030203" pitchFamily="34" charset="0"/>
+                <a:cs typeface="Arial" panose="020B0604020202020204" pitchFamily="34" charset="0"/>
+              </a:rPr>
+              <a:t>Compiler</a:t>
+            </a:r>
+          </a:p>
+        </p:txBody>
+      </p:sp>
+      <p:sp>
+        <p:nvSpPr>
+          <p:cNvPr id="35" name="Right Arrow 34">
+            <a:extLst>
+              <a:ext uri="{FF2B5EF4-FFF2-40B4-BE49-F238E27FC236}">
+                <a16:creationId xmlns:a16="http://schemas.microsoft.com/office/drawing/2014/main" id="{A1D85C2F-7060-6370-50A6-5ED2EDF5FE19}"/>
+              </a:ext>
+            </a:extLst>
+          </p:cNvPr>
+          <p:cNvSpPr>
+            <a:spLocks/>
+          </p:cNvSpPr>
+          <p:nvPr/>
+        </p:nvSpPr>
+        <p:spPr>
+          <a:xfrm>
+            <a:off x="8746015" y="2836039"/>
+            <a:ext cx="450320" cy="535780"/>
+          </a:xfrm>
+          <a:prstGeom prst="rightArrow">
+            <a:avLst/>
+          </a:prstGeom>
+          <a:solidFill>
+            <a:schemeClr val="bg1"/>
+          </a:solidFill>
+          <a:ln>
+            <a:solidFill>
+              <a:schemeClr val="tx2">
+                <a:lumMod val="40000"/>
+                <a:lumOff val="60000"/>
+              </a:schemeClr>
+            </a:solidFill>
+          </a:ln>
+        </p:spPr>
+        <p:style>
+          <a:lnRef idx="2">
+            <a:schemeClr val="accent1">
+              <a:shade val="50000"/>
+            </a:schemeClr>
+          </a:lnRef>
+          <a:fillRef idx="1">
+            <a:schemeClr val="accent1"/>
+          </a:fillRef>
+          <a:effectRef idx="0">
+            <a:schemeClr val="accent1"/>
+          </a:effectRef>
+          <a:fontRef idx="minor">
+            <a:schemeClr val="lt1"/>
+          </a:fontRef>
+        </p:style>
+        <p:txBody>
+          <a:bodyPr rtlCol="0" anchor="ctr"/>
+          <a:lstStyle/>
+          <a:p>
+            <a:pPr algn="ctr"/>
+            <a:endParaRPr lang="en-DE">
+              <a:latin typeface="Arial" panose="020B0604020202020204" pitchFamily="34" charset="0"/>
+              <a:cs typeface="Arial" panose="020B0604020202020204" pitchFamily="34" charset="0"/>
+            </a:endParaRPr>
+          </a:p>
+        </p:txBody>
+      </p:sp>
+      <p:sp>
+        <p:nvSpPr>
+          <p:cNvPr id="3" name="角丸四角形 7">
+            <a:extLst>
+              <a:ext uri="{FF2B5EF4-FFF2-40B4-BE49-F238E27FC236}">
+                <a16:creationId xmlns:a16="http://schemas.microsoft.com/office/drawing/2014/main" id="{57BCF680-F5F7-7238-5EDB-E56AF1DFA5A8}"/>
+              </a:ext>
+            </a:extLst>
+          </p:cNvPr>
+          <p:cNvSpPr>
+            <a:spLocks/>
+          </p:cNvSpPr>
+          <p:nvPr/>
+        </p:nvSpPr>
+        <p:spPr>
+          <a:xfrm>
+            <a:off x="9196335" y="4050495"/>
+            <a:ext cx="1238946" cy="991024"/>
+          </a:xfrm>
+          <a:prstGeom prst="roundRect">
+            <a:avLst>
+              <a:gd name="adj" fmla="val 0"/>
+            </a:avLst>
+          </a:prstGeom>
+          <a:solidFill>
+            <a:schemeClr val="accent1">
+              <a:lumMod val="75000"/>
+            </a:schemeClr>
+          </a:solidFill>
+          <a:ln>
+            <a:noFill/>
+          </a:ln>
+        </p:spPr>
+        <p:style>
+          <a:lnRef idx="0">
+            <a:scrgbClr r="0" g="0" b="0"/>
+          </a:lnRef>
+          <a:fillRef idx="0">
+            <a:scrgbClr r="0" g="0" b="0"/>
+          </a:fillRef>
+          <a:effectRef idx="0">
+            <a:scrgbClr r="0" g="0" b="0"/>
+          </a:effectRef>
+          <a:fontRef idx="minor">
+            <a:schemeClr val="lt1"/>
+          </a:fontRef>
+        </p:style>
+        <p:txBody>
+          <a:bodyPr rtlCol="0" anchor="ctr" anchorCtr="1"/>
+          <a:lstStyle/>
+          <a:p>
+            <a:pPr marL="0" marR="0" lvl="0" indent="0" algn="ctr" defTabSz="1218804" rtl="0" eaLnBrk="0" fontAlgn="base" latinLnBrk="0" hangingPunct="0">
+              <a:lnSpc>
+                <a:spcPct val="100000"/>
+              </a:lnSpc>
+              <a:spcBef>
+                <a:spcPct val="0"/>
+              </a:spcBef>
+              <a:spcAft>
+                <a:spcPct val="0"/>
+              </a:spcAft>
+              <a:buClrTx/>
+              <a:buSzTx/>
+              <a:buFontTx/>
+              <a:buNone/>
+              <a:tabLst/>
+              <a:defRPr/>
+            </a:pPr>
+            <a:r>
+              <a:rPr kumimoji="1" lang="sv-SE" altLang="ja-JP" sz="1600" b="0" i="0" u="none" strike="noStrike" kern="1200" cap="none" spc="0" normalizeH="0" baseline="0" noProof="0" dirty="0">
+                <a:ln>
+                  <a:noFill/>
+                </a:ln>
+                <a:solidFill>
+                  <a:prstClr val="white"/>
+                </a:solidFill>
+                <a:effectLst/>
+                <a:uLnTx/>
+                <a:uFillTx/>
+                <a:latin typeface="Arial" panose="020B0604020202020204" pitchFamily="34" charset="0"/>
+                <a:ea typeface="Lato Light" panose="020F0502020204030203" pitchFamily="34" charset="0"/>
+                <a:cs typeface="Arial" panose="020B0604020202020204" pitchFamily="34" charset="0"/>
+              </a:rPr>
+              <a:t>Ethos-U</a:t>
+            </a:r>
+            <a:br>
+              <a:rPr kumimoji="1" lang="sv-SE" altLang="ja-JP" sz="1600" b="0" i="0" u="none" strike="noStrike" kern="1200" cap="none" spc="0" normalizeH="0" baseline="0" noProof="0" dirty="0">
+                <a:ln>
+                  <a:noFill/>
+                </a:ln>
+                <a:solidFill>
+                  <a:prstClr val="white"/>
+                </a:solidFill>
+                <a:effectLst/>
+                <a:uLnTx/>
+                <a:uFillTx/>
+                <a:latin typeface="Arial" panose="020B0604020202020204" pitchFamily="34" charset="0"/>
+                <a:ea typeface="Lato Light" panose="020F0502020204030203" pitchFamily="34" charset="0"/>
+                <a:cs typeface="Arial" panose="020B0604020202020204" pitchFamily="34" charset="0"/>
+              </a:rPr>
+            </a:br>
+            <a:r>
+              <a:rPr kumimoji="1" lang="sv-SE" altLang="ja-JP" sz="1600" b="0" i="0" u="none" strike="noStrike" kern="1200" cap="none" spc="0" normalizeH="0" baseline="0" noProof="0" dirty="0">
+                <a:ln>
+                  <a:noFill/>
+                </a:ln>
+                <a:solidFill>
+                  <a:prstClr val="white"/>
+                </a:solidFill>
+                <a:effectLst/>
+                <a:uLnTx/>
+                <a:uFillTx/>
+                <a:latin typeface="Arial" panose="020B0604020202020204" pitchFamily="34" charset="0"/>
+                <a:ea typeface="Lato Light" panose="020F0502020204030203" pitchFamily="34" charset="0"/>
+                <a:cs typeface="Arial" panose="020B0604020202020204" pitchFamily="34" charset="0"/>
+              </a:rPr>
+              <a:t>NPU</a:t>
+            </a:r>
+            <a:endParaRPr kumimoji="0" lang="en-US" altLang="ja-JP" sz="1600" b="0" i="0" u="none" strike="noStrike" kern="1200" cap="none" spc="0" normalizeH="0" baseline="0" noProof="0" dirty="0">
+              <a:ln>
+                <a:noFill/>
+              </a:ln>
+              <a:solidFill>
+                <a:prstClr val="white"/>
+              </a:solidFill>
+              <a:effectLst/>
+              <a:uLnTx/>
+              <a:uFillTx/>
+              <a:latin typeface="Arial" panose="020B0604020202020204" pitchFamily="34" charset="0"/>
+              <a:ea typeface="Lato Light" panose="020F0502020204030203" pitchFamily="34" charset="0"/>
+              <a:cs typeface="Arial" panose="020B0604020202020204" pitchFamily="34" charset="0"/>
+            </a:endParaRPr>
+          </a:p>
+        </p:txBody>
+      </p:sp>
+      <p:sp>
+        <p:nvSpPr>
+          <p:cNvPr id="5" name="Right Arrow 4">
+            <a:extLst>
+              <a:ext uri="{FF2B5EF4-FFF2-40B4-BE49-F238E27FC236}">
+                <a16:creationId xmlns:a16="http://schemas.microsoft.com/office/drawing/2014/main" id="{E79C218D-32B5-55A0-FFEE-D0A945A2B352}"/>
+              </a:ext>
+            </a:extLst>
+          </p:cNvPr>
+          <p:cNvSpPr>
+            <a:spLocks/>
+          </p:cNvSpPr>
+          <p:nvPr/>
+        </p:nvSpPr>
+        <p:spPr>
+          <a:xfrm>
+            <a:off x="8752527" y="4280854"/>
+            <a:ext cx="443808" cy="535780"/>
+          </a:xfrm>
+          <a:prstGeom prst="rightArrow">
+            <a:avLst/>
+          </a:prstGeom>
+          <a:solidFill>
+            <a:schemeClr val="bg1"/>
+          </a:solidFill>
+          <a:ln>
+            <a:solidFill>
+              <a:schemeClr val="tx2">
+                <a:lumMod val="40000"/>
+                <a:lumOff val="60000"/>
+              </a:schemeClr>
+            </a:solidFill>
+          </a:ln>
+        </p:spPr>
+        <p:style>
+          <a:lnRef idx="2">
+            <a:schemeClr val="accent1">
+              <a:shade val="50000"/>
+            </a:schemeClr>
+          </a:lnRef>
+          <a:fillRef idx="1">
+            <a:schemeClr val="accent1"/>
+          </a:fillRef>
+          <a:effectRef idx="0">
+            <a:schemeClr val="accent1"/>
+          </a:effectRef>
+          <a:fontRef idx="minor">
+            <a:schemeClr val="lt1"/>
+          </a:fontRef>
+        </p:style>
+        <p:txBody>
+          <a:bodyPr rtlCol="0" anchor="ctr"/>
+          <a:lstStyle/>
+          <a:p>
+            <a:pPr algn="ctr"/>
+            <a:endParaRPr lang="en-DE">
+              <a:latin typeface="Arial" panose="020B0604020202020204" pitchFamily="34" charset="0"/>
+              <a:cs typeface="Arial" panose="020B0604020202020204" pitchFamily="34" charset="0"/>
+            </a:endParaRPr>
+          </a:p>
+        </p:txBody>
+      </p:sp>
+      <p:sp>
+        <p:nvSpPr>
+          <p:cNvPr id="6" name="Right Arrow 5">
+            <a:extLst>
+              <a:ext uri="{FF2B5EF4-FFF2-40B4-BE49-F238E27FC236}">
+                <a16:creationId xmlns:a16="http://schemas.microsoft.com/office/drawing/2014/main" id="{C11D9685-00CB-8327-9BB0-5AA82FB2CD9D}"/>
+              </a:ext>
+            </a:extLst>
+          </p:cNvPr>
+          <p:cNvSpPr>
+            <a:spLocks/>
+          </p:cNvSpPr>
+          <p:nvPr/>
+        </p:nvSpPr>
+        <p:spPr>
+          <a:xfrm>
+            <a:off x="7046273" y="2836040"/>
+            <a:ext cx="450320" cy="535780"/>
+          </a:xfrm>
+          <a:prstGeom prst="rightArrow">
+            <a:avLst/>
+          </a:prstGeom>
+          <a:solidFill>
+            <a:schemeClr val="bg1"/>
+          </a:solidFill>
+          <a:ln>
+            <a:solidFill>
+              <a:schemeClr val="tx2">
+                <a:lumMod val="40000"/>
+                <a:lumOff val="60000"/>
+              </a:schemeClr>
+            </a:solidFill>
+          </a:ln>
+        </p:spPr>
+        <p:style>
+          <a:lnRef idx="2">
+            <a:schemeClr val="accent1">
+              <a:shade val="50000"/>
+            </a:schemeClr>
+          </a:lnRef>
+          <a:fillRef idx="1">
+            <a:schemeClr val="accent1"/>
+          </a:fillRef>
+          <a:effectRef idx="0">
+            <a:schemeClr val="accent1"/>
+          </a:effectRef>
+          <a:fontRef idx="minor">
+            <a:schemeClr val="lt1"/>
+          </a:fontRef>
+        </p:style>
+        <p:txBody>
+          <a:bodyPr rtlCol="0" anchor="ctr"/>
+          <a:lstStyle/>
+          <a:p>
+            <a:pPr algn="ctr"/>
+            <a:endParaRPr lang="en-DE">
+              <a:latin typeface="Arial" panose="020B0604020202020204" pitchFamily="34" charset="0"/>
+              <a:cs typeface="Arial" panose="020B0604020202020204" pitchFamily="34" charset="0"/>
+            </a:endParaRPr>
+          </a:p>
+        </p:txBody>
+      </p:sp>
+      <p:sp>
+        <p:nvSpPr>
+          <p:cNvPr id="7" name="Right Arrow 6">
+            <a:extLst>
+              <a:ext uri="{FF2B5EF4-FFF2-40B4-BE49-F238E27FC236}">
+                <a16:creationId xmlns:a16="http://schemas.microsoft.com/office/drawing/2014/main" id="{39B6F44B-4D74-73EA-34D9-FC17C4F50EFA}"/>
+              </a:ext>
+            </a:extLst>
+          </p:cNvPr>
+          <p:cNvSpPr>
+            <a:spLocks/>
+          </p:cNvSpPr>
+          <p:nvPr/>
+        </p:nvSpPr>
+        <p:spPr>
+          <a:xfrm>
+            <a:off x="7046273" y="4280855"/>
+            <a:ext cx="450320" cy="535780"/>
+          </a:xfrm>
+          <a:prstGeom prst="rightArrow">
+            <a:avLst/>
+          </a:prstGeom>
+          <a:solidFill>
+            <a:schemeClr val="bg1"/>
+          </a:solidFill>
+          <a:ln>
+            <a:solidFill>
+              <a:schemeClr val="tx2">
+                <a:lumMod val="40000"/>
+                <a:lumOff val="60000"/>
+              </a:schemeClr>
+            </a:solidFill>
+          </a:ln>
+        </p:spPr>
+        <p:style>
+          <a:lnRef idx="2">
+            <a:schemeClr val="accent1">
+              <a:shade val="50000"/>
+            </a:schemeClr>
+          </a:lnRef>
+          <a:fillRef idx="1">
+            <a:schemeClr val="accent1"/>
+          </a:fillRef>
+          <a:effectRef idx="0">
+            <a:schemeClr val="accent1"/>
+          </a:effectRef>
+          <a:fontRef idx="minor">
+            <a:schemeClr val="lt1"/>
+          </a:fontRef>
+        </p:style>
+        <p:txBody>
+          <a:bodyPr rtlCol="0" anchor="ctr"/>
+          <a:lstStyle/>
+          <a:p>
+            <a:pPr algn="ctr"/>
+            <a:endParaRPr lang="en-DE">
+              <a:latin typeface="Arial" panose="020B0604020202020204" pitchFamily="34" charset="0"/>
+              <a:cs typeface="Arial" panose="020B0604020202020204" pitchFamily="34" charset="0"/>
+            </a:endParaRPr>
+          </a:p>
+        </p:txBody>
+      </p:sp>
+      <p:sp>
+        <p:nvSpPr>
+          <p:cNvPr id="13" name="角丸四角形 6">
+            <a:extLst>
+              <a:ext uri="{FF2B5EF4-FFF2-40B4-BE49-F238E27FC236}">
+                <a16:creationId xmlns:a16="http://schemas.microsoft.com/office/drawing/2014/main" id="{A60B54B0-3725-80A8-C9F3-40CB43AA62DE}"/>
+              </a:ext>
+            </a:extLst>
+          </p:cNvPr>
+          <p:cNvSpPr>
+            <a:spLocks/>
+          </p:cNvSpPr>
+          <p:nvPr/>
+        </p:nvSpPr>
+        <p:spPr>
+          <a:xfrm rot="16200000">
+            <a:off x="5536241" y="3538943"/>
+            <a:ext cx="2465152" cy="540000"/>
+          </a:xfrm>
+          <a:prstGeom prst="roundRect">
+            <a:avLst>
+              <a:gd name="adj" fmla="val 0"/>
+            </a:avLst>
+          </a:prstGeom>
+          <a:solidFill>
+            <a:schemeClr val="accent4"/>
+          </a:solidFill>
+          <a:ln w="15875">
+            <a:solidFill>
+              <a:schemeClr val="accent4"/>
+            </a:solidFill>
+          </a:ln>
+        </p:spPr>
+        <p:style>
+          <a:lnRef idx="2">
+            <a:schemeClr val="accent4"/>
+          </a:lnRef>
+          <a:fillRef idx="1">
+            <a:schemeClr val="lt1"/>
+          </a:fillRef>
+          <a:effectRef idx="0">
+            <a:schemeClr val="accent4"/>
+          </a:effectRef>
+          <a:fontRef idx="minor">
+            <a:schemeClr val="dk1"/>
+          </a:fontRef>
+        </p:style>
+        <p:txBody>
+          <a:bodyPr rtlCol="0" anchor="ctr" anchorCtr="1"/>
+          <a:lstStyle/>
+          <a:p>
+            <a:pPr marL="0" marR="0" lvl="0" indent="0" algn="ctr" defTabSz="1218804" rtl="0" eaLnBrk="0" fontAlgn="base" latinLnBrk="0" hangingPunct="0">
+              <a:lnSpc>
+                <a:spcPct val="100000"/>
+              </a:lnSpc>
+              <a:spcBef>
+                <a:spcPct val="0"/>
+              </a:spcBef>
+              <a:spcAft>
+                <a:spcPct val="0"/>
+              </a:spcAft>
+              <a:buClrTx/>
+              <a:buSzTx/>
+              <a:buFontTx/>
+              <a:buNone/>
+              <a:tabLst/>
+              <a:defRPr/>
+            </a:pPr>
+            <a:r>
+              <a:rPr kumimoji="1" lang="sv-SE" altLang="ja-JP" sz="1600">
+                <a:solidFill>
+                  <a:sysClr val="windowText" lastClr="000000"/>
+                </a:solidFill>
+                <a:latin typeface="Arial" panose="020B0604020202020204" pitchFamily="34" charset="0"/>
+                <a:ea typeface="Lato Light" panose="020F0502020204030203" pitchFamily="34" charset="0"/>
+                <a:cs typeface="Arial" panose="020B0604020202020204" pitchFamily="34" charset="0"/>
+              </a:rPr>
+              <a:t>ML </a:t>
+            </a:r>
+            <a:r>
+              <a:rPr kumimoji="1" lang="sv-SE" altLang="ja-JP" sz="1600" err="1">
+                <a:solidFill>
+                  <a:sysClr val="windowText" lastClr="000000"/>
+                </a:solidFill>
+                <a:latin typeface="Arial" panose="020B0604020202020204" pitchFamily="34" charset="0"/>
+                <a:ea typeface="Lato Light" panose="020F0502020204030203" pitchFamily="34" charset="0"/>
+                <a:cs typeface="Arial" panose="020B0604020202020204" pitchFamily="34" charset="0"/>
+              </a:rPr>
+              <a:t>Runtime</a:t>
+            </a:r>
+            <a:endParaRPr kumimoji="1" lang="ja-JP" altLang="en-US" sz="1600" b="0" i="0" u="none" strike="noStrike" kern="1200" cap="none" spc="0" normalizeH="0" baseline="0" noProof="0">
+              <a:ln>
+                <a:noFill/>
+              </a:ln>
+              <a:solidFill>
+                <a:sysClr val="windowText" lastClr="000000"/>
+              </a:solidFill>
+              <a:effectLst/>
+              <a:uLnTx/>
+              <a:uFillTx/>
+              <a:latin typeface="Arial" panose="020B0604020202020204" pitchFamily="34" charset="0"/>
+              <a:ea typeface="游ゴシック" panose="020B0400000000000000" pitchFamily="34" charset="-128"/>
+              <a:cs typeface="Arial" panose="020B0604020202020204" pitchFamily="34" charset="0"/>
+            </a:endParaRPr>
+          </a:p>
+        </p:txBody>
+      </p:sp>
+      <p:sp>
+        <p:nvSpPr>
+          <p:cNvPr id="10" name="Right Arrow 9">
+            <a:extLst>
+              <a:ext uri="{FF2B5EF4-FFF2-40B4-BE49-F238E27FC236}">
+                <a16:creationId xmlns:a16="http://schemas.microsoft.com/office/drawing/2014/main" id="{7BC23331-C66C-40E8-E23E-80B78E80BFFC}"/>
+              </a:ext>
+            </a:extLst>
+          </p:cNvPr>
+          <p:cNvSpPr>
+            <a:spLocks/>
+          </p:cNvSpPr>
+          <p:nvPr/>
+        </p:nvSpPr>
+        <p:spPr>
+          <a:xfrm>
+            <a:off x="6087419" y="3573392"/>
+            <a:ext cx="411398" cy="535780"/>
+          </a:xfrm>
+          <a:prstGeom prst="rightArrow">
+            <a:avLst/>
+          </a:prstGeom>
+          <a:solidFill>
+            <a:schemeClr val="bg1"/>
+          </a:solidFill>
+          <a:ln>
+            <a:solidFill>
+              <a:schemeClr val="tx2">
+                <a:lumMod val="40000"/>
+                <a:lumOff val="60000"/>
+              </a:schemeClr>
+            </a:solidFill>
+          </a:ln>
+        </p:spPr>
+        <p:style>
+          <a:lnRef idx="2">
+            <a:schemeClr val="accent1">
+              <a:shade val="50000"/>
+            </a:schemeClr>
+          </a:lnRef>
+          <a:fillRef idx="1">
+            <a:schemeClr val="accent1"/>
+          </a:fillRef>
+          <a:effectRef idx="0">
+            <a:schemeClr val="accent1"/>
+          </a:effectRef>
+          <a:fontRef idx="minor">
+            <a:schemeClr val="lt1"/>
+          </a:fontRef>
+        </p:style>
+        <p:txBody>
+          <a:bodyPr rtlCol="0" anchor="ctr"/>
+          <a:lstStyle/>
+          <a:p>
+            <a:pPr algn="ctr"/>
+            <a:endParaRPr lang="en-DE">
+              <a:latin typeface="Arial" panose="020B0604020202020204" pitchFamily="34" charset="0"/>
+              <a:cs typeface="Arial" panose="020B0604020202020204" pitchFamily="34" charset="0"/>
+            </a:endParaRPr>
+          </a:p>
+        </p:txBody>
+      </p:sp>
+      <p:sp>
+        <p:nvSpPr>
+          <p:cNvPr id="21" name="角丸四角形 6">
+            <a:extLst>
+              <a:ext uri="{FF2B5EF4-FFF2-40B4-BE49-F238E27FC236}">
+                <a16:creationId xmlns:a16="http://schemas.microsoft.com/office/drawing/2014/main" id="{FB2A90DC-6C77-EC71-6DB5-BD3632869C43}"/>
+              </a:ext>
+            </a:extLst>
+          </p:cNvPr>
+          <p:cNvSpPr>
+            <a:spLocks/>
+          </p:cNvSpPr>
+          <p:nvPr/>
+        </p:nvSpPr>
+        <p:spPr>
+          <a:xfrm>
+            <a:off x="4927348" y="3320008"/>
+            <a:ext cx="1155305" cy="977868"/>
+          </a:xfrm>
+          <a:prstGeom prst="roundRect">
+            <a:avLst>
+              <a:gd name="adj" fmla="val 0"/>
+            </a:avLst>
+          </a:prstGeom>
+          <a:solidFill>
+            <a:schemeClr val="accent1"/>
+          </a:solidFill>
+          <a:ln w="15875">
+            <a:noFill/>
+          </a:ln>
+        </p:spPr>
+        <p:style>
+          <a:lnRef idx="2">
+            <a:schemeClr val="accent4"/>
+          </a:lnRef>
+          <a:fillRef idx="1">
+            <a:schemeClr val="lt1"/>
+          </a:fillRef>
+          <a:effectRef idx="0">
+            <a:schemeClr val="accent4"/>
+          </a:effectRef>
+          <a:fontRef idx="minor">
+            <a:schemeClr val="dk1"/>
+          </a:fontRef>
+        </p:style>
+        <p:txBody>
+          <a:bodyPr lIns="0" tIns="60960" rIns="0" bIns="60960" rtlCol="0" anchor="ctr" anchorCtr="1"/>
+          <a:lstStyle/>
+          <a:p>
+            <a:pPr marL="0" marR="0" lvl="0" indent="0" algn="ctr" defTabSz="1218804" rtl="0" eaLnBrk="0" fontAlgn="base" latinLnBrk="0" hangingPunct="0">
+              <a:lnSpc>
+                <a:spcPct val="100000"/>
+              </a:lnSpc>
+              <a:spcBef>
+                <a:spcPct val="0"/>
+              </a:spcBef>
+              <a:spcAft>
+                <a:spcPct val="0"/>
+              </a:spcAft>
+              <a:buClrTx/>
+              <a:buSzTx/>
+              <a:buFontTx/>
+              <a:buNone/>
+              <a:tabLst/>
+              <a:defRPr/>
+            </a:pPr>
+            <a:r>
+              <a:rPr kumimoji="1" lang="sv-SE" altLang="ja-JP" sz="1600" dirty="0">
+                <a:solidFill>
+                  <a:srgbClr val="FFFFFF"/>
+                </a:solidFill>
+                <a:latin typeface="Arial" panose="020B0604020202020204" pitchFamily="34" charset="0"/>
+                <a:ea typeface="Lato Light"/>
+                <a:cs typeface="Arial" panose="020B0604020202020204" pitchFamily="34" charset="0"/>
+              </a:rPr>
+              <a:t>Optimized</a:t>
+            </a:r>
+            <a:br>
+              <a:rPr kumimoji="1" lang="sv-SE" altLang="ja-JP" sz="1600" b="0" i="0" u="none" strike="noStrike" kern="1200" cap="none" spc="0" normalizeH="0" baseline="0" noProof="0" dirty="0">
+                <a:ln>
+                  <a:noFill/>
+                </a:ln>
+                <a:solidFill>
+                  <a:srgbClr val="FFFFFF"/>
+                </a:solidFill>
+                <a:effectLst/>
+                <a:uLnTx/>
+                <a:uFillTx/>
+                <a:latin typeface="Arial" panose="020B0604020202020204" pitchFamily="34" charset="0"/>
+                <a:ea typeface="Lato Light"/>
+                <a:cs typeface="Arial" panose="020B0604020202020204" pitchFamily="34" charset="0"/>
+              </a:rPr>
+            </a:br>
+            <a:r>
+              <a:rPr kumimoji="1" lang="sv-SE" altLang="ja-JP" sz="1600" b="0" i="0" u="none" strike="noStrike" kern="1200" cap="none" spc="0" normalizeH="0" baseline="0" noProof="0" dirty="0">
+                <a:ln>
+                  <a:noFill/>
+                </a:ln>
+                <a:solidFill>
+                  <a:srgbClr val="FFFFFF"/>
+                </a:solidFill>
+                <a:effectLst/>
+                <a:uLnTx/>
+                <a:uFillTx/>
+                <a:latin typeface="Arial" panose="020B0604020202020204" pitchFamily="34" charset="0"/>
+                <a:ea typeface="Lato Light"/>
+                <a:cs typeface="Arial" panose="020B0604020202020204" pitchFamily="34" charset="0"/>
+              </a:rPr>
+              <a:t>ML Model</a:t>
+            </a:r>
+            <a:endParaRPr kumimoji="0" lang="sv-SE" altLang="ja-JP" sz="1600" b="0" i="0" u="none" strike="noStrike" kern="1200" cap="none" spc="0" normalizeH="0" baseline="0" noProof="0" dirty="0">
+              <a:ln>
+                <a:noFill/>
+              </a:ln>
+              <a:solidFill>
+                <a:srgbClr val="FFFFFF"/>
+              </a:solidFill>
+              <a:effectLst/>
+              <a:uLnTx/>
+              <a:uFillTx/>
+              <a:latin typeface="Arial" panose="020B0604020202020204" pitchFamily="34" charset="0"/>
+              <a:ea typeface="Lato Light"/>
+              <a:cs typeface="Arial" panose="020B0604020202020204" pitchFamily="34" charset="0"/>
+            </a:endParaRPr>
+          </a:p>
+        </p:txBody>
+      </p:sp>
+      <p:sp>
+        <p:nvSpPr>
+          <p:cNvPr id="22" name="Right Arrow 9">
+            <a:extLst>
+              <a:ext uri="{FF2B5EF4-FFF2-40B4-BE49-F238E27FC236}">
+                <a16:creationId xmlns:a16="http://schemas.microsoft.com/office/drawing/2014/main" id="{CE681839-96C8-ECC2-5DC3-5CE8B441E008}"/>
+              </a:ext>
+            </a:extLst>
+          </p:cNvPr>
+          <p:cNvSpPr>
+            <a:spLocks/>
+          </p:cNvSpPr>
+          <p:nvPr/>
+        </p:nvSpPr>
+        <p:spPr>
+          <a:xfrm>
+            <a:off x="4491963" y="3541052"/>
+            <a:ext cx="435385" cy="535780"/>
+          </a:xfrm>
+          <a:prstGeom prst="rightArrow">
+            <a:avLst/>
+          </a:prstGeom>
+          <a:solidFill>
+            <a:schemeClr val="bg1"/>
+          </a:solidFill>
+          <a:ln>
+            <a:solidFill>
+              <a:schemeClr val="tx2">
+                <a:lumMod val="40000"/>
+                <a:lumOff val="60000"/>
+              </a:schemeClr>
+            </a:solidFill>
+          </a:ln>
+        </p:spPr>
+        <p:style>
+          <a:lnRef idx="2">
+            <a:schemeClr val="accent1">
+              <a:shade val="50000"/>
+            </a:schemeClr>
+          </a:lnRef>
+          <a:fillRef idx="1">
+            <a:schemeClr val="accent1"/>
+          </a:fillRef>
+          <a:effectRef idx="0">
+            <a:schemeClr val="accent1"/>
+          </a:effectRef>
+          <a:fontRef idx="minor">
+            <a:schemeClr val="lt1"/>
+          </a:fontRef>
+        </p:style>
+        <p:txBody>
+          <a:bodyPr rtlCol="0" anchor="ctr"/>
+          <a:lstStyle/>
+          <a:p>
+            <a:pPr algn="ctr"/>
+            <a:endParaRPr lang="en-DE">
+              <a:latin typeface="Arial" panose="020B0604020202020204" pitchFamily="34" charset="0"/>
+              <a:cs typeface="Arial" panose="020B0604020202020204" pitchFamily="34" charset="0"/>
+            </a:endParaRPr>
+          </a:p>
+        </p:txBody>
+      </p:sp>
+      <p:cxnSp>
+        <p:nvCxnSpPr>
+          <p:cNvPr id="25" name="Straight Arrow Connector 24">
+            <a:extLst>
+              <a:ext uri="{FF2B5EF4-FFF2-40B4-BE49-F238E27FC236}">
+                <a16:creationId xmlns:a16="http://schemas.microsoft.com/office/drawing/2014/main" id="{895D14C4-1C67-E8C5-CC30-2A24D101B209}"/>
+              </a:ext>
+            </a:extLst>
+          </p:cNvPr>
+          <p:cNvCxnSpPr>
+            <a:cxnSpLocks/>
+          </p:cNvCxnSpPr>
+          <p:nvPr/>
+        </p:nvCxnSpPr>
+        <p:spPr>
+          <a:xfrm>
+            <a:off x="2652601" y="3078074"/>
+            <a:ext cx="571872" cy="495318"/>
+          </a:xfrm>
+          <a:prstGeom prst="straightConnector1">
+            <a:avLst/>
+          </a:prstGeom>
+          <a:ln w="53975">
+            <a:solidFill>
+              <a:schemeClr val="bg1"/>
+            </a:solidFill>
+            <a:tailEnd type="triangle"/>
+          </a:ln>
+        </p:spPr>
+        <p:style>
+          <a:lnRef idx="1">
+            <a:schemeClr val="accent1"/>
+          </a:lnRef>
+          <a:fillRef idx="0">
+            <a:schemeClr val="accent1"/>
+          </a:fillRef>
+          <a:effectRef idx="0">
+            <a:schemeClr val="accent1"/>
+          </a:effectRef>
+          <a:fontRef idx="minor">
+            <a:schemeClr val="tx1"/>
+          </a:fontRef>
+        </p:style>
+      </p:cxnSp>
+      <p:cxnSp>
+        <p:nvCxnSpPr>
+          <p:cNvPr id="27" name="Straight Arrow Connector 26">
+            <a:extLst>
+              <a:ext uri="{FF2B5EF4-FFF2-40B4-BE49-F238E27FC236}">
+                <a16:creationId xmlns:a16="http://schemas.microsoft.com/office/drawing/2014/main" id="{0BB29EEB-C831-0FCF-B2A9-F37C9067320D}"/>
+              </a:ext>
+            </a:extLst>
+          </p:cNvPr>
+          <p:cNvCxnSpPr>
+            <a:cxnSpLocks/>
+          </p:cNvCxnSpPr>
+          <p:nvPr/>
+        </p:nvCxnSpPr>
+        <p:spPr>
+          <a:xfrm flipV="1">
+            <a:off x="2845826" y="3949959"/>
+            <a:ext cx="386277" cy="412710"/>
+          </a:xfrm>
+          <a:prstGeom prst="straightConnector1">
+            <a:avLst/>
+          </a:prstGeom>
+          <a:ln w="53975">
+            <a:solidFill>
+              <a:schemeClr val="bg1"/>
+            </a:solidFill>
+            <a:tailEnd type="triangle"/>
+          </a:ln>
+        </p:spPr>
+        <p:style>
+          <a:lnRef idx="1">
+            <a:schemeClr val="accent1"/>
+          </a:lnRef>
+          <a:fillRef idx="0">
+            <a:schemeClr val="accent1"/>
+          </a:fillRef>
+          <a:effectRef idx="0">
+            <a:schemeClr val="accent1"/>
+          </a:effectRef>
+          <a:fontRef idx="minor">
+            <a:schemeClr val="tx1"/>
+          </a:fontRef>
+        </p:style>
+      </p:cxnSp>
+      <p:sp>
+        <p:nvSpPr>
+          <p:cNvPr id="9" name="角丸四角形 6">
+            <a:extLst>
+              <a:ext uri="{FF2B5EF4-FFF2-40B4-BE49-F238E27FC236}">
+                <a16:creationId xmlns:a16="http://schemas.microsoft.com/office/drawing/2014/main" id="{82936832-DE0D-BA67-8E68-B672BE7EFE4C}"/>
+              </a:ext>
+            </a:extLst>
+          </p:cNvPr>
+          <p:cNvSpPr>
+            <a:spLocks/>
+          </p:cNvSpPr>
+          <p:nvPr/>
+        </p:nvSpPr>
+        <p:spPr>
+          <a:xfrm>
+            <a:off x="1690521" y="2675403"/>
+            <a:ext cx="1155305" cy="977868"/>
+          </a:xfrm>
+          <a:prstGeom prst="roundRect">
+            <a:avLst>
+              <a:gd name="adj" fmla="val 0"/>
+            </a:avLst>
+          </a:prstGeom>
+          <a:solidFill>
+            <a:schemeClr val="accent1"/>
+          </a:solidFill>
+          <a:ln w="15875">
+            <a:noFill/>
+          </a:ln>
+        </p:spPr>
+        <p:style>
+          <a:lnRef idx="2">
+            <a:schemeClr val="accent4"/>
+          </a:lnRef>
+          <a:fillRef idx="1">
+            <a:schemeClr val="lt1"/>
+          </a:fillRef>
+          <a:effectRef idx="0">
+            <a:schemeClr val="accent4"/>
+          </a:effectRef>
+          <a:fontRef idx="minor">
+            <a:schemeClr val="dk1"/>
+          </a:fontRef>
+        </p:style>
+        <p:txBody>
+          <a:bodyPr lIns="0" tIns="60960" rIns="0" bIns="60960" rtlCol="0" anchor="ctr" anchorCtr="1"/>
+          <a:lstStyle/>
+          <a:p>
+            <a:pPr marL="0" marR="0" lvl="0" indent="0" algn="ctr" defTabSz="1218804" rtl="0" eaLnBrk="0" fontAlgn="base" latinLnBrk="0" hangingPunct="0">
+              <a:lnSpc>
+                <a:spcPct val="100000"/>
+              </a:lnSpc>
+              <a:spcBef>
+                <a:spcPct val="0"/>
+              </a:spcBef>
+              <a:spcAft>
+                <a:spcPct val="0"/>
+              </a:spcAft>
+              <a:buClrTx/>
+              <a:buSzTx/>
+              <a:buFontTx/>
+              <a:buNone/>
+              <a:tabLst/>
+              <a:defRPr/>
+            </a:pPr>
+            <a:r>
+              <a:rPr kumimoji="1" lang="sv-SE" altLang="ja-JP" sz="1600" b="0" i="0" u="none" strike="noStrike" kern="1200" cap="none" spc="0" normalizeH="0" baseline="0" noProof="0" dirty="0">
+                <a:ln>
+                  <a:noFill/>
+                </a:ln>
+                <a:solidFill>
+                  <a:srgbClr val="FFFFFF"/>
+                </a:solidFill>
+                <a:effectLst/>
+                <a:uLnTx/>
+                <a:uFillTx/>
+                <a:latin typeface="Arial" panose="020B0604020202020204" pitchFamily="34" charset="0"/>
+                <a:ea typeface="Lato Light"/>
+                <a:cs typeface="Arial" panose="020B0604020202020204" pitchFamily="34" charset="0"/>
+              </a:rPr>
+              <a:t>Quantized</a:t>
+            </a:r>
+            <a:br>
+              <a:rPr kumimoji="1" lang="sv-SE" altLang="ja-JP" sz="1600" b="0" i="0" u="none" strike="noStrike" kern="1200" cap="none" spc="0" normalizeH="0" baseline="0" noProof="0" dirty="0">
+                <a:ln>
+                  <a:noFill/>
+                </a:ln>
+                <a:solidFill>
+                  <a:srgbClr val="FFFFFF"/>
+                </a:solidFill>
+                <a:effectLst/>
+                <a:uLnTx/>
+                <a:uFillTx/>
+                <a:latin typeface="Arial" panose="020B0604020202020204" pitchFamily="34" charset="0"/>
+                <a:ea typeface="Lato Light"/>
+                <a:cs typeface="Arial" panose="020B0604020202020204" pitchFamily="34" charset="0"/>
+              </a:rPr>
+            </a:br>
+            <a:r>
+              <a:rPr kumimoji="1" lang="sv-SE" altLang="ja-JP" sz="1600" b="0" i="0" u="none" strike="noStrike" kern="1200" cap="none" spc="0" normalizeH="0" baseline="0" noProof="0" dirty="0">
+                <a:ln>
+                  <a:noFill/>
+                </a:ln>
+                <a:solidFill>
+                  <a:srgbClr val="FFFFFF"/>
+                </a:solidFill>
+                <a:effectLst/>
+                <a:uLnTx/>
+                <a:uFillTx/>
+                <a:latin typeface="Arial" panose="020B0604020202020204" pitchFamily="34" charset="0"/>
+                <a:ea typeface="Lato Light"/>
+                <a:cs typeface="Arial" panose="020B0604020202020204" pitchFamily="34" charset="0"/>
+              </a:rPr>
+              <a:t>ML Model</a:t>
+            </a:r>
+            <a:endParaRPr kumimoji="0" lang="sv-SE" altLang="ja-JP" sz="1600" b="0" i="0" u="none" strike="noStrike" kern="1200" cap="none" spc="0" normalizeH="0" baseline="0" noProof="0" dirty="0">
+              <a:ln>
+                <a:noFill/>
+              </a:ln>
+              <a:solidFill>
+                <a:srgbClr val="FFFFFF"/>
+              </a:solidFill>
+              <a:effectLst/>
+              <a:uLnTx/>
+              <a:uFillTx/>
+              <a:latin typeface="Arial" panose="020B0604020202020204" pitchFamily="34" charset="0"/>
+              <a:ea typeface="Lato Light"/>
+              <a:cs typeface="Arial" panose="020B0604020202020204" pitchFamily="34" charset="0"/>
+            </a:endParaRPr>
+          </a:p>
+        </p:txBody>
+      </p:sp>
+      <p:sp>
+        <p:nvSpPr>
+          <p:cNvPr id="23" name="角丸四角形 6">
+            <a:extLst>
+              <a:ext uri="{FF2B5EF4-FFF2-40B4-BE49-F238E27FC236}">
+                <a16:creationId xmlns:a16="http://schemas.microsoft.com/office/drawing/2014/main" id="{47935825-0EE0-9F16-CBB9-78D6714F99C6}"/>
+              </a:ext>
+            </a:extLst>
+          </p:cNvPr>
+          <p:cNvSpPr>
+            <a:spLocks/>
+          </p:cNvSpPr>
+          <p:nvPr/>
+        </p:nvSpPr>
+        <p:spPr>
+          <a:xfrm>
+            <a:off x="1575379" y="3844693"/>
+            <a:ext cx="1385590" cy="1242000"/>
+          </a:xfrm>
+          <a:prstGeom prst="roundRect">
+            <a:avLst>
+              <a:gd name="adj" fmla="val 0"/>
+            </a:avLst>
+          </a:prstGeom>
+          <a:solidFill>
+            <a:schemeClr val="tx2"/>
+          </a:solidFill>
+          <a:ln w="15875">
+            <a:solidFill>
+              <a:srgbClr val="00C1DE"/>
+            </a:solidFill>
+          </a:ln>
+        </p:spPr>
+        <p:style>
+          <a:lnRef idx="2">
+            <a:schemeClr val="accent1">
+              <a:shade val="50000"/>
+            </a:schemeClr>
+          </a:lnRef>
+          <a:fillRef idx="1">
+            <a:schemeClr val="accent1"/>
+          </a:fillRef>
+          <a:effectRef idx="0">
+            <a:schemeClr val="accent1"/>
+          </a:effectRef>
+          <a:fontRef idx="minor">
+            <a:schemeClr val="lt1"/>
+          </a:fontRef>
+        </p:style>
+        <p:txBody>
+          <a:bodyPr rtlCol="0" anchor="ctr"/>
+          <a:lstStyle/>
+          <a:p>
+            <a:pPr algn="ctr" defTabSz="1219170"/>
+            <a:r>
+              <a:rPr lang="en-US" sz="1600" dirty="0"/>
+              <a:t>Ethos-U target system &amp; memory description</a:t>
+            </a:r>
+            <a:endParaRPr kumimoji="1" lang="sv-SE" altLang="ja-JP" sz="1400" dirty="0">
+              <a:solidFill>
+                <a:srgbClr val="FFFFFF"/>
+              </a:solidFill>
+              <a:latin typeface="Arial" panose="020B0604020202020204" pitchFamily="34" charset="0"/>
+              <a:cs typeface="Arial" panose="020B0604020202020204" pitchFamily="34" charset="0"/>
+            </a:endParaRPr>
+          </a:p>
+        </p:txBody>
+      </p:sp>
+    </p:spTree>
+    <p:extLst>
+      <p:ext uri="{BB962C8B-B14F-4D97-AF65-F5344CB8AC3E}">
+        <p14:creationId xmlns:p14="http://schemas.microsoft.com/office/powerpoint/2010/main" val="3449616423"/>
+      </p:ext>
+    </p:extLst>
+  </p:cSld>
+  <p:clrMapOvr>
+    <a:masterClrMapping/>
+  </p:clrMapOvr>
+</p:sld>
+</file>
+
+<file path=ppt/slides/slide3.xml><?xml version="1.0" encoding="utf-8"?>
+<p:sld xmlns:a="http://schemas.openxmlformats.org/drawingml/2006/main" xmlns:r="http://schemas.openxmlformats.org/officeDocument/2006/relationships" xmlns:p="http://schemas.openxmlformats.org/presentationml/2006/main">
+  <p:cSld>
+    <p:spTree>
+      <p:nvGrpSpPr>
+        <p:cNvPr id="1" name=""/>
+        <p:cNvGrpSpPr/>
+        <p:nvPr/>
+      </p:nvGrpSpPr>
+      <p:grpSpPr>
+        <a:xfrm>
+          <a:off x="0" y="0"/>
+          <a:ext cx="0" cy="0"/>
+          <a:chOff x="0" y="0"/>
+          <a:chExt cx="0" cy="0"/>
+        </a:xfrm>
+      </p:grpSpPr>
+      <p:sp>
+        <p:nvSpPr>
+          <p:cNvPr id="2" name="Title 1">
+            <a:extLst>
+              <a:ext uri="{FF2B5EF4-FFF2-40B4-BE49-F238E27FC236}">
+                <a16:creationId xmlns:a16="http://schemas.microsoft.com/office/drawing/2014/main" id="{CEEF4016-9082-286D-629A-6EC1004915CD}"/>
+              </a:ext>
+            </a:extLst>
+          </p:cNvPr>
+          <p:cNvSpPr>
+            <a:spLocks noGrp="1"/>
+          </p:cNvSpPr>
+          <p:nvPr>
+            <p:ph type="title"/>
+          </p:nvPr>
+        </p:nvSpPr>
+        <p:spPr/>
+        <p:txBody>
+          <a:bodyPr/>
+          <a:lstStyle/>
+          <a:p>
+            <a:endParaRPr lang="en-US"/>
+          </a:p>
+        </p:txBody>
+      </p:sp>
+      <p:sp>
+        <p:nvSpPr>
+          <p:cNvPr id="3" name="Text Placeholder 2">
+            <a:extLst>
+              <a:ext uri="{FF2B5EF4-FFF2-40B4-BE49-F238E27FC236}">
+                <a16:creationId xmlns:a16="http://schemas.microsoft.com/office/drawing/2014/main" id="{DC07EB29-3B33-4E20-229D-ECA79F3BEA79}"/>
+              </a:ext>
+            </a:extLst>
+          </p:cNvPr>
+          <p:cNvSpPr>
+            <a:spLocks noGrp="1"/>
+          </p:cNvSpPr>
+          <p:nvPr>
+            <p:ph type="body" sz="quarter" idx="13"/>
+          </p:nvPr>
+        </p:nvSpPr>
+        <p:spPr/>
+        <p:txBody>
+          <a:bodyPr/>
+          <a:lstStyle/>
+          <a:p>
+            <a:endParaRPr lang="en-US"/>
+          </a:p>
+        </p:txBody>
+      </p:sp>
+      <p:sp>
+        <p:nvSpPr>
+          <p:cNvPr id="4" name="Content Placeholder 3">
+            <a:extLst>
+              <a:ext uri="{FF2B5EF4-FFF2-40B4-BE49-F238E27FC236}">
+                <a16:creationId xmlns:a16="http://schemas.microsoft.com/office/drawing/2014/main" id="{FC77706E-165A-E28E-6340-97057BBBCBB0}"/>
+              </a:ext>
+            </a:extLst>
+          </p:cNvPr>
+          <p:cNvSpPr>
+            <a:spLocks noGrp="1"/>
+          </p:cNvSpPr>
+          <p:nvPr>
+            <p:ph idx="1"/>
+          </p:nvPr>
+        </p:nvSpPr>
+        <p:spPr/>
+        <p:txBody>
+          <a:bodyPr/>
+          <a:lstStyle/>
+          <a:p>
+            <a:endParaRPr lang="en-US"/>
+          </a:p>
+        </p:txBody>
+      </p:sp>
+    </p:spTree>
+    <p:extLst>
+      <p:ext uri="{BB962C8B-B14F-4D97-AF65-F5344CB8AC3E}">
+        <p14:creationId xmlns:p14="http://schemas.microsoft.com/office/powerpoint/2010/main" val="405019737"/>
       </p:ext>
     </p:extLst>
   </p:cSld>

</xml_diff>

<commit_message>
Aligned documentation+example, new Ethos-U driver
</commit_message>
<xml_diff>
--- a/documentation/doxygen/general/src/images/overview.pptx
+++ b/documentation/doxygen/general/src/images/overview.pptx
@@ -5,15 +5,16 @@
     <p:sldMasterId id="2147483661" r:id="rId1"/>
   </p:sldMasterIdLst>
   <p:notesMasterIdLst>
-    <p:notesMasterId r:id="rId5"/>
+    <p:notesMasterId r:id="rId6"/>
   </p:notesMasterIdLst>
   <p:handoutMasterIdLst>
-    <p:handoutMasterId r:id="rId6"/>
+    <p:handoutMasterId r:id="rId7"/>
   </p:handoutMasterIdLst>
   <p:sldIdLst>
     <p:sldId id="548" r:id="rId2"/>
     <p:sldId id="2147479562" r:id="rId3"/>
     <p:sldId id="549" r:id="rId4"/>
+    <p:sldId id="2147479563" r:id="rId5"/>
   </p:sldIdLst>
   <p:sldSz cx="12192000" cy="6858000"/>
   <p:notesSz cx="6858000" cy="9144000"/>
@@ -261,7 +262,7 @@
           <a:p>
             <a:fld id="{008FFADC-39A7-449E-8C68-8776E6FB3C1A}" type="datetimeFigureOut">
               <a:rPr lang="en-GB" smtClean="0"/>
-              <a:t>07/08/2026</a:t>
+              <a:t>17/08/2026</a:t>
             </a:fld>
             <a:endParaRPr lang="en-GB"/>
           </a:p>
@@ -438,7 +439,7 @@
           <a:p>
             <a:fld id="{30B9BAAB-B703-4BB5-9D08-B460FC03C23A}" type="datetimeFigureOut">
               <a:rPr lang="en-GB" smtClean="0"/>
-              <a:t>07/08/2026</a:t>
+              <a:t>17/08/2026</a:t>
             </a:fld>
             <a:endParaRPr lang="en-GB"/>
           </a:p>
@@ -814,6 +815,147 @@
     <p:extLst>
       <p:ext uri="{BB962C8B-B14F-4D97-AF65-F5344CB8AC3E}">
         <p14:creationId xmlns:p14="http://schemas.microsoft.com/office/powerpoint/2010/main" val="1343268853"/>
+      </p:ext>
+    </p:extLst>
+  </p:cSld>
+  <p:clrMapOvr>
+    <a:masterClrMapping/>
+  </p:clrMapOvr>
+</p:notes>
+</file>
+
+<file path=ppt/notesSlides/notesSlide2.xml><?xml version="1.0" encoding="utf-8"?>
+<p:notes xmlns:a="http://schemas.openxmlformats.org/drawingml/2006/main" xmlns:r="http://schemas.openxmlformats.org/officeDocument/2006/relationships" xmlns:p="http://schemas.openxmlformats.org/presentationml/2006/main">
+  <p:cSld>
+    <p:spTree>
+      <p:nvGrpSpPr>
+        <p:cNvPr id="1" name="">
+          <a:extLst>
+            <a:ext uri="{FF2B5EF4-FFF2-40B4-BE49-F238E27FC236}">
+              <a16:creationId xmlns:a16="http://schemas.microsoft.com/office/drawing/2014/main" id="{E183BBA8-B3E4-715D-038D-7794E3BDE00A}"/>
+            </a:ext>
+          </a:extLst>
+        </p:cNvPr>
+        <p:cNvGrpSpPr/>
+        <p:nvPr/>
+      </p:nvGrpSpPr>
+      <p:grpSpPr>
+        <a:xfrm>
+          <a:off x="0" y="0"/>
+          <a:ext cx="0" cy="0"/>
+          <a:chOff x="0" y="0"/>
+          <a:chExt cx="0" cy="0"/>
+        </a:xfrm>
+      </p:grpSpPr>
+      <p:sp>
+        <p:nvSpPr>
+          <p:cNvPr id="2" name="Slide Image Placeholder 1">
+            <a:extLst>
+              <a:ext uri="{FF2B5EF4-FFF2-40B4-BE49-F238E27FC236}">
+                <a16:creationId xmlns:a16="http://schemas.microsoft.com/office/drawing/2014/main" id="{4711F47A-60A6-7834-DB1E-7298B192A56D}"/>
+              </a:ext>
+            </a:extLst>
+          </p:cNvPr>
+          <p:cNvSpPr>
+            <a:spLocks noGrp="1" noRot="1" noChangeAspect="1"/>
+          </p:cNvSpPr>
+          <p:nvPr>
+            <p:ph type="sldImg"/>
+          </p:nvPr>
+        </p:nvSpPr>
+        <p:spPr/>
+        <p:txBody>
+          <a:bodyPr/>
+          <a:lstStyle/>
+          <a:p>
+            <a:endParaRPr lang="en-US"/>
+          </a:p>
+        </p:txBody>
+      </p:sp>
+      <p:sp>
+        <p:nvSpPr>
+          <p:cNvPr id="3" name="Notes Placeholder 2">
+            <a:extLst>
+              <a:ext uri="{FF2B5EF4-FFF2-40B4-BE49-F238E27FC236}">
+                <a16:creationId xmlns:a16="http://schemas.microsoft.com/office/drawing/2014/main" id="{0E2FF2B3-6720-ED98-3C26-D3EF19EC894E}"/>
+              </a:ext>
+            </a:extLst>
+          </p:cNvPr>
+          <p:cNvSpPr>
+            <a:spLocks noGrp="1"/>
+          </p:cNvSpPr>
+          <p:nvPr>
+            <p:ph type="body" idx="1"/>
+          </p:nvPr>
+        </p:nvSpPr>
+        <p:spPr/>
+        <p:txBody>
+          <a:bodyPr/>
+          <a:lstStyle/>
+          <a:p>
+            <a:r>
+              <a:rPr lang="en-US" dirty="0"/>
+              <a:t>ML models from ecosystem partners or open-source model zoos such as Hugging Face are quantized and optimized for embedded deployment. CMSIS-NN executes these optimized models on Cortex-M processors. For Ethos-U NPU targets, Vela converts model operations for NPU acceleration, while operations that cannot be converted continue to run on Cortex-M via CMSIS-NN.</a:t>
+            </a:r>
+          </a:p>
+          <a:p>
+            <a:endParaRPr lang="en-US" dirty="0"/>
+          </a:p>
+          <a:p>
+            <a:r>
+              <a:rPr lang="en-US" dirty="0"/>
+              <a:t>Using these workflows, developers can deploy trained models from </a:t>
+            </a:r>
+            <a:r>
+              <a:rPr lang="en-US" dirty="0" err="1"/>
+              <a:t>PyTorch</a:t>
+            </a:r>
+            <a:r>
+              <a:rPr lang="en-US" dirty="0"/>
+              <a:t>, TensorFlow, and other frameworks onto Arm targets with optimal performance and energy efficiency, enabling intelligent capabilities in IoT devices, wearables, industrial sensors, and other edge computing applications.</a:t>
+            </a:r>
+          </a:p>
+        </p:txBody>
+      </p:sp>
+      <p:sp>
+        <p:nvSpPr>
+          <p:cNvPr id="4" name="Slide Number Placeholder 3">
+            <a:extLst>
+              <a:ext uri="{FF2B5EF4-FFF2-40B4-BE49-F238E27FC236}">
+                <a16:creationId xmlns:a16="http://schemas.microsoft.com/office/drawing/2014/main" id="{B59038E3-3EF6-3220-097E-2BA6573C930E}"/>
+              </a:ext>
+            </a:extLst>
+          </p:cNvPr>
+          <p:cNvSpPr>
+            <a:spLocks noGrp="1"/>
+          </p:cNvSpPr>
+          <p:nvPr>
+            <p:ph type="sldNum" sz="quarter" idx="5"/>
+          </p:nvPr>
+        </p:nvSpPr>
+        <p:spPr/>
+        <p:txBody>
+          <a:bodyPr/>
+          <a:lstStyle/>
+          <a:p>
+            <a:pPr>
+              <a:defRPr/>
+            </a:pPr>
+            <a:fld id="{3B16354E-6974-4833-AB87-3220A0835E84}" type="slidenum">
+              <a:rPr lang="en-US" altLang="en-US" smtClean="0"/>
+              <a:pPr>
+                <a:defRPr/>
+              </a:pPr>
+              <a:t>4</a:t>
+            </a:fld>
+            <a:endParaRPr lang="en-US" altLang="en-US"/>
+          </a:p>
+        </p:txBody>
+      </p:sp>
+    </p:spTree>
+    <p:extLst>
+      <p:ext uri="{BB962C8B-B14F-4D97-AF65-F5344CB8AC3E}">
+        <p14:creationId xmlns:p14="http://schemas.microsoft.com/office/powerpoint/2010/main" val="2358853907"/>
       </p:ext>
     </p:extLst>
   </p:cSld>
@@ -10509,6 +10651,2014 @@
     <p:extLst>
       <p:ext uri="{BB962C8B-B14F-4D97-AF65-F5344CB8AC3E}">
         <p14:creationId xmlns:p14="http://schemas.microsoft.com/office/powerpoint/2010/main" val="405019737"/>
+      </p:ext>
+    </p:extLst>
+  </p:cSld>
+  <p:clrMapOvr>
+    <a:masterClrMapping/>
+  </p:clrMapOvr>
+</p:sld>
+</file>
+
+<file path=ppt/slides/slide4.xml><?xml version="1.0" encoding="utf-8"?>
+<p:sld xmlns:a="http://schemas.openxmlformats.org/drawingml/2006/main" xmlns:r="http://schemas.openxmlformats.org/officeDocument/2006/relationships" xmlns:p="http://schemas.openxmlformats.org/presentationml/2006/main">
+  <p:cSld>
+    <p:spTree>
+      <p:nvGrpSpPr>
+        <p:cNvPr id="1" name="">
+          <a:extLst>
+            <a:ext uri="{FF2B5EF4-FFF2-40B4-BE49-F238E27FC236}">
+              <a16:creationId xmlns:a16="http://schemas.microsoft.com/office/drawing/2014/main" id="{21F35EA9-9DA8-055C-3DD8-B2078FF02732}"/>
+            </a:ext>
+          </a:extLst>
+        </p:cNvPr>
+        <p:cNvGrpSpPr/>
+        <p:nvPr/>
+      </p:nvGrpSpPr>
+      <p:grpSpPr>
+        <a:xfrm>
+          <a:off x="0" y="0"/>
+          <a:ext cx="0" cy="0"/>
+          <a:chOff x="0" y="0"/>
+          <a:chExt cx="0" cy="0"/>
+        </a:xfrm>
+      </p:grpSpPr>
+      <p:sp>
+        <p:nvSpPr>
+          <p:cNvPr id="2" name="Title 1">
+            <a:extLst>
+              <a:ext uri="{FF2B5EF4-FFF2-40B4-BE49-F238E27FC236}">
+                <a16:creationId xmlns:a16="http://schemas.microsoft.com/office/drawing/2014/main" id="{10CE91E9-F49C-F2B4-1591-00C1CE9D8807}"/>
+              </a:ext>
+            </a:extLst>
+          </p:cNvPr>
+          <p:cNvSpPr>
+            <a:spLocks noGrp="1"/>
+          </p:cNvSpPr>
+          <p:nvPr>
+            <p:ph type="title"/>
+          </p:nvPr>
+        </p:nvSpPr>
+        <p:spPr/>
+        <p:txBody>
+          <a:bodyPr/>
+          <a:lstStyle/>
+          <a:p>
+            <a:r>
+              <a:rPr lang="en-US"/>
+              <a:t>Ethos-U Optimized Software Flow for </a:t>
+            </a:r>
+            <a:r>
+              <a:rPr lang="en-US" err="1"/>
+              <a:t>Tensorflow</a:t>
+            </a:r>
+            <a:r>
+              <a:rPr lang="en-US"/>
+              <a:t>/</a:t>
+            </a:r>
+            <a:r>
+              <a:rPr lang="en-US" err="1"/>
+              <a:t>PyTorch</a:t>
+            </a:r>
+            <a:endParaRPr lang="en-US"/>
+          </a:p>
+        </p:txBody>
+      </p:sp>
+      <p:sp>
+        <p:nvSpPr>
+          <p:cNvPr id="29" name="Text Placeholder 28">
+            <a:extLst>
+              <a:ext uri="{FF2B5EF4-FFF2-40B4-BE49-F238E27FC236}">
+                <a16:creationId xmlns:a16="http://schemas.microsoft.com/office/drawing/2014/main" id="{BF9C00EE-D2D0-725F-1CDE-43F90D3891FB}"/>
+              </a:ext>
+            </a:extLst>
+          </p:cNvPr>
+          <p:cNvSpPr>
+            <a:spLocks noGrp="1"/>
+          </p:cNvSpPr>
+          <p:nvPr>
+            <p:ph type="body" sz="quarter" idx="13"/>
+          </p:nvPr>
+        </p:nvSpPr>
+        <p:spPr/>
+        <p:txBody>
+          <a:bodyPr/>
+          <a:lstStyle/>
+          <a:p>
+            <a:r>
+              <a:rPr lang="en-US">
+                <a:hlinkClick r:id="rId3"/>
+              </a:rPr>
+              <a:t>github.com/Arm-Examples#edge-ai-and-machine-learning</a:t>
+            </a:r>
+            <a:endParaRPr lang="en-US"/>
+          </a:p>
+        </p:txBody>
+      </p:sp>
+      <p:grpSp>
+        <p:nvGrpSpPr>
+          <p:cNvPr id="47" name="Group 46">
+            <a:extLst>
+              <a:ext uri="{FF2B5EF4-FFF2-40B4-BE49-F238E27FC236}">
+                <a16:creationId xmlns:a16="http://schemas.microsoft.com/office/drawing/2014/main" id="{7FDEBA3B-14B2-3A05-B96E-C0A02F5B034C}"/>
+              </a:ext>
+            </a:extLst>
+          </p:cNvPr>
+          <p:cNvGrpSpPr/>
+          <p:nvPr/>
+        </p:nvGrpSpPr>
+        <p:grpSpPr>
+          <a:xfrm>
+            <a:off x="835176" y="2094471"/>
+            <a:ext cx="10585491" cy="3037366"/>
+            <a:chOff x="835176" y="2094471"/>
+            <a:chExt cx="10585491" cy="3037366"/>
+          </a:xfrm>
+        </p:grpSpPr>
+        <p:sp>
+          <p:nvSpPr>
+            <p:cNvPr id="11" name="Process 65">
+              <a:extLst>
+                <a:ext uri="{FF2B5EF4-FFF2-40B4-BE49-F238E27FC236}">
+                  <a16:creationId xmlns:a16="http://schemas.microsoft.com/office/drawing/2014/main" id="{18502500-A3A2-ABB6-075E-8DAE582BF83D}"/>
+                </a:ext>
+              </a:extLst>
+            </p:cNvPr>
+            <p:cNvSpPr>
+              <a:spLocks/>
+            </p:cNvSpPr>
+            <p:nvPr/>
+          </p:nvSpPr>
+          <p:spPr>
+            <a:xfrm>
+              <a:off x="6282610" y="2094471"/>
+              <a:ext cx="5138057" cy="3037366"/>
+            </a:xfrm>
+            <a:prstGeom prst="flowChartProcess">
+              <a:avLst/>
+            </a:prstGeom>
+            <a:solidFill>
+              <a:schemeClr val="bg2">
+                <a:lumMod val="50000"/>
+              </a:schemeClr>
+            </a:solidFill>
+            <a:ln w="0">
+              <a:solidFill>
+                <a:schemeClr val="bg1"/>
+              </a:solidFill>
+            </a:ln>
+          </p:spPr>
+          <p:style>
+            <a:lnRef idx="2">
+              <a:schemeClr val="accent1">
+                <a:shade val="50000"/>
+              </a:schemeClr>
+            </a:lnRef>
+            <a:fillRef idx="1">
+              <a:schemeClr val="accent1"/>
+            </a:fillRef>
+            <a:effectRef idx="0">
+              <a:schemeClr val="accent1"/>
+            </a:effectRef>
+            <a:fontRef idx="minor">
+              <a:schemeClr val="lt1"/>
+            </a:fontRef>
+          </p:style>
+          <p:txBody>
+            <a:bodyPr tIns="108000" rtlCol="0" anchor="t"/>
+            <a:lstStyle/>
+            <a:p>
+              <a:pPr defTabSz="1219170">
+                <a:defRPr/>
+              </a:pPr>
+              <a:r>
+                <a:rPr kumimoji="1" lang="en-US" sz="1600" dirty="0">
+                  <a:solidFill>
+                    <a:srgbClr val="FFFFFF"/>
+                  </a:solidFill>
+                  <a:latin typeface="Arial" panose="020B0604020202020204" pitchFamily="34" charset="0"/>
+                  <a:cs typeface="Arial" panose="020B0604020202020204" pitchFamily="34" charset="0"/>
+                </a:rPr>
+                <a:t>DEVICE with Ethos-U</a:t>
+              </a:r>
+            </a:p>
+          </p:txBody>
+        </p:sp>
+        <p:sp>
+          <p:nvSpPr>
+            <p:cNvPr id="14" name="角丸四角形 7">
+              <a:extLst>
+                <a:ext uri="{FF2B5EF4-FFF2-40B4-BE49-F238E27FC236}">
+                  <a16:creationId xmlns:a16="http://schemas.microsoft.com/office/drawing/2014/main" id="{BD4B5930-02E4-A9A3-78CE-0A29FC84E13B}"/>
+                </a:ext>
+              </a:extLst>
+            </p:cNvPr>
+            <p:cNvSpPr>
+              <a:spLocks/>
+            </p:cNvSpPr>
+            <p:nvPr/>
+          </p:nvSpPr>
+          <p:spPr>
+            <a:xfrm>
+              <a:off x="8616018" y="2576367"/>
+              <a:ext cx="1169871" cy="1007207"/>
+            </a:xfrm>
+            <a:prstGeom prst="roundRect">
+              <a:avLst>
+                <a:gd name="adj" fmla="val 0"/>
+              </a:avLst>
+            </a:prstGeom>
+            <a:solidFill>
+              <a:schemeClr val="accent1"/>
+            </a:solidFill>
+            <a:ln>
+              <a:noFill/>
+            </a:ln>
+          </p:spPr>
+          <p:style>
+            <a:lnRef idx="0">
+              <a:scrgbClr r="0" g="0" b="0"/>
+            </a:lnRef>
+            <a:fillRef idx="0">
+              <a:scrgbClr r="0" g="0" b="0"/>
+            </a:fillRef>
+            <a:effectRef idx="0">
+              <a:scrgbClr r="0" g="0" b="0"/>
+            </a:effectRef>
+            <a:fontRef idx="minor">
+              <a:schemeClr val="lt1"/>
+            </a:fontRef>
+          </p:style>
+          <p:txBody>
+            <a:bodyPr lIns="0" rIns="0" rtlCol="0" anchor="ctr" anchorCtr="1"/>
+            <a:lstStyle/>
+            <a:p>
+              <a:pPr marL="0" marR="0" lvl="0" indent="0" algn="ctr" defTabSz="1218804" rtl="0" eaLnBrk="0" fontAlgn="base" latinLnBrk="0" hangingPunct="0">
+                <a:lnSpc>
+                  <a:spcPct val="100000"/>
+                </a:lnSpc>
+                <a:spcBef>
+                  <a:spcPct val="0"/>
+                </a:spcBef>
+                <a:spcAft>
+                  <a:spcPct val="0"/>
+                </a:spcAft>
+                <a:buClrTx/>
+                <a:buSzTx/>
+                <a:buFontTx/>
+                <a:buNone/>
+                <a:tabLst/>
+                <a:defRPr/>
+              </a:pPr>
+              <a:r>
+                <a:rPr kumimoji="1" lang="sv-SE" altLang="ja-JP" sz="1600" b="0" i="0" strike="noStrike" kern="1200" cap="none" spc="0" normalizeH="0" baseline="0" noProof="0" dirty="0">
+                  <a:ln>
+                    <a:noFill/>
+                  </a:ln>
+                  <a:solidFill>
+                    <a:prstClr val="white"/>
+                  </a:solidFill>
+                  <a:effectLst/>
+                  <a:uLnTx/>
+                  <a:uFillTx/>
+                  <a:latin typeface="Arial" panose="020B0604020202020204" pitchFamily="34" charset="0"/>
+                  <a:ea typeface="Lato Light" panose="020F0502020204030203" pitchFamily="34" charset="0"/>
+                  <a:cs typeface="Arial" panose="020B0604020202020204" pitchFamily="34" charset="0"/>
+                </a:rPr>
+                <a:t>CMSIS-NN</a:t>
+              </a:r>
+              <a:endParaRPr kumimoji="0" lang="en-US" sz="1600" b="0" i="0" strike="noStrike" kern="1200" cap="none" spc="0" normalizeH="0" baseline="0" noProof="0" dirty="0">
+                <a:ln>
+                  <a:noFill/>
+                </a:ln>
+                <a:solidFill>
+                  <a:prstClr val="white"/>
+                </a:solidFill>
+                <a:effectLst/>
+                <a:uLnTx/>
+                <a:uFillTx/>
+                <a:latin typeface="Arial" panose="020B0604020202020204" pitchFamily="34" charset="0"/>
+                <a:ea typeface="Lato Light" panose="020F0502020204030203" pitchFamily="34" charset="0"/>
+                <a:cs typeface="Arial" panose="020B0604020202020204" pitchFamily="34" charset="0"/>
+              </a:endParaRPr>
+            </a:p>
+            <a:p>
+              <a:pPr marL="0" marR="0" lvl="0" indent="0" algn="ctr" defTabSz="1218804" rtl="0" eaLnBrk="0" fontAlgn="base" latinLnBrk="0" hangingPunct="0">
+                <a:lnSpc>
+                  <a:spcPct val="100000"/>
+                </a:lnSpc>
+                <a:spcBef>
+                  <a:spcPct val="0"/>
+                </a:spcBef>
+                <a:spcAft>
+                  <a:spcPct val="0"/>
+                </a:spcAft>
+                <a:buClrTx/>
+                <a:buSzTx/>
+                <a:buFontTx/>
+                <a:buNone/>
+                <a:tabLst/>
+                <a:defRPr/>
+              </a:pPr>
+              <a:r>
+                <a:rPr kumimoji="1" lang="sv-SE" altLang="ja-JP" sz="1600" b="0" i="0" strike="noStrike" kern="1200" cap="none" spc="0" normalizeH="0" baseline="0" noProof="0" dirty="0">
+                  <a:ln>
+                    <a:noFill/>
+                  </a:ln>
+                  <a:solidFill>
+                    <a:prstClr val="white"/>
+                  </a:solidFill>
+                  <a:effectLst/>
+                  <a:uLnTx/>
+                  <a:uFillTx/>
+                  <a:latin typeface="Arial" panose="020B0604020202020204" pitchFamily="34" charset="0"/>
+                  <a:ea typeface="Lato Light" panose="020F0502020204030203" pitchFamily="34" charset="0"/>
+                  <a:cs typeface="Arial" panose="020B0604020202020204" pitchFamily="34" charset="0"/>
+                </a:rPr>
+                <a:t>Optimized Kernels</a:t>
+              </a:r>
+              <a:endParaRPr kumimoji="0" lang="en-US" altLang="ja-JP" sz="1600" b="0" i="0" strike="noStrike" kern="1200" cap="none" spc="0" normalizeH="0" baseline="0" noProof="0" dirty="0">
+                <a:ln>
+                  <a:noFill/>
+                </a:ln>
+                <a:solidFill>
+                  <a:prstClr val="white"/>
+                </a:solidFill>
+                <a:effectLst/>
+                <a:uLnTx/>
+                <a:uFillTx/>
+                <a:latin typeface="Arial" panose="020B0604020202020204" pitchFamily="34" charset="0"/>
+                <a:ea typeface="Lato Light" panose="020F0502020204030203" pitchFamily="34" charset="0"/>
+                <a:cs typeface="Arial" panose="020B0604020202020204" pitchFamily="34" charset="0"/>
+              </a:endParaRPr>
+            </a:p>
+          </p:txBody>
+        </p:sp>
+        <p:sp>
+          <p:nvSpPr>
+            <p:cNvPr id="15" name="Rectangle 14">
+              <a:extLst>
+                <a:ext uri="{FF2B5EF4-FFF2-40B4-BE49-F238E27FC236}">
+                  <a16:creationId xmlns:a16="http://schemas.microsoft.com/office/drawing/2014/main" id="{DC3469AD-C44F-E151-C9AA-AEE3D48D6FCA}"/>
+                </a:ext>
+              </a:extLst>
+            </p:cNvPr>
+            <p:cNvSpPr>
+              <a:spLocks/>
+            </p:cNvSpPr>
+            <p:nvPr/>
+          </p:nvSpPr>
+          <p:spPr>
+            <a:xfrm>
+              <a:off x="10110645" y="2582562"/>
+              <a:ext cx="1169871" cy="991024"/>
+            </a:xfrm>
+            <a:prstGeom prst="rect">
+              <a:avLst/>
+            </a:prstGeom>
+            <a:solidFill>
+              <a:schemeClr val="accent1"/>
+            </a:solidFill>
+            <a:ln>
+              <a:noFill/>
+            </a:ln>
+          </p:spPr>
+          <p:style>
+            <a:lnRef idx="0">
+              <a:scrgbClr r="0" g="0" b="0"/>
+            </a:lnRef>
+            <a:fillRef idx="0">
+              <a:scrgbClr r="0" g="0" b="0"/>
+            </a:fillRef>
+            <a:effectRef idx="0">
+              <a:scrgbClr r="0" g="0" b="0"/>
+            </a:effectRef>
+            <a:fontRef idx="minor">
+              <a:schemeClr val="lt1"/>
+            </a:fontRef>
+          </p:style>
+          <p:txBody>
+            <a:bodyPr rtlCol="0" anchor="ctr"/>
+            <a:lstStyle/>
+            <a:p>
+              <a:pPr marL="0" marR="0" lvl="0" indent="0" algn="ctr" defTabSz="1218804" rtl="0" eaLnBrk="0" fontAlgn="base" latinLnBrk="0" hangingPunct="0">
+                <a:lnSpc>
+                  <a:spcPct val="100000"/>
+                </a:lnSpc>
+                <a:spcBef>
+                  <a:spcPct val="0"/>
+                </a:spcBef>
+                <a:spcAft>
+                  <a:spcPct val="0"/>
+                </a:spcAft>
+                <a:buClrTx/>
+                <a:buSzTx/>
+                <a:buFontTx/>
+                <a:buNone/>
+                <a:tabLst/>
+                <a:defRPr/>
+              </a:pPr>
+              <a:r>
+                <a:rPr kumimoji="0" lang="en-GB" sz="1600" b="0" i="0" strike="noStrike" kern="1200" cap="none" spc="0" normalizeH="0" baseline="0" noProof="0" dirty="0">
+                  <a:ln>
+                    <a:noFill/>
+                  </a:ln>
+                  <a:solidFill>
+                    <a:prstClr val="white"/>
+                  </a:solidFill>
+                  <a:effectLst/>
+                  <a:uLnTx/>
+                  <a:uFillTx/>
+                  <a:latin typeface="Arial" panose="020B0604020202020204" pitchFamily="34" charset="0"/>
+                  <a:ea typeface="Lato Light" panose="020F0502020204030203" pitchFamily="34" charset="0"/>
+                  <a:cs typeface="Arial" panose="020B0604020202020204" pitchFamily="34" charset="0"/>
+                </a:rPr>
+                <a:t>Cortex-M</a:t>
+              </a:r>
+            </a:p>
+            <a:p>
+              <a:pPr marL="0" marR="0" lvl="0" indent="0" algn="ctr" defTabSz="1218804" rtl="0" eaLnBrk="0" fontAlgn="base" latinLnBrk="0" hangingPunct="0">
+                <a:lnSpc>
+                  <a:spcPct val="100000"/>
+                </a:lnSpc>
+                <a:spcBef>
+                  <a:spcPct val="0"/>
+                </a:spcBef>
+                <a:spcAft>
+                  <a:spcPct val="0"/>
+                </a:spcAft>
+                <a:buClrTx/>
+                <a:buSzTx/>
+                <a:buFontTx/>
+                <a:buNone/>
+                <a:tabLst/>
+                <a:defRPr/>
+              </a:pPr>
+              <a:r>
+                <a:rPr kumimoji="0" lang="en-GB" sz="1600" b="0" i="0" strike="noStrike" kern="1200" cap="none" spc="0" normalizeH="0" baseline="0" noProof="0" dirty="0">
+                  <a:ln>
+                    <a:noFill/>
+                  </a:ln>
+                  <a:solidFill>
+                    <a:prstClr val="white"/>
+                  </a:solidFill>
+                  <a:effectLst/>
+                  <a:uLnTx/>
+                  <a:uFillTx/>
+                  <a:latin typeface="Arial" panose="020B0604020202020204" pitchFamily="34" charset="0"/>
+                  <a:ea typeface="Lato Light" panose="020F0502020204030203" pitchFamily="34" charset="0"/>
+                  <a:cs typeface="Arial" panose="020B0604020202020204" pitchFamily="34" charset="0"/>
+                </a:rPr>
+                <a:t>CPU</a:t>
+              </a:r>
+            </a:p>
+          </p:txBody>
+        </p:sp>
+        <p:sp>
+          <p:nvSpPr>
+            <p:cNvPr id="18" name="角丸四角形 7">
+              <a:extLst>
+                <a:ext uri="{FF2B5EF4-FFF2-40B4-BE49-F238E27FC236}">
+                  <a16:creationId xmlns:a16="http://schemas.microsoft.com/office/drawing/2014/main" id="{D69323CD-3A99-268C-7957-FB66E4197C19}"/>
+                </a:ext>
+              </a:extLst>
+            </p:cNvPr>
+            <p:cNvSpPr>
+              <a:spLocks/>
+            </p:cNvSpPr>
+            <p:nvPr/>
+          </p:nvSpPr>
+          <p:spPr>
+            <a:xfrm>
+              <a:off x="8622530" y="4050495"/>
+              <a:ext cx="1169871" cy="991024"/>
+            </a:xfrm>
+            <a:prstGeom prst="roundRect">
+              <a:avLst>
+                <a:gd name="adj" fmla="val 0"/>
+              </a:avLst>
+            </a:prstGeom>
+            <a:solidFill>
+              <a:schemeClr val="accent1">
+                <a:lumMod val="75000"/>
+              </a:schemeClr>
+            </a:solidFill>
+            <a:ln>
+              <a:noFill/>
+            </a:ln>
+          </p:spPr>
+          <p:style>
+            <a:lnRef idx="0">
+              <a:scrgbClr r="0" g="0" b="0"/>
+            </a:lnRef>
+            <a:fillRef idx="0">
+              <a:scrgbClr r="0" g="0" b="0"/>
+            </a:fillRef>
+            <a:effectRef idx="0">
+              <a:scrgbClr r="0" g="0" b="0"/>
+            </a:effectRef>
+            <a:fontRef idx="minor">
+              <a:schemeClr val="lt1"/>
+            </a:fontRef>
+          </p:style>
+          <p:txBody>
+            <a:bodyPr rtlCol="0" anchor="ctr" anchorCtr="1"/>
+            <a:lstStyle/>
+            <a:p>
+              <a:pPr marL="0" marR="0" lvl="0" indent="0" algn="ctr" defTabSz="1218804" rtl="0" eaLnBrk="0" fontAlgn="base" latinLnBrk="0" hangingPunct="0">
+                <a:lnSpc>
+                  <a:spcPct val="100000"/>
+                </a:lnSpc>
+                <a:spcBef>
+                  <a:spcPct val="0"/>
+                </a:spcBef>
+                <a:spcAft>
+                  <a:spcPct val="0"/>
+                </a:spcAft>
+                <a:buClrTx/>
+                <a:buSzTx/>
+                <a:buFontTx/>
+                <a:buNone/>
+                <a:tabLst/>
+                <a:defRPr/>
+              </a:pPr>
+              <a:r>
+                <a:rPr kumimoji="1" lang="sv-SE" altLang="ja-JP" sz="1600" b="0" i="0" strike="noStrike" kern="1200" cap="none" spc="0" normalizeH="0" baseline="0" noProof="0" dirty="0">
+                  <a:ln>
+                    <a:noFill/>
+                  </a:ln>
+                  <a:solidFill>
+                    <a:prstClr val="white"/>
+                  </a:solidFill>
+                  <a:effectLst/>
+                  <a:uLnTx/>
+                  <a:uFillTx/>
+                  <a:latin typeface="Arial" panose="020B0604020202020204" pitchFamily="34" charset="0"/>
+                  <a:ea typeface="Lato Light" panose="020F0502020204030203" pitchFamily="34" charset="0"/>
+                  <a:cs typeface="Arial" panose="020B0604020202020204" pitchFamily="34" charset="0"/>
+                </a:rPr>
+                <a:t>Ethos-U Driver</a:t>
+              </a:r>
+              <a:endParaRPr kumimoji="0" lang="en-US" altLang="ja-JP" sz="1600" b="0" i="0" strike="noStrike" kern="1200" cap="none" spc="0" normalizeH="0" baseline="0" noProof="0" dirty="0">
+                <a:ln>
+                  <a:noFill/>
+                </a:ln>
+                <a:solidFill>
+                  <a:prstClr val="white"/>
+                </a:solidFill>
+                <a:effectLst/>
+                <a:uLnTx/>
+                <a:uFillTx/>
+                <a:latin typeface="Arial" panose="020B0604020202020204" pitchFamily="34" charset="0"/>
+                <a:ea typeface="Lato Light" panose="020F0502020204030203" pitchFamily="34" charset="0"/>
+                <a:cs typeface="Arial" panose="020B0604020202020204" pitchFamily="34" charset="0"/>
+              </a:endParaRPr>
+            </a:p>
+          </p:txBody>
+        </p:sp>
+        <p:sp>
+          <p:nvSpPr>
+            <p:cNvPr id="35" name="Right Arrow 34">
+              <a:extLst>
+                <a:ext uri="{FF2B5EF4-FFF2-40B4-BE49-F238E27FC236}">
+                  <a16:creationId xmlns:a16="http://schemas.microsoft.com/office/drawing/2014/main" id="{93013D7F-D8DD-D7C7-C400-D4DA98B5730C}"/>
+                </a:ext>
+              </a:extLst>
+            </p:cNvPr>
+            <p:cNvSpPr>
+              <a:spLocks/>
+            </p:cNvSpPr>
+            <p:nvPr/>
+          </p:nvSpPr>
+          <p:spPr>
+            <a:xfrm>
+              <a:off x="9797307" y="2823683"/>
+              <a:ext cx="295860" cy="535780"/>
+            </a:xfrm>
+            <a:prstGeom prst="rightArrow">
+              <a:avLst/>
+            </a:prstGeom>
+            <a:solidFill>
+              <a:schemeClr val="bg1"/>
+            </a:solidFill>
+            <a:ln>
+              <a:solidFill>
+                <a:schemeClr val="tx2">
+                  <a:lumMod val="40000"/>
+                  <a:lumOff val="60000"/>
+                </a:schemeClr>
+              </a:solidFill>
+            </a:ln>
+          </p:spPr>
+          <p:style>
+            <a:lnRef idx="2">
+              <a:schemeClr val="accent1">
+                <a:shade val="50000"/>
+              </a:schemeClr>
+            </a:lnRef>
+            <a:fillRef idx="1">
+              <a:schemeClr val="accent1"/>
+            </a:fillRef>
+            <a:effectRef idx="0">
+              <a:schemeClr val="accent1"/>
+            </a:effectRef>
+            <a:fontRef idx="minor">
+              <a:schemeClr val="lt1"/>
+            </a:fontRef>
+          </p:style>
+          <p:txBody>
+            <a:bodyPr rtlCol="0" anchor="ctr"/>
+            <a:lstStyle/>
+            <a:p>
+              <a:pPr algn="ctr"/>
+              <a:endParaRPr lang="en-DE">
+                <a:latin typeface="Arial" panose="020B0604020202020204" pitchFamily="34" charset="0"/>
+                <a:cs typeface="Arial" panose="020B0604020202020204" pitchFamily="34" charset="0"/>
+              </a:endParaRPr>
+            </a:p>
+          </p:txBody>
+        </p:sp>
+        <p:sp>
+          <p:nvSpPr>
+            <p:cNvPr id="3" name="角丸四角形 7">
+              <a:extLst>
+                <a:ext uri="{FF2B5EF4-FFF2-40B4-BE49-F238E27FC236}">
+                  <a16:creationId xmlns:a16="http://schemas.microsoft.com/office/drawing/2014/main" id="{26B4E428-A624-60D3-CF7B-FD718232E9A5}"/>
+                </a:ext>
+              </a:extLst>
+            </p:cNvPr>
+            <p:cNvSpPr>
+              <a:spLocks/>
+            </p:cNvSpPr>
+            <p:nvPr/>
+          </p:nvSpPr>
+          <p:spPr>
+            <a:xfrm>
+              <a:off x="10116823" y="4050495"/>
+              <a:ext cx="1169871" cy="991024"/>
+            </a:xfrm>
+            <a:prstGeom prst="roundRect">
+              <a:avLst>
+                <a:gd name="adj" fmla="val 0"/>
+              </a:avLst>
+            </a:prstGeom>
+            <a:solidFill>
+              <a:schemeClr val="accent1">
+                <a:lumMod val="75000"/>
+              </a:schemeClr>
+            </a:solidFill>
+            <a:ln>
+              <a:noFill/>
+            </a:ln>
+          </p:spPr>
+          <p:style>
+            <a:lnRef idx="0">
+              <a:scrgbClr r="0" g="0" b="0"/>
+            </a:lnRef>
+            <a:fillRef idx="0">
+              <a:scrgbClr r="0" g="0" b="0"/>
+            </a:fillRef>
+            <a:effectRef idx="0">
+              <a:scrgbClr r="0" g="0" b="0"/>
+            </a:effectRef>
+            <a:fontRef idx="minor">
+              <a:schemeClr val="lt1"/>
+            </a:fontRef>
+          </p:style>
+          <p:txBody>
+            <a:bodyPr rtlCol="0" anchor="ctr" anchorCtr="1"/>
+            <a:lstStyle/>
+            <a:p>
+              <a:pPr marL="0" marR="0" lvl="0" indent="0" algn="ctr" defTabSz="1218804" rtl="0" eaLnBrk="0" fontAlgn="base" latinLnBrk="0" hangingPunct="0">
+                <a:lnSpc>
+                  <a:spcPct val="100000"/>
+                </a:lnSpc>
+                <a:spcBef>
+                  <a:spcPct val="0"/>
+                </a:spcBef>
+                <a:spcAft>
+                  <a:spcPct val="0"/>
+                </a:spcAft>
+                <a:buClrTx/>
+                <a:buSzTx/>
+                <a:buFontTx/>
+                <a:buNone/>
+                <a:tabLst/>
+                <a:defRPr/>
+              </a:pPr>
+              <a:r>
+                <a:rPr kumimoji="1" lang="sv-SE" altLang="ja-JP" sz="1600" b="0" i="0" strike="noStrike" kern="1200" cap="none" spc="0" normalizeH="0" baseline="0" noProof="0" dirty="0">
+                  <a:ln>
+                    <a:noFill/>
+                  </a:ln>
+                  <a:solidFill>
+                    <a:prstClr val="white"/>
+                  </a:solidFill>
+                  <a:effectLst/>
+                  <a:uLnTx/>
+                  <a:uFillTx/>
+                  <a:latin typeface="Arial" panose="020B0604020202020204" pitchFamily="34" charset="0"/>
+                  <a:ea typeface="Lato Light" panose="020F0502020204030203" pitchFamily="34" charset="0"/>
+                  <a:cs typeface="Arial" panose="020B0604020202020204" pitchFamily="34" charset="0"/>
+                </a:rPr>
+                <a:t>Ethos-U</a:t>
+              </a:r>
+              <a:br>
+                <a:rPr kumimoji="1" lang="sv-SE" altLang="ja-JP" sz="1600" b="0" i="0" strike="noStrike" kern="1200" cap="none" spc="0" normalizeH="0" baseline="0" noProof="0" dirty="0">
+                  <a:ln>
+                    <a:noFill/>
+                  </a:ln>
+                  <a:solidFill>
+                    <a:prstClr val="white"/>
+                  </a:solidFill>
+                  <a:effectLst/>
+                  <a:uLnTx/>
+                  <a:uFillTx/>
+                  <a:latin typeface="Arial" panose="020B0604020202020204" pitchFamily="34" charset="0"/>
+                  <a:ea typeface="Lato Light" panose="020F0502020204030203" pitchFamily="34" charset="0"/>
+                  <a:cs typeface="Arial" panose="020B0604020202020204" pitchFamily="34" charset="0"/>
+                </a:rPr>
+              </a:br>
+              <a:r>
+                <a:rPr kumimoji="1" lang="sv-SE" altLang="ja-JP" sz="1600" b="0" i="0" strike="noStrike" kern="1200" cap="none" spc="0" normalizeH="0" baseline="0" noProof="0" dirty="0">
+                  <a:ln>
+                    <a:noFill/>
+                  </a:ln>
+                  <a:solidFill>
+                    <a:prstClr val="white"/>
+                  </a:solidFill>
+                  <a:effectLst/>
+                  <a:uLnTx/>
+                  <a:uFillTx/>
+                  <a:latin typeface="Arial" panose="020B0604020202020204" pitchFamily="34" charset="0"/>
+                  <a:ea typeface="Lato Light" panose="020F0502020204030203" pitchFamily="34" charset="0"/>
+                  <a:cs typeface="Arial" panose="020B0604020202020204" pitchFamily="34" charset="0"/>
+                </a:rPr>
+                <a:t>NPU</a:t>
+              </a:r>
+              <a:endParaRPr kumimoji="0" lang="en-US" altLang="ja-JP" sz="1600" b="0" i="0" strike="noStrike" kern="1200" cap="none" spc="0" normalizeH="0" baseline="0" noProof="0" dirty="0">
+                <a:ln>
+                  <a:noFill/>
+                </a:ln>
+                <a:solidFill>
+                  <a:prstClr val="white"/>
+                </a:solidFill>
+                <a:effectLst/>
+                <a:uLnTx/>
+                <a:uFillTx/>
+                <a:latin typeface="Arial" panose="020B0604020202020204" pitchFamily="34" charset="0"/>
+                <a:ea typeface="Lato Light" panose="020F0502020204030203" pitchFamily="34" charset="0"/>
+                <a:cs typeface="Arial" panose="020B0604020202020204" pitchFamily="34" charset="0"/>
+              </a:endParaRPr>
+            </a:p>
+          </p:txBody>
+        </p:sp>
+        <p:sp>
+          <p:nvSpPr>
+            <p:cNvPr id="5" name="Right Arrow 4">
+              <a:extLst>
+                <a:ext uri="{FF2B5EF4-FFF2-40B4-BE49-F238E27FC236}">
+                  <a16:creationId xmlns:a16="http://schemas.microsoft.com/office/drawing/2014/main" id="{35A9DB58-9021-15D5-B0A1-248B81DEBC5C}"/>
+                </a:ext>
+              </a:extLst>
+            </p:cNvPr>
+            <p:cNvSpPr>
+              <a:spLocks/>
+            </p:cNvSpPr>
+            <p:nvPr/>
+          </p:nvSpPr>
+          <p:spPr>
+            <a:xfrm>
+              <a:off x="9803819" y="4268498"/>
+              <a:ext cx="291582" cy="535780"/>
+            </a:xfrm>
+            <a:prstGeom prst="rightArrow">
+              <a:avLst/>
+            </a:prstGeom>
+            <a:solidFill>
+              <a:schemeClr val="bg1"/>
+            </a:solidFill>
+            <a:ln>
+              <a:solidFill>
+                <a:schemeClr val="tx2">
+                  <a:lumMod val="40000"/>
+                  <a:lumOff val="60000"/>
+                </a:schemeClr>
+              </a:solidFill>
+            </a:ln>
+          </p:spPr>
+          <p:style>
+            <a:lnRef idx="2">
+              <a:schemeClr val="accent1">
+                <a:shade val="50000"/>
+              </a:schemeClr>
+            </a:lnRef>
+            <a:fillRef idx="1">
+              <a:schemeClr val="accent1"/>
+            </a:fillRef>
+            <a:effectRef idx="0">
+              <a:schemeClr val="accent1"/>
+            </a:effectRef>
+            <a:fontRef idx="minor">
+              <a:schemeClr val="lt1"/>
+            </a:fontRef>
+          </p:style>
+          <p:txBody>
+            <a:bodyPr rtlCol="0" anchor="ctr"/>
+            <a:lstStyle/>
+            <a:p>
+              <a:pPr algn="ctr"/>
+              <a:endParaRPr lang="en-DE">
+                <a:latin typeface="Arial" panose="020B0604020202020204" pitchFamily="34" charset="0"/>
+                <a:cs typeface="Arial" panose="020B0604020202020204" pitchFamily="34" charset="0"/>
+              </a:endParaRPr>
+            </a:p>
+          </p:txBody>
+        </p:sp>
+        <p:sp>
+          <p:nvSpPr>
+            <p:cNvPr id="6" name="Right Arrow 5">
+              <a:extLst>
+                <a:ext uri="{FF2B5EF4-FFF2-40B4-BE49-F238E27FC236}">
+                  <a16:creationId xmlns:a16="http://schemas.microsoft.com/office/drawing/2014/main" id="{6792AC77-5ADC-3376-F910-01D2C822BD50}"/>
+                </a:ext>
+              </a:extLst>
+            </p:cNvPr>
+            <p:cNvSpPr>
+              <a:spLocks/>
+            </p:cNvSpPr>
+            <p:nvPr/>
+          </p:nvSpPr>
+          <p:spPr>
+            <a:xfrm>
+              <a:off x="8314097" y="2836040"/>
+              <a:ext cx="295860" cy="535780"/>
+            </a:xfrm>
+            <a:prstGeom prst="rightArrow">
+              <a:avLst/>
+            </a:prstGeom>
+            <a:solidFill>
+              <a:schemeClr val="bg1"/>
+            </a:solidFill>
+            <a:ln>
+              <a:solidFill>
+                <a:schemeClr val="tx2">
+                  <a:lumMod val="40000"/>
+                  <a:lumOff val="60000"/>
+                </a:schemeClr>
+              </a:solidFill>
+            </a:ln>
+          </p:spPr>
+          <p:style>
+            <a:lnRef idx="2">
+              <a:schemeClr val="accent1">
+                <a:shade val="50000"/>
+              </a:schemeClr>
+            </a:lnRef>
+            <a:fillRef idx="1">
+              <a:schemeClr val="accent1"/>
+            </a:fillRef>
+            <a:effectRef idx="0">
+              <a:schemeClr val="accent1"/>
+            </a:effectRef>
+            <a:fontRef idx="minor">
+              <a:schemeClr val="lt1"/>
+            </a:fontRef>
+          </p:style>
+          <p:txBody>
+            <a:bodyPr rtlCol="0" anchor="ctr"/>
+            <a:lstStyle/>
+            <a:p>
+              <a:pPr algn="ctr"/>
+              <a:endParaRPr lang="en-DE">
+                <a:latin typeface="Arial" panose="020B0604020202020204" pitchFamily="34" charset="0"/>
+                <a:cs typeface="Arial" panose="020B0604020202020204" pitchFamily="34" charset="0"/>
+              </a:endParaRPr>
+            </a:p>
+          </p:txBody>
+        </p:sp>
+        <p:sp>
+          <p:nvSpPr>
+            <p:cNvPr id="7" name="Right Arrow 6">
+              <a:extLst>
+                <a:ext uri="{FF2B5EF4-FFF2-40B4-BE49-F238E27FC236}">
+                  <a16:creationId xmlns:a16="http://schemas.microsoft.com/office/drawing/2014/main" id="{55BA382B-F929-ECE0-44E6-F8EB5270DB98}"/>
+                </a:ext>
+              </a:extLst>
+            </p:cNvPr>
+            <p:cNvSpPr>
+              <a:spLocks/>
+            </p:cNvSpPr>
+            <p:nvPr/>
+          </p:nvSpPr>
+          <p:spPr>
+            <a:xfrm>
+              <a:off x="8314097" y="4280855"/>
+              <a:ext cx="295860" cy="535780"/>
+            </a:xfrm>
+            <a:prstGeom prst="rightArrow">
+              <a:avLst/>
+            </a:prstGeom>
+            <a:solidFill>
+              <a:schemeClr val="bg1"/>
+            </a:solidFill>
+            <a:ln>
+              <a:solidFill>
+                <a:schemeClr val="tx2">
+                  <a:lumMod val="40000"/>
+                  <a:lumOff val="60000"/>
+                </a:schemeClr>
+              </a:solidFill>
+            </a:ln>
+          </p:spPr>
+          <p:style>
+            <a:lnRef idx="2">
+              <a:schemeClr val="accent1">
+                <a:shade val="50000"/>
+              </a:schemeClr>
+            </a:lnRef>
+            <a:fillRef idx="1">
+              <a:schemeClr val="accent1"/>
+            </a:fillRef>
+            <a:effectRef idx="0">
+              <a:schemeClr val="accent1"/>
+            </a:effectRef>
+            <a:fontRef idx="minor">
+              <a:schemeClr val="lt1"/>
+            </a:fontRef>
+          </p:style>
+          <p:txBody>
+            <a:bodyPr rtlCol="0" anchor="ctr"/>
+            <a:lstStyle/>
+            <a:p>
+              <a:pPr algn="ctr"/>
+              <a:endParaRPr lang="en-DE">
+                <a:latin typeface="Arial" panose="020B0604020202020204" pitchFamily="34" charset="0"/>
+                <a:cs typeface="Arial" panose="020B0604020202020204" pitchFamily="34" charset="0"/>
+              </a:endParaRPr>
+            </a:p>
+          </p:txBody>
+        </p:sp>
+        <p:sp>
+          <p:nvSpPr>
+            <p:cNvPr id="13" name="角丸四角形 6">
+              <a:extLst>
+                <a:ext uri="{FF2B5EF4-FFF2-40B4-BE49-F238E27FC236}">
+                  <a16:creationId xmlns:a16="http://schemas.microsoft.com/office/drawing/2014/main" id="{534ABEDD-191D-79F6-2C95-881D3883CB3D}"/>
+                </a:ext>
+              </a:extLst>
+            </p:cNvPr>
+            <p:cNvSpPr>
+              <a:spLocks/>
+            </p:cNvSpPr>
+            <p:nvPr/>
+          </p:nvSpPr>
+          <p:spPr>
+            <a:xfrm rot="16200000">
+              <a:off x="6804065" y="3538943"/>
+              <a:ext cx="2465152" cy="540000"/>
+            </a:xfrm>
+            <a:prstGeom prst="roundRect">
+              <a:avLst>
+                <a:gd name="adj" fmla="val 0"/>
+              </a:avLst>
+            </a:prstGeom>
+            <a:solidFill>
+              <a:schemeClr val="accent4"/>
+            </a:solidFill>
+            <a:ln w="15875">
+              <a:solidFill>
+                <a:schemeClr val="accent4"/>
+              </a:solidFill>
+            </a:ln>
+          </p:spPr>
+          <p:style>
+            <a:lnRef idx="2">
+              <a:schemeClr val="accent4"/>
+            </a:lnRef>
+            <a:fillRef idx="1">
+              <a:schemeClr val="lt1"/>
+            </a:fillRef>
+            <a:effectRef idx="0">
+              <a:schemeClr val="accent4"/>
+            </a:effectRef>
+            <a:fontRef idx="minor">
+              <a:schemeClr val="dk1"/>
+            </a:fontRef>
+          </p:style>
+          <p:txBody>
+            <a:bodyPr rtlCol="0" anchor="ctr" anchorCtr="1"/>
+            <a:lstStyle/>
+            <a:p>
+              <a:pPr marL="0" marR="0" lvl="0" indent="0" algn="ctr" defTabSz="1218804" rtl="0" eaLnBrk="0" fontAlgn="base" latinLnBrk="0" hangingPunct="0">
+                <a:lnSpc>
+                  <a:spcPct val="100000"/>
+                </a:lnSpc>
+                <a:spcBef>
+                  <a:spcPct val="0"/>
+                </a:spcBef>
+                <a:spcAft>
+                  <a:spcPct val="0"/>
+                </a:spcAft>
+                <a:buClrTx/>
+                <a:buSzTx/>
+                <a:buFontTx/>
+                <a:buNone/>
+                <a:tabLst/>
+                <a:defRPr/>
+              </a:pPr>
+              <a:r>
+                <a:rPr kumimoji="1" lang="sv-SE" altLang="ja-JP" sz="1600">
+                  <a:solidFill>
+                    <a:sysClr val="windowText" lastClr="000000"/>
+                  </a:solidFill>
+                  <a:latin typeface="Arial" panose="020B0604020202020204" pitchFamily="34" charset="0"/>
+                  <a:ea typeface="Lato Light" panose="020F0502020204030203" pitchFamily="34" charset="0"/>
+                  <a:cs typeface="Arial" panose="020B0604020202020204" pitchFamily="34" charset="0"/>
+                </a:rPr>
+                <a:t>ML </a:t>
+              </a:r>
+              <a:r>
+                <a:rPr kumimoji="1" lang="sv-SE" altLang="ja-JP" sz="1600" err="1">
+                  <a:solidFill>
+                    <a:sysClr val="windowText" lastClr="000000"/>
+                  </a:solidFill>
+                  <a:latin typeface="Arial" panose="020B0604020202020204" pitchFamily="34" charset="0"/>
+                  <a:ea typeface="Lato Light" panose="020F0502020204030203" pitchFamily="34" charset="0"/>
+                  <a:cs typeface="Arial" panose="020B0604020202020204" pitchFamily="34" charset="0"/>
+                </a:rPr>
+                <a:t>Runtime</a:t>
+              </a:r>
+              <a:endParaRPr kumimoji="1" lang="ja-JP" altLang="en-US" sz="1600" b="0" i="0" strike="noStrike" kern="1200" cap="none" spc="0" normalizeH="0" baseline="0" noProof="0">
+                <a:ln>
+                  <a:noFill/>
+                </a:ln>
+                <a:solidFill>
+                  <a:sysClr val="windowText" lastClr="000000"/>
+                </a:solidFill>
+                <a:effectLst/>
+                <a:uLnTx/>
+                <a:uFillTx/>
+                <a:latin typeface="Arial" panose="020B0604020202020204" pitchFamily="34" charset="0"/>
+                <a:ea typeface="游ゴシック" panose="020B0400000000000000" pitchFamily="34" charset="-128"/>
+                <a:cs typeface="Arial" panose="020B0604020202020204" pitchFamily="34" charset="0"/>
+              </a:endParaRPr>
+            </a:p>
+          </p:txBody>
+        </p:sp>
+        <p:sp>
+          <p:nvSpPr>
+            <p:cNvPr id="10" name="Right Arrow 9">
+              <a:extLst>
+                <a:ext uri="{FF2B5EF4-FFF2-40B4-BE49-F238E27FC236}">
+                  <a16:creationId xmlns:a16="http://schemas.microsoft.com/office/drawing/2014/main" id="{3EE4516D-7C33-A3F6-E7B5-C7791AD7D786}"/>
+                </a:ext>
+              </a:extLst>
+            </p:cNvPr>
+            <p:cNvSpPr>
+              <a:spLocks/>
+            </p:cNvSpPr>
+            <p:nvPr/>
+          </p:nvSpPr>
+          <p:spPr>
+            <a:xfrm>
+              <a:off x="7491163" y="3573392"/>
+              <a:ext cx="270288" cy="535780"/>
+            </a:xfrm>
+            <a:prstGeom prst="rightArrow">
+              <a:avLst/>
+            </a:prstGeom>
+            <a:solidFill>
+              <a:schemeClr val="bg1"/>
+            </a:solidFill>
+            <a:ln>
+              <a:solidFill>
+                <a:schemeClr val="tx2">
+                  <a:lumMod val="40000"/>
+                  <a:lumOff val="60000"/>
+                </a:schemeClr>
+              </a:solidFill>
+            </a:ln>
+          </p:spPr>
+          <p:style>
+            <a:lnRef idx="2">
+              <a:schemeClr val="accent1">
+                <a:shade val="50000"/>
+              </a:schemeClr>
+            </a:lnRef>
+            <a:fillRef idx="1">
+              <a:schemeClr val="accent1"/>
+            </a:fillRef>
+            <a:effectRef idx="0">
+              <a:schemeClr val="accent1"/>
+            </a:effectRef>
+            <a:fontRef idx="minor">
+              <a:schemeClr val="lt1"/>
+            </a:fontRef>
+          </p:style>
+          <p:txBody>
+            <a:bodyPr rtlCol="0" anchor="ctr"/>
+            <a:lstStyle/>
+            <a:p>
+              <a:pPr algn="ctr"/>
+              <a:endParaRPr lang="en-DE">
+                <a:latin typeface="Arial" panose="020B0604020202020204" pitchFamily="34" charset="0"/>
+                <a:cs typeface="Arial" panose="020B0604020202020204" pitchFamily="34" charset="0"/>
+              </a:endParaRPr>
+            </a:p>
+          </p:txBody>
+        </p:sp>
+        <p:sp>
+          <p:nvSpPr>
+            <p:cNvPr id="21" name="角丸四角形 6">
+              <a:extLst>
+                <a:ext uri="{FF2B5EF4-FFF2-40B4-BE49-F238E27FC236}">
+                  <a16:creationId xmlns:a16="http://schemas.microsoft.com/office/drawing/2014/main" id="{F9658CB8-2E82-CCFE-A383-8CC6716E96E7}"/>
+                </a:ext>
+              </a:extLst>
+            </p:cNvPr>
+            <p:cNvSpPr>
+              <a:spLocks/>
+            </p:cNvSpPr>
+            <p:nvPr/>
+          </p:nvSpPr>
+          <p:spPr>
+            <a:xfrm>
+              <a:off x="6388357" y="3320008"/>
+              <a:ext cx="1098040" cy="977868"/>
+            </a:xfrm>
+            <a:prstGeom prst="roundRect">
+              <a:avLst>
+                <a:gd name="adj" fmla="val 0"/>
+              </a:avLst>
+            </a:prstGeom>
+            <a:solidFill>
+              <a:schemeClr val="accent1"/>
+            </a:solidFill>
+            <a:ln w="15875">
+              <a:noFill/>
+            </a:ln>
+          </p:spPr>
+          <p:style>
+            <a:lnRef idx="2">
+              <a:schemeClr val="accent4"/>
+            </a:lnRef>
+            <a:fillRef idx="1">
+              <a:schemeClr val="lt1"/>
+            </a:fillRef>
+            <a:effectRef idx="0">
+              <a:schemeClr val="accent4"/>
+            </a:effectRef>
+            <a:fontRef idx="minor">
+              <a:schemeClr val="dk1"/>
+            </a:fontRef>
+          </p:style>
+          <p:txBody>
+            <a:bodyPr lIns="0" tIns="60960" rIns="0" bIns="60960" rtlCol="0" anchor="ctr" anchorCtr="1"/>
+            <a:lstStyle/>
+            <a:p>
+              <a:pPr marL="0" marR="0" lvl="0" indent="0" algn="ctr" defTabSz="1218804" rtl="0" eaLnBrk="0" fontAlgn="base" latinLnBrk="0" hangingPunct="0">
+                <a:lnSpc>
+                  <a:spcPct val="100000"/>
+                </a:lnSpc>
+                <a:spcBef>
+                  <a:spcPct val="0"/>
+                </a:spcBef>
+                <a:spcAft>
+                  <a:spcPct val="0"/>
+                </a:spcAft>
+                <a:buClrTx/>
+                <a:buSzTx/>
+                <a:buFontTx/>
+                <a:buNone/>
+                <a:tabLst/>
+                <a:defRPr/>
+              </a:pPr>
+              <a:r>
+                <a:rPr kumimoji="1" lang="sv-SE" altLang="ja-JP" sz="1600" dirty="0">
+                  <a:solidFill>
+                    <a:srgbClr val="FFFFFF"/>
+                  </a:solidFill>
+                  <a:latin typeface="Arial" panose="020B0604020202020204" pitchFamily="34" charset="0"/>
+                  <a:ea typeface="Lato Light"/>
+                  <a:cs typeface="Arial" panose="020B0604020202020204" pitchFamily="34" charset="0"/>
+                </a:rPr>
+                <a:t>Optimized</a:t>
+              </a:r>
+              <a:br>
+                <a:rPr kumimoji="1" lang="sv-SE" altLang="ja-JP" sz="1600" b="0" i="0" strike="noStrike" kern="1200" cap="none" spc="0" normalizeH="0" baseline="0" noProof="0" dirty="0">
+                  <a:ln>
+                    <a:noFill/>
+                  </a:ln>
+                  <a:solidFill>
+                    <a:srgbClr val="FFFFFF"/>
+                  </a:solidFill>
+                  <a:effectLst/>
+                  <a:uLnTx/>
+                  <a:uFillTx/>
+                  <a:latin typeface="Arial" panose="020B0604020202020204" pitchFamily="34" charset="0"/>
+                  <a:ea typeface="Lato Light"/>
+                  <a:cs typeface="Arial" panose="020B0604020202020204" pitchFamily="34" charset="0"/>
+                </a:rPr>
+              </a:br>
+              <a:r>
+                <a:rPr kumimoji="1" lang="sv-SE" altLang="ja-JP" sz="1600" b="0" i="0" strike="noStrike" kern="1200" cap="none" spc="0" normalizeH="0" baseline="0" noProof="0" dirty="0">
+                  <a:ln>
+                    <a:noFill/>
+                  </a:ln>
+                  <a:solidFill>
+                    <a:srgbClr val="FFFFFF"/>
+                  </a:solidFill>
+                  <a:effectLst/>
+                  <a:uLnTx/>
+                  <a:uFillTx/>
+                  <a:latin typeface="Arial" panose="020B0604020202020204" pitchFamily="34" charset="0"/>
+                  <a:ea typeface="Lato Light"/>
+                  <a:cs typeface="Arial" panose="020B0604020202020204" pitchFamily="34" charset="0"/>
+                </a:rPr>
+                <a:t>ML Model</a:t>
+              </a:r>
+              <a:endParaRPr kumimoji="0" lang="sv-SE" altLang="ja-JP" sz="1600" b="0" i="0" strike="noStrike" kern="1200" cap="none" spc="0" normalizeH="0" baseline="0" noProof="0" dirty="0">
+                <a:ln>
+                  <a:noFill/>
+                </a:ln>
+                <a:solidFill>
+                  <a:srgbClr val="FFFFFF"/>
+                </a:solidFill>
+                <a:effectLst/>
+                <a:uLnTx/>
+                <a:uFillTx/>
+                <a:latin typeface="Arial" panose="020B0604020202020204" pitchFamily="34" charset="0"/>
+                <a:ea typeface="Lato Light"/>
+                <a:cs typeface="Arial" panose="020B0604020202020204" pitchFamily="34" charset="0"/>
+              </a:endParaRPr>
+            </a:p>
+          </p:txBody>
+        </p:sp>
+        <p:sp>
+          <p:nvSpPr>
+            <p:cNvPr id="34" name="Process 65">
+              <a:extLst>
+                <a:ext uri="{FF2B5EF4-FFF2-40B4-BE49-F238E27FC236}">
+                  <a16:creationId xmlns:a16="http://schemas.microsoft.com/office/drawing/2014/main" id="{D78E3A6F-F0D1-6849-E045-029BA06C4409}"/>
+                </a:ext>
+              </a:extLst>
+            </p:cNvPr>
+            <p:cNvSpPr>
+              <a:spLocks/>
+            </p:cNvSpPr>
+            <p:nvPr/>
+          </p:nvSpPr>
+          <p:spPr>
+            <a:xfrm>
+              <a:off x="835176" y="2094471"/>
+              <a:ext cx="5138057" cy="3037366"/>
+            </a:xfrm>
+            <a:prstGeom prst="flowChartProcess">
+              <a:avLst/>
+            </a:prstGeom>
+            <a:solidFill>
+              <a:schemeClr val="bg2">
+                <a:lumMod val="50000"/>
+              </a:schemeClr>
+            </a:solidFill>
+            <a:ln w="0">
+              <a:solidFill>
+                <a:schemeClr val="bg1"/>
+              </a:solidFill>
+            </a:ln>
+          </p:spPr>
+          <p:style>
+            <a:lnRef idx="2">
+              <a:schemeClr val="accent1">
+                <a:shade val="50000"/>
+              </a:schemeClr>
+            </a:lnRef>
+            <a:fillRef idx="1">
+              <a:schemeClr val="accent1"/>
+            </a:fillRef>
+            <a:effectRef idx="0">
+              <a:schemeClr val="accent1"/>
+            </a:effectRef>
+            <a:fontRef idx="minor">
+              <a:schemeClr val="lt1"/>
+            </a:fontRef>
+          </p:style>
+          <p:txBody>
+            <a:bodyPr tIns="108000" rtlCol="0" anchor="t"/>
+            <a:lstStyle/>
+            <a:p>
+              <a:pPr defTabSz="1219170">
+                <a:defRPr/>
+              </a:pPr>
+              <a:r>
+                <a:rPr kumimoji="1" lang="en-US" sz="1600" dirty="0">
+                  <a:solidFill>
+                    <a:srgbClr val="FFFFFF"/>
+                  </a:solidFill>
+                  <a:latin typeface="Arial" panose="020B0604020202020204" pitchFamily="34" charset="0"/>
+                  <a:cs typeface="Arial" panose="020B0604020202020204" pitchFamily="34" charset="0"/>
+                </a:rPr>
+                <a:t>DEVICE without Ethos-U</a:t>
+              </a:r>
+            </a:p>
+          </p:txBody>
+        </p:sp>
+        <p:sp>
+          <p:nvSpPr>
+            <p:cNvPr id="36" name="角丸四角形 7">
+              <a:extLst>
+                <a:ext uri="{FF2B5EF4-FFF2-40B4-BE49-F238E27FC236}">
+                  <a16:creationId xmlns:a16="http://schemas.microsoft.com/office/drawing/2014/main" id="{6BBBE024-73F8-B9C7-4BB1-9903544C7DDE}"/>
+                </a:ext>
+              </a:extLst>
+            </p:cNvPr>
+            <p:cNvSpPr>
+              <a:spLocks/>
+            </p:cNvSpPr>
+            <p:nvPr/>
+          </p:nvSpPr>
+          <p:spPr>
+            <a:xfrm>
+              <a:off x="3168584" y="2576367"/>
+              <a:ext cx="1169871" cy="1007207"/>
+            </a:xfrm>
+            <a:prstGeom prst="roundRect">
+              <a:avLst>
+                <a:gd name="adj" fmla="val 0"/>
+              </a:avLst>
+            </a:prstGeom>
+            <a:solidFill>
+              <a:schemeClr val="accent1"/>
+            </a:solidFill>
+            <a:ln>
+              <a:noFill/>
+            </a:ln>
+          </p:spPr>
+          <p:style>
+            <a:lnRef idx="0">
+              <a:scrgbClr r="0" g="0" b="0"/>
+            </a:lnRef>
+            <a:fillRef idx="0">
+              <a:scrgbClr r="0" g="0" b="0"/>
+            </a:fillRef>
+            <a:effectRef idx="0">
+              <a:scrgbClr r="0" g="0" b="0"/>
+            </a:effectRef>
+            <a:fontRef idx="minor">
+              <a:schemeClr val="lt1"/>
+            </a:fontRef>
+          </p:style>
+          <p:txBody>
+            <a:bodyPr lIns="0" rIns="0" rtlCol="0" anchor="ctr" anchorCtr="1"/>
+            <a:lstStyle/>
+            <a:p>
+              <a:pPr marL="0" marR="0" lvl="0" indent="0" algn="ctr" defTabSz="1218804" rtl="0" eaLnBrk="0" fontAlgn="base" latinLnBrk="0" hangingPunct="0">
+                <a:lnSpc>
+                  <a:spcPct val="100000"/>
+                </a:lnSpc>
+                <a:spcBef>
+                  <a:spcPct val="0"/>
+                </a:spcBef>
+                <a:spcAft>
+                  <a:spcPct val="0"/>
+                </a:spcAft>
+                <a:buClrTx/>
+                <a:buSzTx/>
+                <a:buFontTx/>
+                <a:buNone/>
+                <a:tabLst/>
+                <a:defRPr/>
+              </a:pPr>
+              <a:r>
+                <a:rPr kumimoji="1" lang="sv-SE" altLang="ja-JP" sz="1600" b="0" i="0" strike="noStrike" kern="1200" cap="none" spc="0" normalizeH="0" baseline="0" noProof="0" dirty="0">
+                  <a:ln>
+                    <a:noFill/>
+                  </a:ln>
+                  <a:solidFill>
+                    <a:prstClr val="white"/>
+                  </a:solidFill>
+                  <a:effectLst/>
+                  <a:uLnTx/>
+                  <a:uFillTx/>
+                  <a:latin typeface="Arial" panose="020B0604020202020204" pitchFamily="34" charset="0"/>
+                  <a:ea typeface="Lato Light" panose="020F0502020204030203" pitchFamily="34" charset="0"/>
+                  <a:cs typeface="Arial" panose="020B0604020202020204" pitchFamily="34" charset="0"/>
+                </a:rPr>
+                <a:t>CMSIS-NN</a:t>
+              </a:r>
+              <a:endParaRPr kumimoji="0" lang="en-US" sz="1600" b="0" i="0" strike="noStrike" kern="1200" cap="none" spc="0" normalizeH="0" baseline="0" noProof="0" dirty="0">
+                <a:ln>
+                  <a:noFill/>
+                </a:ln>
+                <a:solidFill>
+                  <a:prstClr val="white"/>
+                </a:solidFill>
+                <a:effectLst/>
+                <a:uLnTx/>
+                <a:uFillTx/>
+                <a:latin typeface="Arial" panose="020B0604020202020204" pitchFamily="34" charset="0"/>
+                <a:ea typeface="Lato Light" panose="020F0502020204030203" pitchFamily="34" charset="0"/>
+                <a:cs typeface="Arial" panose="020B0604020202020204" pitchFamily="34" charset="0"/>
+              </a:endParaRPr>
+            </a:p>
+            <a:p>
+              <a:pPr marL="0" marR="0" lvl="0" indent="0" algn="ctr" defTabSz="1218804" rtl="0" eaLnBrk="0" fontAlgn="base" latinLnBrk="0" hangingPunct="0">
+                <a:lnSpc>
+                  <a:spcPct val="100000"/>
+                </a:lnSpc>
+                <a:spcBef>
+                  <a:spcPct val="0"/>
+                </a:spcBef>
+                <a:spcAft>
+                  <a:spcPct val="0"/>
+                </a:spcAft>
+                <a:buClrTx/>
+                <a:buSzTx/>
+                <a:buFontTx/>
+                <a:buNone/>
+                <a:tabLst/>
+                <a:defRPr/>
+              </a:pPr>
+              <a:r>
+                <a:rPr kumimoji="1" lang="sv-SE" altLang="ja-JP" sz="1600" b="0" i="0" strike="noStrike" kern="1200" cap="none" spc="0" normalizeH="0" baseline="0" noProof="0" dirty="0">
+                  <a:ln>
+                    <a:noFill/>
+                  </a:ln>
+                  <a:solidFill>
+                    <a:prstClr val="white"/>
+                  </a:solidFill>
+                  <a:effectLst/>
+                  <a:uLnTx/>
+                  <a:uFillTx/>
+                  <a:latin typeface="Arial" panose="020B0604020202020204" pitchFamily="34" charset="0"/>
+                  <a:ea typeface="Lato Light" panose="020F0502020204030203" pitchFamily="34" charset="0"/>
+                  <a:cs typeface="Arial" panose="020B0604020202020204" pitchFamily="34" charset="0"/>
+                </a:rPr>
+                <a:t>Optimized Kernels</a:t>
+              </a:r>
+              <a:endParaRPr kumimoji="0" lang="en-US" altLang="ja-JP" sz="1600" b="0" i="0" strike="noStrike" kern="1200" cap="none" spc="0" normalizeH="0" baseline="0" noProof="0" dirty="0">
+                <a:ln>
+                  <a:noFill/>
+                </a:ln>
+                <a:solidFill>
+                  <a:prstClr val="white"/>
+                </a:solidFill>
+                <a:effectLst/>
+                <a:uLnTx/>
+                <a:uFillTx/>
+                <a:latin typeface="Arial" panose="020B0604020202020204" pitchFamily="34" charset="0"/>
+                <a:ea typeface="Lato Light" panose="020F0502020204030203" pitchFamily="34" charset="0"/>
+                <a:cs typeface="Arial" panose="020B0604020202020204" pitchFamily="34" charset="0"/>
+              </a:endParaRPr>
+            </a:p>
+          </p:txBody>
+        </p:sp>
+        <p:sp>
+          <p:nvSpPr>
+            <p:cNvPr id="37" name="Rectangle 36">
+              <a:extLst>
+                <a:ext uri="{FF2B5EF4-FFF2-40B4-BE49-F238E27FC236}">
+                  <a16:creationId xmlns:a16="http://schemas.microsoft.com/office/drawing/2014/main" id="{8C49957D-77F3-55EA-17EF-9B23AB39BC3B}"/>
+                </a:ext>
+              </a:extLst>
+            </p:cNvPr>
+            <p:cNvSpPr>
+              <a:spLocks/>
+            </p:cNvSpPr>
+            <p:nvPr/>
+          </p:nvSpPr>
+          <p:spPr>
+            <a:xfrm>
+              <a:off x="4663211" y="2582562"/>
+              <a:ext cx="1169871" cy="991024"/>
+            </a:xfrm>
+            <a:prstGeom prst="rect">
+              <a:avLst/>
+            </a:prstGeom>
+            <a:solidFill>
+              <a:schemeClr val="accent1"/>
+            </a:solidFill>
+            <a:ln>
+              <a:noFill/>
+            </a:ln>
+          </p:spPr>
+          <p:style>
+            <a:lnRef idx="0">
+              <a:scrgbClr r="0" g="0" b="0"/>
+            </a:lnRef>
+            <a:fillRef idx="0">
+              <a:scrgbClr r="0" g="0" b="0"/>
+            </a:fillRef>
+            <a:effectRef idx="0">
+              <a:scrgbClr r="0" g="0" b="0"/>
+            </a:effectRef>
+            <a:fontRef idx="minor">
+              <a:schemeClr val="lt1"/>
+            </a:fontRef>
+          </p:style>
+          <p:txBody>
+            <a:bodyPr rtlCol="0" anchor="ctr"/>
+            <a:lstStyle/>
+            <a:p>
+              <a:pPr marL="0" marR="0" lvl="0" indent="0" algn="ctr" defTabSz="1218804" rtl="0" eaLnBrk="0" fontAlgn="base" latinLnBrk="0" hangingPunct="0">
+                <a:lnSpc>
+                  <a:spcPct val="100000"/>
+                </a:lnSpc>
+                <a:spcBef>
+                  <a:spcPct val="0"/>
+                </a:spcBef>
+                <a:spcAft>
+                  <a:spcPct val="0"/>
+                </a:spcAft>
+                <a:buClrTx/>
+                <a:buSzTx/>
+                <a:buFontTx/>
+                <a:buNone/>
+                <a:tabLst/>
+                <a:defRPr/>
+              </a:pPr>
+              <a:r>
+                <a:rPr kumimoji="0" lang="en-GB" sz="1600" b="0" i="0" strike="noStrike" kern="1200" cap="none" spc="0" normalizeH="0" baseline="0" noProof="0" dirty="0">
+                  <a:ln>
+                    <a:noFill/>
+                  </a:ln>
+                  <a:solidFill>
+                    <a:prstClr val="white"/>
+                  </a:solidFill>
+                  <a:effectLst/>
+                  <a:uLnTx/>
+                  <a:uFillTx/>
+                  <a:latin typeface="Arial" panose="020B0604020202020204" pitchFamily="34" charset="0"/>
+                  <a:ea typeface="Lato Light" panose="020F0502020204030203" pitchFamily="34" charset="0"/>
+                  <a:cs typeface="Arial" panose="020B0604020202020204" pitchFamily="34" charset="0"/>
+                </a:rPr>
+                <a:t>Cortex-M</a:t>
+              </a:r>
+            </a:p>
+            <a:p>
+              <a:pPr marL="0" marR="0" lvl="0" indent="0" algn="ctr" defTabSz="1218804" rtl="0" eaLnBrk="0" fontAlgn="base" latinLnBrk="0" hangingPunct="0">
+                <a:lnSpc>
+                  <a:spcPct val="100000"/>
+                </a:lnSpc>
+                <a:spcBef>
+                  <a:spcPct val="0"/>
+                </a:spcBef>
+                <a:spcAft>
+                  <a:spcPct val="0"/>
+                </a:spcAft>
+                <a:buClrTx/>
+                <a:buSzTx/>
+                <a:buFontTx/>
+                <a:buNone/>
+                <a:tabLst/>
+                <a:defRPr/>
+              </a:pPr>
+              <a:r>
+                <a:rPr kumimoji="0" lang="en-GB" sz="1600" b="0" i="0" strike="noStrike" kern="1200" cap="none" spc="0" normalizeH="0" baseline="0" noProof="0" dirty="0">
+                  <a:ln>
+                    <a:noFill/>
+                  </a:ln>
+                  <a:solidFill>
+                    <a:prstClr val="white"/>
+                  </a:solidFill>
+                  <a:effectLst/>
+                  <a:uLnTx/>
+                  <a:uFillTx/>
+                  <a:latin typeface="Arial" panose="020B0604020202020204" pitchFamily="34" charset="0"/>
+                  <a:ea typeface="Lato Light" panose="020F0502020204030203" pitchFamily="34" charset="0"/>
+                  <a:cs typeface="Arial" panose="020B0604020202020204" pitchFamily="34" charset="0"/>
+                </a:rPr>
+                <a:t>CPU</a:t>
+              </a:r>
+            </a:p>
+          </p:txBody>
+        </p:sp>
+        <p:sp>
+          <p:nvSpPr>
+            <p:cNvPr id="39" name="Right Arrow 34">
+              <a:extLst>
+                <a:ext uri="{FF2B5EF4-FFF2-40B4-BE49-F238E27FC236}">
+                  <a16:creationId xmlns:a16="http://schemas.microsoft.com/office/drawing/2014/main" id="{3D67194A-E195-C210-13AC-168854671DD3}"/>
+                </a:ext>
+              </a:extLst>
+            </p:cNvPr>
+            <p:cNvSpPr>
+              <a:spLocks/>
+            </p:cNvSpPr>
+            <p:nvPr/>
+          </p:nvSpPr>
+          <p:spPr>
+            <a:xfrm>
+              <a:off x="4349873" y="2823683"/>
+              <a:ext cx="295860" cy="535780"/>
+            </a:xfrm>
+            <a:prstGeom prst="rightArrow">
+              <a:avLst/>
+            </a:prstGeom>
+            <a:solidFill>
+              <a:schemeClr val="bg1"/>
+            </a:solidFill>
+            <a:ln>
+              <a:solidFill>
+                <a:schemeClr val="tx2">
+                  <a:lumMod val="40000"/>
+                  <a:lumOff val="60000"/>
+                </a:schemeClr>
+              </a:solidFill>
+            </a:ln>
+          </p:spPr>
+          <p:style>
+            <a:lnRef idx="2">
+              <a:schemeClr val="accent1">
+                <a:shade val="50000"/>
+              </a:schemeClr>
+            </a:lnRef>
+            <a:fillRef idx="1">
+              <a:schemeClr val="accent1"/>
+            </a:fillRef>
+            <a:effectRef idx="0">
+              <a:schemeClr val="accent1"/>
+            </a:effectRef>
+            <a:fontRef idx="minor">
+              <a:schemeClr val="lt1"/>
+            </a:fontRef>
+          </p:style>
+          <p:txBody>
+            <a:bodyPr rtlCol="0" anchor="ctr"/>
+            <a:lstStyle/>
+            <a:p>
+              <a:pPr algn="ctr"/>
+              <a:endParaRPr lang="en-DE">
+                <a:latin typeface="Arial" panose="020B0604020202020204" pitchFamily="34" charset="0"/>
+                <a:cs typeface="Arial" panose="020B0604020202020204" pitchFamily="34" charset="0"/>
+              </a:endParaRPr>
+            </a:p>
+          </p:txBody>
+        </p:sp>
+        <p:sp>
+          <p:nvSpPr>
+            <p:cNvPr id="42" name="Right Arrow 5">
+              <a:extLst>
+                <a:ext uri="{FF2B5EF4-FFF2-40B4-BE49-F238E27FC236}">
+                  <a16:creationId xmlns:a16="http://schemas.microsoft.com/office/drawing/2014/main" id="{1B3E173C-9509-1FC1-6B49-2B69BA109024}"/>
+                </a:ext>
+              </a:extLst>
+            </p:cNvPr>
+            <p:cNvSpPr>
+              <a:spLocks/>
+            </p:cNvSpPr>
+            <p:nvPr/>
+          </p:nvSpPr>
+          <p:spPr>
+            <a:xfrm>
+              <a:off x="2866663" y="2836040"/>
+              <a:ext cx="295860" cy="535780"/>
+            </a:xfrm>
+            <a:prstGeom prst="rightArrow">
+              <a:avLst/>
+            </a:prstGeom>
+            <a:solidFill>
+              <a:schemeClr val="bg1"/>
+            </a:solidFill>
+            <a:ln>
+              <a:solidFill>
+                <a:schemeClr val="tx2">
+                  <a:lumMod val="40000"/>
+                  <a:lumOff val="60000"/>
+                </a:schemeClr>
+              </a:solidFill>
+            </a:ln>
+          </p:spPr>
+          <p:style>
+            <a:lnRef idx="2">
+              <a:schemeClr val="accent1">
+                <a:shade val="50000"/>
+              </a:schemeClr>
+            </a:lnRef>
+            <a:fillRef idx="1">
+              <a:schemeClr val="accent1"/>
+            </a:fillRef>
+            <a:effectRef idx="0">
+              <a:schemeClr val="accent1"/>
+            </a:effectRef>
+            <a:fontRef idx="minor">
+              <a:schemeClr val="lt1"/>
+            </a:fontRef>
+          </p:style>
+          <p:txBody>
+            <a:bodyPr rtlCol="0" anchor="ctr"/>
+            <a:lstStyle/>
+            <a:p>
+              <a:pPr algn="ctr"/>
+              <a:endParaRPr lang="en-DE">
+                <a:latin typeface="Arial" panose="020B0604020202020204" pitchFamily="34" charset="0"/>
+                <a:cs typeface="Arial" panose="020B0604020202020204" pitchFamily="34" charset="0"/>
+              </a:endParaRPr>
+            </a:p>
+          </p:txBody>
+        </p:sp>
+        <p:sp>
+          <p:nvSpPr>
+            <p:cNvPr id="44" name="角丸四角形 6">
+              <a:extLst>
+                <a:ext uri="{FF2B5EF4-FFF2-40B4-BE49-F238E27FC236}">
+                  <a16:creationId xmlns:a16="http://schemas.microsoft.com/office/drawing/2014/main" id="{58E55F26-B848-08F4-A818-8BB09E835E55}"/>
+                </a:ext>
+              </a:extLst>
+            </p:cNvPr>
+            <p:cNvSpPr>
+              <a:spLocks/>
+            </p:cNvSpPr>
+            <p:nvPr/>
+          </p:nvSpPr>
+          <p:spPr>
+            <a:xfrm rot="16200000">
+              <a:off x="1356631" y="3538943"/>
+              <a:ext cx="2465152" cy="540000"/>
+            </a:xfrm>
+            <a:prstGeom prst="roundRect">
+              <a:avLst>
+                <a:gd name="adj" fmla="val 0"/>
+              </a:avLst>
+            </a:prstGeom>
+            <a:solidFill>
+              <a:schemeClr val="accent4"/>
+            </a:solidFill>
+            <a:ln w="15875">
+              <a:solidFill>
+                <a:schemeClr val="accent4"/>
+              </a:solidFill>
+            </a:ln>
+          </p:spPr>
+          <p:style>
+            <a:lnRef idx="2">
+              <a:schemeClr val="accent4"/>
+            </a:lnRef>
+            <a:fillRef idx="1">
+              <a:schemeClr val="lt1"/>
+            </a:fillRef>
+            <a:effectRef idx="0">
+              <a:schemeClr val="accent4"/>
+            </a:effectRef>
+            <a:fontRef idx="minor">
+              <a:schemeClr val="dk1"/>
+            </a:fontRef>
+          </p:style>
+          <p:txBody>
+            <a:bodyPr rtlCol="0" anchor="ctr" anchorCtr="1"/>
+            <a:lstStyle/>
+            <a:p>
+              <a:pPr marL="0" marR="0" lvl="0" indent="0" algn="ctr" defTabSz="1218804" rtl="0" eaLnBrk="0" fontAlgn="base" latinLnBrk="0" hangingPunct="0">
+                <a:lnSpc>
+                  <a:spcPct val="100000"/>
+                </a:lnSpc>
+                <a:spcBef>
+                  <a:spcPct val="0"/>
+                </a:spcBef>
+                <a:spcAft>
+                  <a:spcPct val="0"/>
+                </a:spcAft>
+                <a:buClrTx/>
+                <a:buSzTx/>
+                <a:buFontTx/>
+                <a:buNone/>
+                <a:tabLst/>
+                <a:defRPr/>
+              </a:pPr>
+              <a:r>
+                <a:rPr kumimoji="1" lang="sv-SE" altLang="ja-JP" sz="1600">
+                  <a:solidFill>
+                    <a:sysClr val="windowText" lastClr="000000"/>
+                  </a:solidFill>
+                  <a:latin typeface="Arial" panose="020B0604020202020204" pitchFamily="34" charset="0"/>
+                  <a:ea typeface="Lato Light" panose="020F0502020204030203" pitchFamily="34" charset="0"/>
+                  <a:cs typeface="Arial" panose="020B0604020202020204" pitchFamily="34" charset="0"/>
+                </a:rPr>
+                <a:t>ML </a:t>
+              </a:r>
+              <a:r>
+                <a:rPr kumimoji="1" lang="sv-SE" altLang="ja-JP" sz="1600" err="1">
+                  <a:solidFill>
+                    <a:sysClr val="windowText" lastClr="000000"/>
+                  </a:solidFill>
+                  <a:latin typeface="Arial" panose="020B0604020202020204" pitchFamily="34" charset="0"/>
+                  <a:ea typeface="Lato Light" panose="020F0502020204030203" pitchFamily="34" charset="0"/>
+                  <a:cs typeface="Arial" panose="020B0604020202020204" pitchFamily="34" charset="0"/>
+                </a:rPr>
+                <a:t>Runtime</a:t>
+              </a:r>
+              <a:endParaRPr kumimoji="1" lang="ja-JP" altLang="en-US" sz="1600" b="0" i="0" strike="noStrike" kern="1200" cap="none" spc="0" normalizeH="0" baseline="0" noProof="0">
+                <a:ln>
+                  <a:noFill/>
+                </a:ln>
+                <a:solidFill>
+                  <a:sysClr val="windowText" lastClr="000000"/>
+                </a:solidFill>
+                <a:effectLst/>
+                <a:uLnTx/>
+                <a:uFillTx/>
+                <a:latin typeface="Arial" panose="020B0604020202020204" pitchFamily="34" charset="0"/>
+                <a:ea typeface="游ゴシック" panose="020B0400000000000000" pitchFamily="34" charset="-128"/>
+                <a:cs typeface="Arial" panose="020B0604020202020204" pitchFamily="34" charset="0"/>
+              </a:endParaRPr>
+            </a:p>
+          </p:txBody>
+        </p:sp>
+        <p:sp>
+          <p:nvSpPr>
+            <p:cNvPr id="45" name="Right Arrow 9">
+              <a:extLst>
+                <a:ext uri="{FF2B5EF4-FFF2-40B4-BE49-F238E27FC236}">
+                  <a16:creationId xmlns:a16="http://schemas.microsoft.com/office/drawing/2014/main" id="{8E95FA96-2E8D-1B64-BD01-8C4E31AB494D}"/>
+                </a:ext>
+              </a:extLst>
+            </p:cNvPr>
+            <p:cNvSpPr>
+              <a:spLocks/>
+            </p:cNvSpPr>
+            <p:nvPr/>
+          </p:nvSpPr>
+          <p:spPr>
+            <a:xfrm>
+              <a:off x="2043729" y="3573392"/>
+              <a:ext cx="270288" cy="535780"/>
+            </a:xfrm>
+            <a:prstGeom prst="rightArrow">
+              <a:avLst/>
+            </a:prstGeom>
+            <a:solidFill>
+              <a:schemeClr val="bg1"/>
+            </a:solidFill>
+            <a:ln>
+              <a:solidFill>
+                <a:schemeClr val="tx2">
+                  <a:lumMod val="40000"/>
+                  <a:lumOff val="60000"/>
+                </a:schemeClr>
+              </a:solidFill>
+            </a:ln>
+          </p:spPr>
+          <p:style>
+            <a:lnRef idx="2">
+              <a:schemeClr val="accent1">
+                <a:shade val="50000"/>
+              </a:schemeClr>
+            </a:lnRef>
+            <a:fillRef idx="1">
+              <a:schemeClr val="accent1"/>
+            </a:fillRef>
+            <a:effectRef idx="0">
+              <a:schemeClr val="accent1"/>
+            </a:effectRef>
+            <a:fontRef idx="minor">
+              <a:schemeClr val="lt1"/>
+            </a:fontRef>
+          </p:style>
+          <p:txBody>
+            <a:bodyPr rtlCol="0" anchor="ctr"/>
+            <a:lstStyle/>
+            <a:p>
+              <a:pPr algn="ctr"/>
+              <a:endParaRPr lang="en-DE">
+                <a:latin typeface="Arial" panose="020B0604020202020204" pitchFamily="34" charset="0"/>
+                <a:cs typeface="Arial" panose="020B0604020202020204" pitchFamily="34" charset="0"/>
+              </a:endParaRPr>
+            </a:p>
+          </p:txBody>
+        </p:sp>
+        <p:sp>
+          <p:nvSpPr>
+            <p:cNvPr id="46" name="角丸四角形 6">
+              <a:extLst>
+                <a:ext uri="{FF2B5EF4-FFF2-40B4-BE49-F238E27FC236}">
+                  <a16:creationId xmlns:a16="http://schemas.microsoft.com/office/drawing/2014/main" id="{5A2633CC-FA49-C38E-8FF7-4BB7478E5E53}"/>
+                </a:ext>
+              </a:extLst>
+            </p:cNvPr>
+            <p:cNvSpPr>
+              <a:spLocks/>
+            </p:cNvSpPr>
+            <p:nvPr/>
+          </p:nvSpPr>
+          <p:spPr>
+            <a:xfrm>
+              <a:off x="940923" y="3320008"/>
+              <a:ext cx="1098040" cy="977868"/>
+            </a:xfrm>
+            <a:prstGeom prst="roundRect">
+              <a:avLst>
+                <a:gd name="adj" fmla="val 0"/>
+              </a:avLst>
+            </a:prstGeom>
+            <a:solidFill>
+              <a:schemeClr val="accent1"/>
+            </a:solidFill>
+            <a:ln w="15875">
+              <a:noFill/>
+            </a:ln>
+          </p:spPr>
+          <p:style>
+            <a:lnRef idx="2">
+              <a:schemeClr val="accent4"/>
+            </a:lnRef>
+            <a:fillRef idx="1">
+              <a:schemeClr val="lt1"/>
+            </a:fillRef>
+            <a:effectRef idx="0">
+              <a:schemeClr val="accent4"/>
+            </a:effectRef>
+            <a:fontRef idx="minor">
+              <a:schemeClr val="dk1"/>
+            </a:fontRef>
+          </p:style>
+          <p:txBody>
+            <a:bodyPr lIns="0" tIns="60960" rIns="0" bIns="60960" rtlCol="0" anchor="ctr" anchorCtr="1"/>
+            <a:lstStyle/>
+            <a:p>
+              <a:pPr marL="0" marR="0" lvl="0" indent="0" algn="ctr" defTabSz="1218804" rtl="0" eaLnBrk="0" fontAlgn="base" latinLnBrk="0" hangingPunct="0">
+                <a:lnSpc>
+                  <a:spcPct val="100000"/>
+                </a:lnSpc>
+                <a:spcBef>
+                  <a:spcPct val="0"/>
+                </a:spcBef>
+                <a:spcAft>
+                  <a:spcPct val="0"/>
+                </a:spcAft>
+                <a:buClrTx/>
+                <a:buSzTx/>
+                <a:buFontTx/>
+                <a:buNone/>
+                <a:tabLst/>
+                <a:defRPr/>
+              </a:pPr>
+              <a:r>
+                <a:rPr kumimoji="1" lang="sv-SE" altLang="ja-JP" sz="1600" dirty="0">
+                  <a:solidFill>
+                    <a:srgbClr val="FFFFFF"/>
+                  </a:solidFill>
+                  <a:latin typeface="Arial" panose="020B0604020202020204" pitchFamily="34" charset="0"/>
+                  <a:ea typeface="Lato Light"/>
+                  <a:cs typeface="Arial" panose="020B0604020202020204" pitchFamily="34" charset="0"/>
+                </a:rPr>
+                <a:t>Optimized</a:t>
+              </a:r>
+              <a:br>
+                <a:rPr kumimoji="1" lang="sv-SE" altLang="ja-JP" sz="1600" b="0" i="0" strike="noStrike" kern="1200" cap="none" spc="0" normalizeH="0" baseline="0" noProof="0" dirty="0">
+                  <a:ln>
+                    <a:noFill/>
+                  </a:ln>
+                  <a:solidFill>
+                    <a:srgbClr val="FFFFFF"/>
+                  </a:solidFill>
+                  <a:effectLst/>
+                  <a:uLnTx/>
+                  <a:uFillTx/>
+                  <a:latin typeface="Arial" panose="020B0604020202020204" pitchFamily="34" charset="0"/>
+                  <a:ea typeface="Lato Light"/>
+                  <a:cs typeface="Arial" panose="020B0604020202020204" pitchFamily="34" charset="0"/>
+                </a:rPr>
+              </a:br>
+              <a:r>
+                <a:rPr kumimoji="1" lang="sv-SE" altLang="ja-JP" sz="1600" b="0" i="0" strike="noStrike" kern="1200" cap="none" spc="0" normalizeH="0" baseline="0" noProof="0" dirty="0">
+                  <a:ln>
+                    <a:noFill/>
+                  </a:ln>
+                  <a:solidFill>
+                    <a:srgbClr val="FFFFFF"/>
+                  </a:solidFill>
+                  <a:effectLst/>
+                  <a:uLnTx/>
+                  <a:uFillTx/>
+                  <a:latin typeface="Arial" panose="020B0604020202020204" pitchFamily="34" charset="0"/>
+                  <a:ea typeface="Lato Light"/>
+                  <a:cs typeface="Arial" panose="020B0604020202020204" pitchFamily="34" charset="0"/>
+                </a:rPr>
+                <a:t>ML Model</a:t>
+              </a:r>
+              <a:endParaRPr kumimoji="0" lang="sv-SE" altLang="ja-JP" sz="1600" b="0" i="0" strike="noStrike" kern="1200" cap="none" spc="0" normalizeH="0" baseline="0" noProof="0" dirty="0">
+                <a:ln>
+                  <a:noFill/>
+                </a:ln>
+                <a:solidFill>
+                  <a:srgbClr val="FFFFFF"/>
+                </a:solidFill>
+                <a:effectLst/>
+                <a:uLnTx/>
+                <a:uFillTx/>
+                <a:latin typeface="Arial" panose="020B0604020202020204" pitchFamily="34" charset="0"/>
+                <a:ea typeface="Lato Light"/>
+                <a:cs typeface="Arial" panose="020B0604020202020204" pitchFamily="34" charset="0"/>
+              </a:endParaRPr>
+            </a:p>
+          </p:txBody>
+        </p:sp>
+      </p:grpSp>
+    </p:spTree>
+    <p:extLst>
+      <p:ext uri="{BB962C8B-B14F-4D97-AF65-F5344CB8AC3E}">
+        <p14:creationId xmlns:p14="http://schemas.microsoft.com/office/powerpoint/2010/main" val="1992346745"/>
       </p:ext>
     </p:extLst>
   </p:cSld>

</xml_diff>

<commit_message>
Aligned example and docu, multi-variant driver  (#2)
* Aligned documentation+example, new Ethos-U driver
* explicit doxygen download link
</commit_message>
<xml_diff>
--- a/documentation/doxygen/general/src/images/overview.pptx
+++ b/documentation/doxygen/general/src/images/overview.pptx
@@ -5,15 +5,16 @@
     <p:sldMasterId id="2147483661" r:id="rId1"/>
   </p:sldMasterIdLst>
   <p:notesMasterIdLst>
-    <p:notesMasterId r:id="rId5"/>
+    <p:notesMasterId r:id="rId6"/>
   </p:notesMasterIdLst>
   <p:handoutMasterIdLst>
-    <p:handoutMasterId r:id="rId6"/>
+    <p:handoutMasterId r:id="rId7"/>
   </p:handoutMasterIdLst>
   <p:sldIdLst>
     <p:sldId id="548" r:id="rId2"/>
     <p:sldId id="2147479562" r:id="rId3"/>
     <p:sldId id="549" r:id="rId4"/>
+    <p:sldId id="2147479563" r:id="rId5"/>
   </p:sldIdLst>
   <p:sldSz cx="12192000" cy="6858000"/>
   <p:notesSz cx="6858000" cy="9144000"/>
@@ -261,7 +262,7 @@
           <a:p>
             <a:fld id="{008FFADC-39A7-449E-8C68-8776E6FB3C1A}" type="datetimeFigureOut">
               <a:rPr lang="en-GB" smtClean="0"/>
-              <a:t>07/08/2026</a:t>
+              <a:t>17/08/2026</a:t>
             </a:fld>
             <a:endParaRPr lang="en-GB"/>
           </a:p>
@@ -438,7 +439,7 @@
           <a:p>
             <a:fld id="{30B9BAAB-B703-4BB5-9D08-B460FC03C23A}" type="datetimeFigureOut">
               <a:rPr lang="en-GB" smtClean="0"/>
-              <a:t>07/08/2026</a:t>
+              <a:t>17/08/2026</a:t>
             </a:fld>
             <a:endParaRPr lang="en-GB"/>
           </a:p>
@@ -814,6 +815,147 @@
     <p:extLst>
       <p:ext uri="{BB962C8B-B14F-4D97-AF65-F5344CB8AC3E}">
         <p14:creationId xmlns:p14="http://schemas.microsoft.com/office/powerpoint/2010/main" val="1343268853"/>
+      </p:ext>
+    </p:extLst>
+  </p:cSld>
+  <p:clrMapOvr>
+    <a:masterClrMapping/>
+  </p:clrMapOvr>
+</p:notes>
+</file>
+
+<file path=ppt/notesSlides/notesSlide2.xml><?xml version="1.0" encoding="utf-8"?>
+<p:notes xmlns:a="http://schemas.openxmlformats.org/drawingml/2006/main" xmlns:r="http://schemas.openxmlformats.org/officeDocument/2006/relationships" xmlns:p="http://schemas.openxmlformats.org/presentationml/2006/main">
+  <p:cSld>
+    <p:spTree>
+      <p:nvGrpSpPr>
+        <p:cNvPr id="1" name="">
+          <a:extLst>
+            <a:ext uri="{FF2B5EF4-FFF2-40B4-BE49-F238E27FC236}">
+              <a16:creationId xmlns:a16="http://schemas.microsoft.com/office/drawing/2014/main" id="{E183BBA8-B3E4-715D-038D-7794E3BDE00A}"/>
+            </a:ext>
+          </a:extLst>
+        </p:cNvPr>
+        <p:cNvGrpSpPr/>
+        <p:nvPr/>
+      </p:nvGrpSpPr>
+      <p:grpSpPr>
+        <a:xfrm>
+          <a:off x="0" y="0"/>
+          <a:ext cx="0" cy="0"/>
+          <a:chOff x="0" y="0"/>
+          <a:chExt cx="0" cy="0"/>
+        </a:xfrm>
+      </p:grpSpPr>
+      <p:sp>
+        <p:nvSpPr>
+          <p:cNvPr id="2" name="Slide Image Placeholder 1">
+            <a:extLst>
+              <a:ext uri="{FF2B5EF4-FFF2-40B4-BE49-F238E27FC236}">
+                <a16:creationId xmlns:a16="http://schemas.microsoft.com/office/drawing/2014/main" id="{4711F47A-60A6-7834-DB1E-7298B192A56D}"/>
+              </a:ext>
+            </a:extLst>
+          </p:cNvPr>
+          <p:cNvSpPr>
+            <a:spLocks noGrp="1" noRot="1" noChangeAspect="1"/>
+          </p:cNvSpPr>
+          <p:nvPr>
+            <p:ph type="sldImg"/>
+          </p:nvPr>
+        </p:nvSpPr>
+        <p:spPr/>
+        <p:txBody>
+          <a:bodyPr/>
+          <a:lstStyle/>
+          <a:p>
+            <a:endParaRPr lang="en-US"/>
+          </a:p>
+        </p:txBody>
+      </p:sp>
+      <p:sp>
+        <p:nvSpPr>
+          <p:cNvPr id="3" name="Notes Placeholder 2">
+            <a:extLst>
+              <a:ext uri="{FF2B5EF4-FFF2-40B4-BE49-F238E27FC236}">
+                <a16:creationId xmlns:a16="http://schemas.microsoft.com/office/drawing/2014/main" id="{0E2FF2B3-6720-ED98-3C26-D3EF19EC894E}"/>
+              </a:ext>
+            </a:extLst>
+          </p:cNvPr>
+          <p:cNvSpPr>
+            <a:spLocks noGrp="1"/>
+          </p:cNvSpPr>
+          <p:nvPr>
+            <p:ph type="body" idx="1"/>
+          </p:nvPr>
+        </p:nvSpPr>
+        <p:spPr/>
+        <p:txBody>
+          <a:bodyPr/>
+          <a:lstStyle/>
+          <a:p>
+            <a:r>
+              <a:rPr lang="en-US" dirty="0"/>
+              <a:t>ML models from ecosystem partners or open-source model zoos such as Hugging Face are quantized and optimized for embedded deployment. CMSIS-NN executes these optimized models on Cortex-M processors. For Ethos-U NPU targets, Vela converts model operations for NPU acceleration, while operations that cannot be converted continue to run on Cortex-M via CMSIS-NN.</a:t>
+            </a:r>
+          </a:p>
+          <a:p>
+            <a:endParaRPr lang="en-US" dirty="0"/>
+          </a:p>
+          <a:p>
+            <a:r>
+              <a:rPr lang="en-US" dirty="0"/>
+              <a:t>Using these workflows, developers can deploy trained models from </a:t>
+            </a:r>
+            <a:r>
+              <a:rPr lang="en-US" dirty="0" err="1"/>
+              <a:t>PyTorch</a:t>
+            </a:r>
+            <a:r>
+              <a:rPr lang="en-US" dirty="0"/>
+              <a:t>, TensorFlow, and other frameworks onto Arm targets with optimal performance and energy efficiency, enabling intelligent capabilities in IoT devices, wearables, industrial sensors, and other edge computing applications.</a:t>
+            </a:r>
+          </a:p>
+        </p:txBody>
+      </p:sp>
+      <p:sp>
+        <p:nvSpPr>
+          <p:cNvPr id="4" name="Slide Number Placeholder 3">
+            <a:extLst>
+              <a:ext uri="{FF2B5EF4-FFF2-40B4-BE49-F238E27FC236}">
+                <a16:creationId xmlns:a16="http://schemas.microsoft.com/office/drawing/2014/main" id="{B59038E3-3EF6-3220-097E-2BA6573C930E}"/>
+              </a:ext>
+            </a:extLst>
+          </p:cNvPr>
+          <p:cNvSpPr>
+            <a:spLocks noGrp="1"/>
+          </p:cNvSpPr>
+          <p:nvPr>
+            <p:ph type="sldNum" sz="quarter" idx="5"/>
+          </p:nvPr>
+        </p:nvSpPr>
+        <p:spPr/>
+        <p:txBody>
+          <a:bodyPr/>
+          <a:lstStyle/>
+          <a:p>
+            <a:pPr>
+              <a:defRPr/>
+            </a:pPr>
+            <a:fld id="{3B16354E-6974-4833-AB87-3220A0835E84}" type="slidenum">
+              <a:rPr lang="en-US" altLang="en-US" smtClean="0"/>
+              <a:pPr>
+                <a:defRPr/>
+              </a:pPr>
+              <a:t>4</a:t>
+            </a:fld>
+            <a:endParaRPr lang="en-US" altLang="en-US"/>
+          </a:p>
+        </p:txBody>
+      </p:sp>
+    </p:spTree>
+    <p:extLst>
+      <p:ext uri="{BB962C8B-B14F-4D97-AF65-F5344CB8AC3E}">
+        <p14:creationId xmlns:p14="http://schemas.microsoft.com/office/powerpoint/2010/main" val="2358853907"/>
       </p:ext>
     </p:extLst>
   </p:cSld>
@@ -10509,6 +10651,2014 @@
     <p:extLst>
       <p:ext uri="{BB962C8B-B14F-4D97-AF65-F5344CB8AC3E}">
         <p14:creationId xmlns:p14="http://schemas.microsoft.com/office/powerpoint/2010/main" val="405019737"/>
+      </p:ext>
+    </p:extLst>
+  </p:cSld>
+  <p:clrMapOvr>
+    <a:masterClrMapping/>
+  </p:clrMapOvr>
+</p:sld>
+</file>
+
+<file path=ppt/slides/slide4.xml><?xml version="1.0" encoding="utf-8"?>
+<p:sld xmlns:a="http://schemas.openxmlformats.org/drawingml/2006/main" xmlns:r="http://schemas.openxmlformats.org/officeDocument/2006/relationships" xmlns:p="http://schemas.openxmlformats.org/presentationml/2006/main">
+  <p:cSld>
+    <p:spTree>
+      <p:nvGrpSpPr>
+        <p:cNvPr id="1" name="">
+          <a:extLst>
+            <a:ext uri="{FF2B5EF4-FFF2-40B4-BE49-F238E27FC236}">
+              <a16:creationId xmlns:a16="http://schemas.microsoft.com/office/drawing/2014/main" id="{21F35EA9-9DA8-055C-3DD8-B2078FF02732}"/>
+            </a:ext>
+          </a:extLst>
+        </p:cNvPr>
+        <p:cNvGrpSpPr/>
+        <p:nvPr/>
+      </p:nvGrpSpPr>
+      <p:grpSpPr>
+        <a:xfrm>
+          <a:off x="0" y="0"/>
+          <a:ext cx="0" cy="0"/>
+          <a:chOff x="0" y="0"/>
+          <a:chExt cx="0" cy="0"/>
+        </a:xfrm>
+      </p:grpSpPr>
+      <p:sp>
+        <p:nvSpPr>
+          <p:cNvPr id="2" name="Title 1">
+            <a:extLst>
+              <a:ext uri="{FF2B5EF4-FFF2-40B4-BE49-F238E27FC236}">
+                <a16:creationId xmlns:a16="http://schemas.microsoft.com/office/drawing/2014/main" id="{10CE91E9-F49C-F2B4-1591-00C1CE9D8807}"/>
+              </a:ext>
+            </a:extLst>
+          </p:cNvPr>
+          <p:cNvSpPr>
+            <a:spLocks noGrp="1"/>
+          </p:cNvSpPr>
+          <p:nvPr>
+            <p:ph type="title"/>
+          </p:nvPr>
+        </p:nvSpPr>
+        <p:spPr/>
+        <p:txBody>
+          <a:bodyPr/>
+          <a:lstStyle/>
+          <a:p>
+            <a:r>
+              <a:rPr lang="en-US"/>
+              <a:t>Ethos-U Optimized Software Flow for </a:t>
+            </a:r>
+            <a:r>
+              <a:rPr lang="en-US" err="1"/>
+              <a:t>Tensorflow</a:t>
+            </a:r>
+            <a:r>
+              <a:rPr lang="en-US"/>
+              <a:t>/</a:t>
+            </a:r>
+            <a:r>
+              <a:rPr lang="en-US" err="1"/>
+              <a:t>PyTorch</a:t>
+            </a:r>
+            <a:endParaRPr lang="en-US"/>
+          </a:p>
+        </p:txBody>
+      </p:sp>
+      <p:sp>
+        <p:nvSpPr>
+          <p:cNvPr id="29" name="Text Placeholder 28">
+            <a:extLst>
+              <a:ext uri="{FF2B5EF4-FFF2-40B4-BE49-F238E27FC236}">
+                <a16:creationId xmlns:a16="http://schemas.microsoft.com/office/drawing/2014/main" id="{BF9C00EE-D2D0-725F-1CDE-43F90D3891FB}"/>
+              </a:ext>
+            </a:extLst>
+          </p:cNvPr>
+          <p:cNvSpPr>
+            <a:spLocks noGrp="1"/>
+          </p:cNvSpPr>
+          <p:nvPr>
+            <p:ph type="body" sz="quarter" idx="13"/>
+          </p:nvPr>
+        </p:nvSpPr>
+        <p:spPr/>
+        <p:txBody>
+          <a:bodyPr/>
+          <a:lstStyle/>
+          <a:p>
+            <a:r>
+              <a:rPr lang="en-US">
+                <a:hlinkClick r:id="rId3"/>
+              </a:rPr>
+              <a:t>github.com/Arm-Examples#edge-ai-and-machine-learning</a:t>
+            </a:r>
+            <a:endParaRPr lang="en-US"/>
+          </a:p>
+        </p:txBody>
+      </p:sp>
+      <p:grpSp>
+        <p:nvGrpSpPr>
+          <p:cNvPr id="47" name="Group 46">
+            <a:extLst>
+              <a:ext uri="{FF2B5EF4-FFF2-40B4-BE49-F238E27FC236}">
+                <a16:creationId xmlns:a16="http://schemas.microsoft.com/office/drawing/2014/main" id="{7FDEBA3B-14B2-3A05-B96E-C0A02F5B034C}"/>
+              </a:ext>
+            </a:extLst>
+          </p:cNvPr>
+          <p:cNvGrpSpPr/>
+          <p:nvPr/>
+        </p:nvGrpSpPr>
+        <p:grpSpPr>
+          <a:xfrm>
+            <a:off x="835176" y="2094471"/>
+            <a:ext cx="10585491" cy="3037366"/>
+            <a:chOff x="835176" y="2094471"/>
+            <a:chExt cx="10585491" cy="3037366"/>
+          </a:xfrm>
+        </p:grpSpPr>
+        <p:sp>
+          <p:nvSpPr>
+            <p:cNvPr id="11" name="Process 65">
+              <a:extLst>
+                <a:ext uri="{FF2B5EF4-FFF2-40B4-BE49-F238E27FC236}">
+                  <a16:creationId xmlns:a16="http://schemas.microsoft.com/office/drawing/2014/main" id="{18502500-A3A2-ABB6-075E-8DAE582BF83D}"/>
+                </a:ext>
+              </a:extLst>
+            </p:cNvPr>
+            <p:cNvSpPr>
+              <a:spLocks/>
+            </p:cNvSpPr>
+            <p:nvPr/>
+          </p:nvSpPr>
+          <p:spPr>
+            <a:xfrm>
+              <a:off x="6282610" y="2094471"/>
+              <a:ext cx="5138057" cy="3037366"/>
+            </a:xfrm>
+            <a:prstGeom prst="flowChartProcess">
+              <a:avLst/>
+            </a:prstGeom>
+            <a:solidFill>
+              <a:schemeClr val="bg2">
+                <a:lumMod val="50000"/>
+              </a:schemeClr>
+            </a:solidFill>
+            <a:ln w="0">
+              <a:solidFill>
+                <a:schemeClr val="bg1"/>
+              </a:solidFill>
+            </a:ln>
+          </p:spPr>
+          <p:style>
+            <a:lnRef idx="2">
+              <a:schemeClr val="accent1">
+                <a:shade val="50000"/>
+              </a:schemeClr>
+            </a:lnRef>
+            <a:fillRef idx="1">
+              <a:schemeClr val="accent1"/>
+            </a:fillRef>
+            <a:effectRef idx="0">
+              <a:schemeClr val="accent1"/>
+            </a:effectRef>
+            <a:fontRef idx="minor">
+              <a:schemeClr val="lt1"/>
+            </a:fontRef>
+          </p:style>
+          <p:txBody>
+            <a:bodyPr tIns="108000" rtlCol="0" anchor="t"/>
+            <a:lstStyle/>
+            <a:p>
+              <a:pPr defTabSz="1219170">
+                <a:defRPr/>
+              </a:pPr>
+              <a:r>
+                <a:rPr kumimoji="1" lang="en-US" sz="1600" dirty="0">
+                  <a:solidFill>
+                    <a:srgbClr val="FFFFFF"/>
+                  </a:solidFill>
+                  <a:latin typeface="Arial" panose="020B0604020202020204" pitchFamily="34" charset="0"/>
+                  <a:cs typeface="Arial" panose="020B0604020202020204" pitchFamily="34" charset="0"/>
+                </a:rPr>
+                <a:t>DEVICE with Ethos-U</a:t>
+              </a:r>
+            </a:p>
+          </p:txBody>
+        </p:sp>
+        <p:sp>
+          <p:nvSpPr>
+            <p:cNvPr id="14" name="角丸四角形 7">
+              <a:extLst>
+                <a:ext uri="{FF2B5EF4-FFF2-40B4-BE49-F238E27FC236}">
+                  <a16:creationId xmlns:a16="http://schemas.microsoft.com/office/drawing/2014/main" id="{BD4B5930-02E4-A9A3-78CE-0A29FC84E13B}"/>
+                </a:ext>
+              </a:extLst>
+            </p:cNvPr>
+            <p:cNvSpPr>
+              <a:spLocks/>
+            </p:cNvSpPr>
+            <p:nvPr/>
+          </p:nvSpPr>
+          <p:spPr>
+            <a:xfrm>
+              <a:off x="8616018" y="2576367"/>
+              <a:ext cx="1169871" cy="1007207"/>
+            </a:xfrm>
+            <a:prstGeom prst="roundRect">
+              <a:avLst>
+                <a:gd name="adj" fmla="val 0"/>
+              </a:avLst>
+            </a:prstGeom>
+            <a:solidFill>
+              <a:schemeClr val="accent1"/>
+            </a:solidFill>
+            <a:ln>
+              <a:noFill/>
+            </a:ln>
+          </p:spPr>
+          <p:style>
+            <a:lnRef idx="0">
+              <a:scrgbClr r="0" g="0" b="0"/>
+            </a:lnRef>
+            <a:fillRef idx="0">
+              <a:scrgbClr r="0" g="0" b="0"/>
+            </a:fillRef>
+            <a:effectRef idx="0">
+              <a:scrgbClr r="0" g="0" b="0"/>
+            </a:effectRef>
+            <a:fontRef idx="minor">
+              <a:schemeClr val="lt1"/>
+            </a:fontRef>
+          </p:style>
+          <p:txBody>
+            <a:bodyPr lIns="0" rIns="0" rtlCol="0" anchor="ctr" anchorCtr="1"/>
+            <a:lstStyle/>
+            <a:p>
+              <a:pPr marL="0" marR="0" lvl="0" indent="0" algn="ctr" defTabSz="1218804" rtl="0" eaLnBrk="0" fontAlgn="base" latinLnBrk="0" hangingPunct="0">
+                <a:lnSpc>
+                  <a:spcPct val="100000"/>
+                </a:lnSpc>
+                <a:spcBef>
+                  <a:spcPct val="0"/>
+                </a:spcBef>
+                <a:spcAft>
+                  <a:spcPct val="0"/>
+                </a:spcAft>
+                <a:buClrTx/>
+                <a:buSzTx/>
+                <a:buFontTx/>
+                <a:buNone/>
+                <a:tabLst/>
+                <a:defRPr/>
+              </a:pPr>
+              <a:r>
+                <a:rPr kumimoji="1" lang="sv-SE" altLang="ja-JP" sz="1600" b="0" i="0" strike="noStrike" kern="1200" cap="none" spc="0" normalizeH="0" baseline="0" noProof="0" dirty="0">
+                  <a:ln>
+                    <a:noFill/>
+                  </a:ln>
+                  <a:solidFill>
+                    <a:prstClr val="white"/>
+                  </a:solidFill>
+                  <a:effectLst/>
+                  <a:uLnTx/>
+                  <a:uFillTx/>
+                  <a:latin typeface="Arial" panose="020B0604020202020204" pitchFamily="34" charset="0"/>
+                  <a:ea typeface="Lato Light" panose="020F0502020204030203" pitchFamily="34" charset="0"/>
+                  <a:cs typeface="Arial" panose="020B0604020202020204" pitchFamily="34" charset="0"/>
+                </a:rPr>
+                <a:t>CMSIS-NN</a:t>
+              </a:r>
+              <a:endParaRPr kumimoji="0" lang="en-US" sz="1600" b="0" i="0" strike="noStrike" kern="1200" cap="none" spc="0" normalizeH="0" baseline="0" noProof="0" dirty="0">
+                <a:ln>
+                  <a:noFill/>
+                </a:ln>
+                <a:solidFill>
+                  <a:prstClr val="white"/>
+                </a:solidFill>
+                <a:effectLst/>
+                <a:uLnTx/>
+                <a:uFillTx/>
+                <a:latin typeface="Arial" panose="020B0604020202020204" pitchFamily="34" charset="0"/>
+                <a:ea typeface="Lato Light" panose="020F0502020204030203" pitchFamily="34" charset="0"/>
+                <a:cs typeface="Arial" panose="020B0604020202020204" pitchFamily="34" charset="0"/>
+              </a:endParaRPr>
+            </a:p>
+            <a:p>
+              <a:pPr marL="0" marR="0" lvl="0" indent="0" algn="ctr" defTabSz="1218804" rtl="0" eaLnBrk="0" fontAlgn="base" latinLnBrk="0" hangingPunct="0">
+                <a:lnSpc>
+                  <a:spcPct val="100000"/>
+                </a:lnSpc>
+                <a:spcBef>
+                  <a:spcPct val="0"/>
+                </a:spcBef>
+                <a:spcAft>
+                  <a:spcPct val="0"/>
+                </a:spcAft>
+                <a:buClrTx/>
+                <a:buSzTx/>
+                <a:buFontTx/>
+                <a:buNone/>
+                <a:tabLst/>
+                <a:defRPr/>
+              </a:pPr>
+              <a:r>
+                <a:rPr kumimoji="1" lang="sv-SE" altLang="ja-JP" sz="1600" b="0" i="0" strike="noStrike" kern="1200" cap="none" spc="0" normalizeH="0" baseline="0" noProof="0" dirty="0">
+                  <a:ln>
+                    <a:noFill/>
+                  </a:ln>
+                  <a:solidFill>
+                    <a:prstClr val="white"/>
+                  </a:solidFill>
+                  <a:effectLst/>
+                  <a:uLnTx/>
+                  <a:uFillTx/>
+                  <a:latin typeface="Arial" panose="020B0604020202020204" pitchFamily="34" charset="0"/>
+                  <a:ea typeface="Lato Light" panose="020F0502020204030203" pitchFamily="34" charset="0"/>
+                  <a:cs typeface="Arial" panose="020B0604020202020204" pitchFamily="34" charset="0"/>
+                </a:rPr>
+                <a:t>Optimized Kernels</a:t>
+              </a:r>
+              <a:endParaRPr kumimoji="0" lang="en-US" altLang="ja-JP" sz="1600" b="0" i="0" strike="noStrike" kern="1200" cap="none" spc="0" normalizeH="0" baseline="0" noProof="0" dirty="0">
+                <a:ln>
+                  <a:noFill/>
+                </a:ln>
+                <a:solidFill>
+                  <a:prstClr val="white"/>
+                </a:solidFill>
+                <a:effectLst/>
+                <a:uLnTx/>
+                <a:uFillTx/>
+                <a:latin typeface="Arial" panose="020B0604020202020204" pitchFamily="34" charset="0"/>
+                <a:ea typeface="Lato Light" panose="020F0502020204030203" pitchFamily="34" charset="0"/>
+                <a:cs typeface="Arial" panose="020B0604020202020204" pitchFamily="34" charset="0"/>
+              </a:endParaRPr>
+            </a:p>
+          </p:txBody>
+        </p:sp>
+        <p:sp>
+          <p:nvSpPr>
+            <p:cNvPr id="15" name="Rectangle 14">
+              <a:extLst>
+                <a:ext uri="{FF2B5EF4-FFF2-40B4-BE49-F238E27FC236}">
+                  <a16:creationId xmlns:a16="http://schemas.microsoft.com/office/drawing/2014/main" id="{DC3469AD-C44F-E151-C9AA-AEE3D48D6FCA}"/>
+                </a:ext>
+              </a:extLst>
+            </p:cNvPr>
+            <p:cNvSpPr>
+              <a:spLocks/>
+            </p:cNvSpPr>
+            <p:nvPr/>
+          </p:nvSpPr>
+          <p:spPr>
+            <a:xfrm>
+              <a:off x="10110645" y="2582562"/>
+              <a:ext cx="1169871" cy="991024"/>
+            </a:xfrm>
+            <a:prstGeom prst="rect">
+              <a:avLst/>
+            </a:prstGeom>
+            <a:solidFill>
+              <a:schemeClr val="accent1"/>
+            </a:solidFill>
+            <a:ln>
+              <a:noFill/>
+            </a:ln>
+          </p:spPr>
+          <p:style>
+            <a:lnRef idx="0">
+              <a:scrgbClr r="0" g="0" b="0"/>
+            </a:lnRef>
+            <a:fillRef idx="0">
+              <a:scrgbClr r="0" g="0" b="0"/>
+            </a:fillRef>
+            <a:effectRef idx="0">
+              <a:scrgbClr r="0" g="0" b="0"/>
+            </a:effectRef>
+            <a:fontRef idx="minor">
+              <a:schemeClr val="lt1"/>
+            </a:fontRef>
+          </p:style>
+          <p:txBody>
+            <a:bodyPr rtlCol="0" anchor="ctr"/>
+            <a:lstStyle/>
+            <a:p>
+              <a:pPr marL="0" marR="0" lvl="0" indent="0" algn="ctr" defTabSz="1218804" rtl="0" eaLnBrk="0" fontAlgn="base" latinLnBrk="0" hangingPunct="0">
+                <a:lnSpc>
+                  <a:spcPct val="100000"/>
+                </a:lnSpc>
+                <a:spcBef>
+                  <a:spcPct val="0"/>
+                </a:spcBef>
+                <a:spcAft>
+                  <a:spcPct val="0"/>
+                </a:spcAft>
+                <a:buClrTx/>
+                <a:buSzTx/>
+                <a:buFontTx/>
+                <a:buNone/>
+                <a:tabLst/>
+                <a:defRPr/>
+              </a:pPr>
+              <a:r>
+                <a:rPr kumimoji="0" lang="en-GB" sz="1600" b="0" i="0" strike="noStrike" kern="1200" cap="none" spc="0" normalizeH="0" baseline="0" noProof="0" dirty="0">
+                  <a:ln>
+                    <a:noFill/>
+                  </a:ln>
+                  <a:solidFill>
+                    <a:prstClr val="white"/>
+                  </a:solidFill>
+                  <a:effectLst/>
+                  <a:uLnTx/>
+                  <a:uFillTx/>
+                  <a:latin typeface="Arial" panose="020B0604020202020204" pitchFamily="34" charset="0"/>
+                  <a:ea typeface="Lato Light" panose="020F0502020204030203" pitchFamily="34" charset="0"/>
+                  <a:cs typeface="Arial" panose="020B0604020202020204" pitchFamily="34" charset="0"/>
+                </a:rPr>
+                <a:t>Cortex-M</a:t>
+              </a:r>
+            </a:p>
+            <a:p>
+              <a:pPr marL="0" marR="0" lvl="0" indent="0" algn="ctr" defTabSz="1218804" rtl="0" eaLnBrk="0" fontAlgn="base" latinLnBrk="0" hangingPunct="0">
+                <a:lnSpc>
+                  <a:spcPct val="100000"/>
+                </a:lnSpc>
+                <a:spcBef>
+                  <a:spcPct val="0"/>
+                </a:spcBef>
+                <a:spcAft>
+                  <a:spcPct val="0"/>
+                </a:spcAft>
+                <a:buClrTx/>
+                <a:buSzTx/>
+                <a:buFontTx/>
+                <a:buNone/>
+                <a:tabLst/>
+                <a:defRPr/>
+              </a:pPr>
+              <a:r>
+                <a:rPr kumimoji="0" lang="en-GB" sz="1600" b="0" i="0" strike="noStrike" kern="1200" cap="none" spc="0" normalizeH="0" baseline="0" noProof="0" dirty="0">
+                  <a:ln>
+                    <a:noFill/>
+                  </a:ln>
+                  <a:solidFill>
+                    <a:prstClr val="white"/>
+                  </a:solidFill>
+                  <a:effectLst/>
+                  <a:uLnTx/>
+                  <a:uFillTx/>
+                  <a:latin typeface="Arial" panose="020B0604020202020204" pitchFamily="34" charset="0"/>
+                  <a:ea typeface="Lato Light" panose="020F0502020204030203" pitchFamily="34" charset="0"/>
+                  <a:cs typeface="Arial" panose="020B0604020202020204" pitchFamily="34" charset="0"/>
+                </a:rPr>
+                <a:t>CPU</a:t>
+              </a:r>
+            </a:p>
+          </p:txBody>
+        </p:sp>
+        <p:sp>
+          <p:nvSpPr>
+            <p:cNvPr id="18" name="角丸四角形 7">
+              <a:extLst>
+                <a:ext uri="{FF2B5EF4-FFF2-40B4-BE49-F238E27FC236}">
+                  <a16:creationId xmlns:a16="http://schemas.microsoft.com/office/drawing/2014/main" id="{D69323CD-3A99-268C-7957-FB66E4197C19}"/>
+                </a:ext>
+              </a:extLst>
+            </p:cNvPr>
+            <p:cNvSpPr>
+              <a:spLocks/>
+            </p:cNvSpPr>
+            <p:nvPr/>
+          </p:nvSpPr>
+          <p:spPr>
+            <a:xfrm>
+              <a:off x="8622530" y="4050495"/>
+              <a:ext cx="1169871" cy="991024"/>
+            </a:xfrm>
+            <a:prstGeom prst="roundRect">
+              <a:avLst>
+                <a:gd name="adj" fmla="val 0"/>
+              </a:avLst>
+            </a:prstGeom>
+            <a:solidFill>
+              <a:schemeClr val="accent1">
+                <a:lumMod val="75000"/>
+              </a:schemeClr>
+            </a:solidFill>
+            <a:ln>
+              <a:noFill/>
+            </a:ln>
+          </p:spPr>
+          <p:style>
+            <a:lnRef idx="0">
+              <a:scrgbClr r="0" g="0" b="0"/>
+            </a:lnRef>
+            <a:fillRef idx="0">
+              <a:scrgbClr r="0" g="0" b="0"/>
+            </a:fillRef>
+            <a:effectRef idx="0">
+              <a:scrgbClr r="0" g="0" b="0"/>
+            </a:effectRef>
+            <a:fontRef idx="minor">
+              <a:schemeClr val="lt1"/>
+            </a:fontRef>
+          </p:style>
+          <p:txBody>
+            <a:bodyPr rtlCol="0" anchor="ctr" anchorCtr="1"/>
+            <a:lstStyle/>
+            <a:p>
+              <a:pPr marL="0" marR="0" lvl="0" indent="0" algn="ctr" defTabSz="1218804" rtl="0" eaLnBrk="0" fontAlgn="base" latinLnBrk="0" hangingPunct="0">
+                <a:lnSpc>
+                  <a:spcPct val="100000"/>
+                </a:lnSpc>
+                <a:spcBef>
+                  <a:spcPct val="0"/>
+                </a:spcBef>
+                <a:spcAft>
+                  <a:spcPct val="0"/>
+                </a:spcAft>
+                <a:buClrTx/>
+                <a:buSzTx/>
+                <a:buFontTx/>
+                <a:buNone/>
+                <a:tabLst/>
+                <a:defRPr/>
+              </a:pPr>
+              <a:r>
+                <a:rPr kumimoji="1" lang="sv-SE" altLang="ja-JP" sz="1600" b="0" i="0" strike="noStrike" kern="1200" cap="none" spc="0" normalizeH="0" baseline="0" noProof="0" dirty="0">
+                  <a:ln>
+                    <a:noFill/>
+                  </a:ln>
+                  <a:solidFill>
+                    <a:prstClr val="white"/>
+                  </a:solidFill>
+                  <a:effectLst/>
+                  <a:uLnTx/>
+                  <a:uFillTx/>
+                  <a:latin typeface="Arial" panose="020B0604020202020204" pitchFamily="34" charset="0"/>
+                  <a:ea typeface="Lato Light" panose="020F0502020204030203" pitchFamily="34" charset="0"/>
+                  <a:cs typeface="Arial" panose="020B0604020202020204" pitchFamily="34" charset="0"/>
+                </a:rPr>
+                <a:t>Ethos-U Driver</a:t>
+              </a:r>
+              <a:endParaRPr kumimoji="0" lang="en-US" altLang="ja-JP" sz="1600" b="0" i="0" strike="noStrike" kern="1200" cap="none" spc="0" normalizeH="0" baseline="0" noProof="0" dirty="0">
+                <a:ln>
+                  <a:noFill/>
+                </a:ln>
+                <a:solidFill>
+                  <a:prstClr val="white"/>
+                </a:solidFill>
+                <a:effectLst/>
+                <a:uLnTx/>
+                <a:uFillTx/>
+                <a:latin typeface="Arial" panose="020B0604020202020204" pitchFamily="34" charset="0"/>
+                <a:ea typeface="Lato Light" panose="020F0502020204030203" pitchFamily="34" charset="0"/>
+                <a:cs typeface="Arial" panose="020B0604020202020204" pitchFamily="34" charset="0"/>
+              </a:endParaRPr>
+            </a:p>
+          </p:txBody>
+        </p:sp>
+        <p:sp>
+          <p:nvSpPr>
+            <p:cNvPr id="35" name="Right Arrow 34">
+              <a:extLst>
+                <a:ext uri="{FF2B5EF4-FFF2-40B4-BE49-F238E27FC236}">
+                  <a16:creationId xmlns:a16="http://schemas.microsoft.com/office/drawing/2014/main" id="{93013D7F-D8DD-D7C7-C400-D4DA98B5730C}"/>
+                </a:ext>
+              </a:extLst>
+            </p:cNvPr>
+            <p:cNvSpPr>
+              <a:spLocks/>
+            </p:cNvSpPr>
+            <p:nvPr/>
+          </p:nvSpPr>
+          <p:spPr>
+            <a:xfrm>
+              <a:off x="9797307" y="2823683"/>
+              <a:ext cx="295860" cy="535780"/>
+            </a:xfrm>
+            <a:prstGeom prst="rightArrow">
+              <a:avLst/>
+            </a:prstGeom>
+            <a:solidFill>
+              <a:schemeClr val="bg1"/>
+            </a:solidFill>
+            <a:ln>
+              <a:solidFill>
+                <a:schemeClr val="tx2">
+                  <a:lumMod val="40000"/>
+                  <a:lumOff val="60000"/>
+                </a:schemeClr>
+              </a:solidFill>
+            </a:ln>
+          </p:spPr>
+          <p:style>
+            <a:lnRef idx="2">
+              <a:schemeClr val="accent1">
+                <a:shade val="50000"/>
+              </a:schemeClr>
+            </a:lnRef>
+            <a:fillRef idx="1">
+              <a:schemeClr val="accent1"/>
+            </a:fillRef>
+            <a:effectRef idx="0">
+              <a:schemeClr val="accent1"/>
+            </a:effectRef>
+            <a:fontRef idx="minor">
+              <a:schemeClr val="lt1"/>
+            </a:fontRef>
+          </p:style>
+          <p:txBody>
+            <a:bodyPr rtlCol="0" anchor="ctr"/>
+            <a:lstStyle/>
+            <a:p>
+              <a:pPr algn="ctr"/>
+              <a:endParaRPr lang="en-DE">
+                <a:latin typeface="Arial" panose="020B0604020202020204" pitchFamily="34" charset="0"/>
+                <a:cs typeface="Arial" panose="020B0604020202020204" pitchFamily="34" charset="0"/>
+              </a:endParaRPr>
+            </a:p>
+          </p:txBody>
+        </p:sp>
+        <p:sp>
+          <p:nvSpPr>
+            <p:cNvPr id="3" name="角丸四角形 7">
+              <a:extLst>
+                <a:ext uri="{FF2B5EF4-FFF2-40B4-BE49-F238E27FC236}">
+                  <a16:creationId xmlns:a16="http://schemas.microsoft.com/office/drawing/2014/main" id="{26B4E428-A624-60D3-CF7B-FD718232E9A5}"/>
+                </a:ext>
+              </a:extLst>
+            </p:cNvPr>
+            <p:cNvSpPr>
+              <a:spLocks/>
+            </p:cNvSpPr>
+            <p:nvPr/>
+          </p:nvSpPr>
+          <p:spPr>
+            <a:xfrm>
+              <a:off x="10116823" y="4050495"/>
+              <a:ext cx="1169871" cy="991024"/>
+            </a:xfrm>
+            <a:prstGeom prst="roundRect">
+              <a:avLst>
+                <a:gd name="adj" fmla="val 0"/>
+              </a:avLst>
+            </a:prstGeom>
+            <a:solidFill>
+              <a:schemeClr val="accent1">
+                <a:lumMod val="75000"/>
+              </a:schemeClr>
+            </a:solidFill>
+            <a:ln>
+              <a:noFill/>
+            </a:ln>
+          </p:spPr>
+          <p:style>
+            <a:lnRef idx="0">
+              <a:scrgbClr r="0" g="0" b="0"/>
+            </a:lnRef>
+            <a:fillRef idx="0">
+              <a:scrgbClr r="0" g="0" b="0"/>
+            </a:fillRef>
+            <a:effectRef idx="0">
+              <a:scrgbClr r="0" g="0" b="0"/>
+            </a:effectRef>
+            <a:fontRef idx="minor">
+              <a:schemeClr val="lt1"/>
+            </a:fontRef>
+          </p:style>
+          <p:txBody>
+            <a:bodyPr rtlCol="0" anchor="ctr" anchorCtr="1"/>
+            <a:lstStyle/>
+            <a:p>
+              <a:pPr marL="0" marR="0" lvl="0" indent="0" algn="ctr" defTabSz="1218804" rtl="0" eaLnBrk="0" fontAlgn="base" latinLnBrk="0" hangingPunct="0">
+                <a:lnSpc>
+                  <a:spcPct val="100000"/>
+                </a:lnSpc>
+                <a:spcBef>
+                  <a:spcPct val="0"/>
+                </a:spcBef>
+                <a:spcAft>
+                  <a:spcPct val="0"/>
+                </a:spcAft>
+                <a:buClrTx/>
+                <a:buSzTx/>
+                <a:buFontTx/>
+                <a:buNone/>
+                <a:tabLst/>
+                <a:defRPr/>
+              </a:pPr>
+              <a:r>
+                <a:rPr kumimoji="1" lang="sv-SE" altLang="ja-JP" sz="1600" b="0" i="0" strike="noStrike" kern="1200" cap="none" spc="0" normalizeH="0" baseline="0" noProof="0" dirty="0">
+                  <a:ln>
+                    <a:noFill/>
+                  </a:ln>
+                  <a:solidFill>
+                    <a:prstClr val="white"/>
+                  </a:solidFill>
+                  <a:effectLst/>
+                  <a:uLnTx/>
+                  <a:uFillTx/>
+                  <a:latin typeface="Arial" panose="020B0604020202020204" pitchFamily="34" charset="0"/>
+                  <a:ea typeface="Lato Light" panose="020F0502020204030203" pitchFamily="34" charset="0"/>
+                  <a:cs typeface="Arial" panose="020B0604020202020204" pitchFamily="34" charset="0"/>
+                </a:rPr>
+                <a:t>Ethos-U</a:t>
+              </a:r>
+              <a:br>
+                <a:rPr kumimoji="1" lang="sv-SE" altLang="ja-JP" sz="1600" b="0" i="0" strike="noStrike" kern="1200" cap="none" spc="0" normalizeH="0" baseline="0" noProof="0" dirty="0">
+                  <a:ln>
+                    <a:noFill/>
+                  </a:ln>
+                  <a:solidFill>
+                    <a:prstClr val="white"/>
+                  </a:solidFill>
+                  <a:effectLst/>
+                  <a:uLnTx/>
+                  <a:uFillTx/>
+                  <a:latin typeface="Arial" panose="020B0604020202020204" pitchFamily="34" charset="0"/>
+                  <a:ea typeface="Lato Light" panose="020F0502020204030203" pitchFamily="34" charset="0"/>
+                  <a:cs typeface="Arial" panose="020B0604020202020204" pitchFamily="34" charset="0"/>
+                </a:rPr>
+              </a:br>
+              <a:r>
+                <a:rPr kumimoji="1" lang="sv-SE" altLang="ja-JP" sz="1600" b="0" i="0" strike="noStrike" kern="1200" cap="none" spc="0" normalizeH="0" baseline="0" noProof="0" dirty="0">
+                  <a:ln>
+                    <a:noFill/>
+                  </a:ln>
+                  <a:solidFill>
+                    <a:prstClr val="white"/>
+                  </a:solidFill>
+                  <a:effectLst/>
+                  <a:uLnTx/>
+                  <a:uFillTx/>
+                  <a:latin typeface="Arial" panose="020B0604020202020204" pitchFamily="34" charset="0"/>
+                  <a:ea typeface="Lato Light" panose="020F0502020204030203" pitchFamily="34" charset="0"/>
+                  <a:cs typeface="Arial" panose="020B0604020202020204" pitchFamily="34" charset="0"/>
+                </a:rPr>
+                <a:t>NPU</a:t>
+              </a:r>
+              <a:endParaRPr kumimoji="0" lang="en-US" altLang="ja-JP" sz="1600" b="0" i="0" strike="noStrike" kern="1200" cap="none" spc="0" normalizeH="0" baseline="0" noProof="0" dirty="0">
+                <a:ln>
+                  <a:noFill/>
+                </a:ln>
+                <a:solidFill>
+                  <a:prstClr val="white"/>
+                </a:solidFill>
+                <a:effectLst/>
+                <a:uLnTx/>
+                <a:uFillTx/>
+                <a:latin typeface="Arial" panose="020B0604020202020204" pitchFamily="34" charset="0"/>
+                <a:ea typeface="Lato Light" panose="020F0502020204030203" pitchFamily="34" charset="0"/>
+                <a:cs typeface="Arial" panose="020B0604020202020204" pitchFamily="34" charset="0"/>
+              </a:endParaRPr>
+            </a:p>
+          </p:txBody>
+        </p:sp>
+        <p:sp>
+          <p:nvSpPr>
+            <p:cNvPr id="5" name="Right Arrow 4">
+              <a:extLst>
+                <a:ext uri="{FF2B5EF4-FFF2-40B4-BE49-F238E27FC236}">
+                  <a16:creationId xmlns:a16="http://schemas.microsoft.com/office/drawing/2014/main" id="{35A9DB58-9021-15D5-B0A1-248B81DEBC5C}"/>
+                </a:ext>
+              </a:extLst>
+            </p:cNvPr>
+            <p:cNvSpPr>
+              <a:spLocks/>
+            </p:cNvSpPr>
+            <p:nvPr/>
+          </p:nvSpPr>
+          <p:spPr>
+            <a:xfrm>
+              <a:off x="9803819" y="4268498"/>
+              <a:ext cx="291582" cy="535780"/>
+            </a:xfrm>
+            <a:prstGeom prst="rightArrow">
+              <a:avLst/>
+            </a:prstGeom>
+            <a:solidFill>
+              <a:schemeClr val="bg1"/>
+            </a:solidFill>
+            <a:ln>
+              <a:solidFill>
+                <a:schemeClr val="tx2">
+                  <a:lumMod val="40000"/>
+                  <a:lumOff val="60000"/>
+                </a:schemeClr>
+              </a:solidFill>
+            </a:ln>
+          </p:spPr>
+          <p:style>
+            <a:lnRef idx="2">
+              <a:schemeClr val="accent1">
+                <a:shade val="50000"/>
+              </a:schemeClr>
+            </a:lnRef>
+            <a:fillRef idx="1">
+              <a:schemeClr val="accent1"/>
+            </a:fillRef>
+            <a:effectRef idx="0">
+              <a:schemeClr val="accent1"/>
+            </a:effectRef>
+            <a:fontRef idx="minor">
+              <a:schemeClr val="lt1"/>
+            </a:fontRef>
+          </p:style>
+          <p:txBody>
+            <a:bodyPr rtlCol="0" anchor="ctr"/>
+            <a:lstStyle/>
+            <a:p>
+              <a:pPr algn="ctr"/>
+              <a:endParaRPr lang="en-DE">
+                <a:latin typeface="Arial" panose="020B0604020202020204" pitchFamily="34" charset="0"/>
+                <a:cs typeface="Arial" panose="020B0604020202020204" pitchFamily="34" charset="0"/>
+              </a:endParaRPr>
+            </a:p>
+          </p:txBody>
+        </p:sp>
+        <p:sp>
+          <p:nvSpPr>
+            <p:cNvPr id="6" name="Right Arrow 5">
+              <a:extLst>
+                <a:ext uri="{FF2B5EF4-FFF2-40B4-BE49-F238E27FC236}">
+                  <a16:creationId xmlns:a16="http://schemas.microsoft.com/office/drawing/2014/main" id="{6792AC77-5ADC-3376-F910-01D2C822BD50}"/>
+                </a:ext>
+              </a:extLst>
+            </p:cNvPr>
+            <p:cNvSpPr>
+              <a:spLocks/>
+            </p:cNvSpPr>
+            <p:nvPr/>
+          </p:nvSpPr>
+          <p:spPr>
+            <a:xfrm>
+              <a:off x="8314097" y="2836040"/>
+              <a:ext cx="295860" cy="535780"/>
+            </a:xfrm>
+            <a:prstGeom prst="rightArrow">
+              <a:avLst/>
+            </a:prstGeom>
+            <a:solidFill>
+              <a:schemeClr val="bg1"/>
+            </a:solidFill>
+            <a:ln>
+              <a:solidFill>
+                <a:schemeClr val="tx2">
+                  <a:lumMod val="40000"/>
+                  <a:lumOff val="60000"/>
+                </a:schemeClr>
+              </a:solidFill>
+            </a:ln>
+          </p:spPr>
+          <p:style>
+            <a:lnRef idx="2">
+              <a:schemeClr val="accent1">
+                <a:shade val="50000"/>
+              </a:schemeClr>
+            </a:lnRef>
+            <a:fillRef idx="1">
+              <a:schemeClr val="accent1"/>
+            </a:fillRef>
+            <a:effectRef idx="0">
+              <a:schemeClr val="accent1"/>
+            </a:effectRef>
+            <a:fontRef idx="minor">
+              <a:schemeClr val="lt1"/>
+            </a:fontRef>
+          </p:style>
+          <p:txBody>
+            <a:bodyPr rtlCol="0" anchor="ctr"/>
+            <a:lstStyle/>
+            <a:p>
+              <a:pPr algn="ctr"/>
+              <a:endParaRPr lang="en-DE">
+                <a:latin typeface="Arial" panose="020B0604020202020204" pitchFamily="34" charset="0"/>
+                <a:cs typeface="Arial" panose="020B0604020202020204" pitchFamily="34" charset="0"/>
+              </a:endParaRPr>
+            </a:p>
+          </p:txBody>
+        </p:sp>
+        <p:sp>
+          <p:nvSpPr>
+            <p:cNvPr id="7" name="Right Arrow 6">
+              <a:extLst>
+                <a:ext uri="{FF2B5EF4-FFF2-40B4-BE49-F238E27FC236}">
+                  <a16:creationId xmlns:a16="http://schemas.microsoft.com/office/drawing/2014/main" id="{55BA382B-F929-ECE0-44E6-F8EB5270DB98}"/>
+                </a:ext>
+              </a:extLst>
+            </p:cNvPr>
+            <p:cNvSpPr>
+              <a:spLocks/>
+            </p:cNvSpPr>
+            <p:nvPr/>
+          </p:nvSpPr>
+          <p:spPr>
+            <a:xfrm>
+              <a:off x="8314097" y="4280855"/>
+              <a:ext cx="295860" cy="535780"/>
+            </a:xfrm>
+            <a:prstGeom prst="rightArrow">
+              <a:avLst/>
+            </a:prstGeom>
+            <a:solidFill>
+              <a:schemeClr val="bg1"/>
+            </a:solidFill>
+            <a:ln>
+              <a:solidFill>
+                <a:schemeClr val="tx2">
+                  <a:lumMod val="40000"/>
+                  <a:lumOff val="60000"/>
+                </a:schemeClr>
+              </a:solidFill>
+            </a:ln>
+          </p:spPr>
+          <p:style>
+            <a:lnRef idx="2">
+              <a:schemeClr val="accent1">
+                <a:shade val="50000"/>
+              </a:schemeClr>
+            </a:lnRef>
+            <a:fillRef idx="1">
+              <a:schemeClr val="accent1"/>
+            </a:fillRef>
+            <a:effectRef idx="0">
+              <a:schemeClr val="accent1"/>
+            </a:effectRef>
+            <a:fontRef idx="minor">
+              <a:schemeClr val="lt1"/>
+            </a:fontRef>
+          </p:style>
+          <p:txBody>
+            <a:bodyPr rtlCol="0" anchor="ctr"/>
+            <a:lstStyle/>
+            <a:p>
+              <a:pPr algn="ctr"/>
+              <a:endParaRPr lang="en-DE">
+                <a:latin typeface="Arial" panose="020B0604020202020204" pitchFamily="34" charset="0"/>
+                <a:cs typeface="Arial" panose="020B0604020202020204" pitchFamily="34" charset="0"/>
+              </a:endParaRPr>
+            </a:p>
+          </p:txBody>
+        </p:sp>
+        <p:sp>
+          <p:nvSpPr>
+            <p:cNvPr id="13" name="角丸四角形 6">
+              <a:extLst>
+                <a:ext uri="{FF2B5EF4-FFF2-40B4-BE49-F238E27FC236}">
+                  <a16:creationId xmlns:a16="http://schemas.microsoft.com/office/drawing/2014/main" id="{534ABEDD-191D-79F6-2C95-881D3883CB3D}"/>
+                </a:ext>
+              </a:extLst>
+            </p:cNvPr>
+            <p:cNvSpPr>
+              <a:spLocks/>
+            </p:cNvSpPr>
+            <p:nvPr/>
+          </p:nvSpPr>
+          <p:spPr>
+            <a:xfrm rot="16200000">
+              <a:off x="6804065" y="3538943"/>
+              <a:ext cx="2465152" cy="540000"/>
+            </a:xfrm>
+            <a:prstGeom prst="roundRect">
+              <a:avLst>
+                <a:gd name="adj" fmla="val 0"/>
+              </a:avLst>
+            </a:prstGeom>
+            <a:solidFill>
+              <a:schemeClr val="accent4"/>
+            </a:solidFill>
+            <a:ln w="15875">
+              <a:solidFill>
+                <a:schemeClr val="accent4"/>
+              </a:solidFill>
+            </a:ln>
+          </p:spPr>
+          <p:style>
+            <a:lnRef idx="2">
+              <a:schemeClr val="accent4"/>
+            </a:lnRef>
+            <a:fillRef idx="1">
+              <a:schemeClr val="lt1"/>
+            </a:fillRef>
+            <a:effectRef idx="0">
+              <a:schemeClr val="accent4"/>
+            </a:effectRef>
+            <a:fontRef idx="minor">
+              <a:schemeClr val="dk1"/>
+            </a:fontRef>
+          </p:style>
+          <p:txBody>
+            <a:bodyPr rtlCol="0" anchor="ctr" anchorCtr="1"/>
+            <a:lstStyle/>
+            <a:p>
+              <a:pPr marL="0" marR="0" lvl="0" indent="0" algn="ctr" defTabSz="1218804" rtl="0" eaLnBrk="0" fontAlgn="base" latinLnBrk="0" hangingPunct="0">
+                <a:lnSpc>
+                  <a:spcPct val="100000"/>
+                </a:lnSpc>
+                <a:spcBef>
+                  <a:spcPct val="0"/>
+                </a:spcBef>
+                <a:spcAft>
+                  <a:spcPct val="0"/>
+                </a:spcAft>
+                <a:buClrTx/>
+                <a:buSzTx/>
+                <a:buFontTx/>
+                <a:buNone/>
+                <a:tabLst/>
+                <a:defRPr/>
+              </a:pPr>
+              <a:r>
+                <a:rPr kumimoji="1" lang="sv-SE" altLang="ja-JP" sz="1600">
+                  <a:solidFill>
+                    <a:sysClr val="windowText" lastClr="000000"/>
+                  </a:solidFill>
+                  <a:latin typeface="Arial" panose="020B0604020202020204" pitchFamily="34" charset="0"/>
+                  <a:ea typeface="Lato Light" panose="020F0502020204030203" pitchFamily="34" charset="0"/>
+                  <a:cs typeface="Arial" panose="020B0604020202020204" pitchFamily="34" charset="0"/>
+                </a:rPr>
+                <a:t>ML </a:t>
+              </a:r>
+              <a:r>
+                <a:rPr kumimoji="1" lang="sv-SE" altLang="ja-JP" sz="1600" err="1">
+                  <a:solidFill>
+                    <a:sysClr val="windowText" lastClr="000000"/>
+                  </a:solidFill>
+                  <a:latin typeface="Arial" panose="020B0604020202020204" pitchFamily="34" charset="0"/>
+                  <a:ea typeface="Lato Light" panose="020F0502020204030203" pitchFamily="34" charset="0"/>
+                  <a:cs typeface="Arial" panose="020B0604020202020204" pitchFamily="34" charset="0"/>
+                </a:rPr>
+                <a:t>Runtime</a:t>
+              </a:r>
+              <a:endParaRPr kumimoji="1" lang="ja-JP" altLang="en-US" sz="1600" b="0" i="0" strike="noStrike" kern="1200" cap="none" spc="0" normalizeH="0" baseline="0" noProof="0">
+                <a:ln>
+                  <a:noFill/>
+                </a:ln>
+                <a:solidFill>
+                  <a:sysClr val="windowText" lastClr="000000"/>
+                </a:solidFill>
+                <a:effectLst/>
+                <a:uLnTx/>
+                <a:uFillTx/>
+                <a:latin typeface="Arial" panose="020B0604020202020204" pitchFamily="34" charset="0"/>
+                <a:ea typeface="游ゴシック" panose="020B0400000000000000" pitchFamily="34" charset="-128"/>
+                <a:cs typeface="Arial" panose="020B0604020202020204" pitchFamily="34" charset="0"/>
+              </a:endParaRPr>
+            </a:p>
+          </p:txBody>
+        </p:sp>
+        <p:sp>
+          <p:nvSpPr>
+            <p:cNvPr id="10" name="Right Arrow 9">
+              <a:extLst>
+                <a:ext uri="{FF2B5EF4-FFF2-40B4-BE49-F238E27FC236}">
+                  <a16:creationId xmlns:a16="http://schemas.microsoft.com/office/drawing/2014/main" id="{3EE4516D-7C33-A3F6-E7B5-C7791AD7D786}"/>
+                </a:ext>
+              </a:extLst>
+            </p:cNvPr>
+            <p:cNvSpPr>
+              <a:spLocks/>
+            </p:cNvSpPr>
+            <p:nvPr/>
+          </p:nvSpPr>
+          <p:spPr>
+            <a:xfrm>
+              <a:off x="7491163" y="3573392"/>
+              <a:ext cx="270288" cy="535780"/>
+            </a:xfrm>
+            <a:prstGeom prst="rightArrow">
+              <a:avLst/>
+            </a:prstGeom>
+            <a:solidFill>
+              <a:schemeClr val="bg1"/>
+            </a:solidFill>
+            <a:ln>
+              <a:solidFill>
+                <a:schemeClr val="tx2">
+                  <a:lumMod val="40000"/>
+                  <a:lumOff val="60000"/>
+                </a:schemeClr>
+              </a:solidFill>
+            </a:ln>
+          </p:spPr>
+          <p:style>
+            <a:lnRef idx="2">
+              <a:schemeClr val="accent1">
+                <a:shade val="50000"/>
+              </a:schemeClr>
+            </a:lnRef>
+            <a:fillRef idx="1">
+              <a:schemeClr val="accent1"/>
+            </a:fillRef>
+            <a:effectRef idx="0">
+              <a:schemeClr val="accent1"/>
+            </a:effectRef>
+            <a:fontRef idx="minor">
+              <a:schemeClr val="lt1"/>
+            </a:fontRef>
+          </p:style>
+          <p:txBody>
+            <a:bodyPr rtlCol="0" anchor="ctr"/>
+            <a:lstStyle/>
+            <a:p>
+              <a:pPr algn="ctr"/>
+              <a:endParaRPr lang="en-DE">
+                <a:latin typeface="Arial" panose="020B0604020202020204" pitchFamily="34" charset="0"/>
+                <a:cs typeface="Arial" panose="020B0604020202020204" pitchFamily="34" charset="0"/>
+              </a:endParaRPr>
+            </a:p>
+          </p:txBody>
+        </p:sp>
+        <p:sp>
+          <p:nvSpPr>
+            <p:cNvPr id="21" name="角丸四角形 6">
+              <a:extLst>
+                <a:ext uri="{FF2B5EF4-FFF2-40B4-BE49-F238E27FC236}">
+                  <a16:creationId xmlns:a16="http://schemas.microsoft.com/office/drawing/2014/main" id="{F9658CB8-2E82-CCFE-A383-8CC6716E96E7}"/>
+                </a:ext>
+              </a:extLst>
+            </p:cNvPr>
+            <p:cNvSpPr>
+              <a:spLocks/>
+            </p:cNvSpPr>
+            <p:nvPr/>
+          </p:nvSpPr>
+          <p:spPr>
+            <a:xfrm>
+              <a:off x="6388357" y="3320008"/>
+              <a:ext cx="1098040" cy="977868"/>
+            </a:xfrm>
+            <a:prstGeom prst="roundRect">
+              <a:avLst>
+                <a:gd name="adj" fmla="val 0"/>
+              </a:avLst>
+            </a:prstGeom>
+            <a:solidFill>
+              <a:schemeClr val="accent1"/>
+            </a:solidFill>
+            <a:ln w="15875">
+              <a:noFill/>
+            </a:ln>
+          </p:spPr>
+          <p:style>
+            <a:lnRef idx="2">
+              <a:schemeClr val="accent4"/>
+            </a:lnRef>
+            <a:fillRef idx="1">
+              <a:schemeClr val="lt1"/>
+            </a:fillRef>
+            <a:effectRef idx="0">
+              <a:schemeClr val="accent4"/>
+            </a:effectRef>
+            <a:fontRef idx="minor">
+              <a:schemeClr val="dk1"/>
+            </a:fontRef>
+          </p:style>
+          <p:txBody>
+            <a:bodyPr lIns="0" tIns="60960" rIns="0" bIns="60960" rtlCol="0" anchor="ctr" anchorCtr="1"/>
+            <a:lstStyle/>
+            <a:p>
+              <a:pPr marL="0" marR="0" lvl="0" indent="0" algn="ctr" defTabSz="1218804" rtl="0" eaLnBrk="0" fontAlgn="base" latinLnBrk="0" hangingPunct="0">
+                <a:lnSpc>
+                  <a:spcPct val="100000"/>
+                </a:lnSpc>
+                <a:spcBef>
+                  <a:spcPct val="0"/>
+                </a:spcBef>
+                <a:spcAft>
+                  <a:spcPct val="0"/>
+                </a:spcAft>
+                <a:buClrTx/>
+                <a:buSzTx/>
+                <a:buFontTx/>
+                <a:buNone/>
+                <a:tabLst/>
+                <a:defRPr/>
+              </a:pPr>
+              <a:r>
+                <a:rPr kumimoji="1" lang="sv-SE" altLang="ja-JP" sz="1600" dirty="0">
+                  <a:solidFill>
+                    <a:srgbClr val="FFFFFF"/>
+                  </a:solidFill>
+                  <a:latin typeface="Arial" panose="020B0604020202020204" pitchFamily="34" charset="0"/>
+                  <a:ea typeface="Lato Light"/>
+                  <a:cs typeface="Arial" panose="020B0604020202020204" pitchFamily="34" charset="0"/>
+                </a:rPr>
+                <a:t>Optimized</a:t>
+              </a:r>
+              <a:br>
+                <a:rPr kumimoji="1" lang="sv-SE" altLang="ja-JP" sz="1600" b="0" i="0" strike="noStrike" kern="1200" cap="none" spc="0" normalizeH="0" baseline="0" noProof="0" dirty="0">
+                  <a:ln>
+                    <a:noFill/>
+                  </a:ln>
+                  <a:solidFill>
+                    <a:srgbClr val="FFFFFF"/>
+                  </a:solidFill>
+                  <a:effectLst/>
+                  <a:uLnTx/>
+                  <a:uFillTx/>
+                  <a:latin typeface="Arial" panose="020B0604020202020204" pitchFamily="34" charset="0"/>
+                  <a:ea typeface="Lato Light"/>
+                  <a:cs typeface="Arial" panose="020B0604020202020204" pitchFamily="34" charset="0"/>
+                </a:rPr>
+              </a:br>
+              <a:r>
+                <a:rPr kumimoji="1" lang="sv-SE" altLang="ja-JP" sz="1600" b="0" i="0" strike="noStrike" kern="1200" cap="none" spc="0" normalizeH="0" baseline="0" noProof="0" dirty="0">
+                  <a:ln>
+                    <a:noFill/>
+                  </a:ln>
+                  <a:solidFill>
+                    <a:srgbClr val="FFFFFF"/>
+                  </a:solidFill>
+                  <a:effectLst/>
+                  <a:uLnTx/>
+                  <a:uFillTx/>
+                  <a:latin typeface="Arial" panose="020B0604020202020204" pitchFamily="34" charset="0"/>
+                  <a:ea typeface="Lato Light"/>
+                  <a:cs typeface="Arial" panose="020B0604020202020204" pitchFamily="34" charset="0"/>
+                </a:rPr>
+                <a:t>ML Model</a:t>
+              </a:r>
+              <a:endParaRPr kumimoji="0" lang="sv-SE" altLang="ja-JP" sz="1600" b="0" i="0" strike="noStrike" kern="1200" cap="none" spc="0" normalizeH="0" baseline="0" noProof="0" dirty="0">
+                <a:ln>
+                  <a:noFill/>
+                </a:ln>
+                <a:solidFill>
+                  <a:srgbClr val="FFFFFF"/>
+                </a:solidFill>
+                <a:effectLst/>
+                <a:uLnTx/>
+                <a:uFillTx/>
+                <a:latin typeface="Arial" panose="020B0604020202020204" pitchFamily="34" charset="0"/>
+                <a:ea typeface="Lato Light"/>
+                <a:cs typeface="Arial" panose="020B0604020202020204" pitchFamily="34" charset="0"/>
+              </a:endParaRPr>
+            </a:p>
+          </p:txBody>
+        </p:sp>
+        <p:sp>
+          <p:nvSpPr>
+            <p:cNvPr id="34" name="Process 65">
+              <a:extLst>
+                <a:ext uri="{FF2B5EF4-FFF2-40B4-BE49-F238E27FC236}">
+                  <a16:creationId xmlns:a16="http://schemas.microsoft.com/office/drawing/2014/main" id="{D78E3A6F-F0D1-6849-E045-029BA06C4409}"/>
+                </a:ext>
+              </a:extLst>
+            </p:cNvPr>
+            <p:cNvSpPr>
+              <a:spLocks/>
+            </p:cNvSpPr>
+            <p:nvPr/>
+          </p:nvSpPr>
+          <p:spPr>
+            <a:xfrm>
+              <a:off x="835176" y="2094471"/>
+              <a:ext cx="5138057" cy="3037366"/>
+            </a:xfrm>
+            <a:prstGeom prst="flowChartProcess">
+              <a:avLst/>
+            </a:prstGeom>
+            <a:solidFill>
+              <a:schemeClr val="bg2">
+                <a:lumMod val="50000"/>
+              </a:schemeClr>
+            </a:solidFill>
+            <a:ln w="0">
+              <a:solidFill>
+                <a:schemeClr val="bg1"/>
+              </a:solidFill>
+            </a:ln>
+          </p:spPr>
+          <p:style>
+            <a:lnRef idx="2">
+              <a:schemeClr val="accent1">
+                <a:shade val="50000"/>
+              </a:schemeClr>
+            </a:lnRef>
+            <a:fillRef idx="1">
+              <a:schemeClr val="accent1"/>
+            </a:fillRef>
+            <a:effectRef idx="0">
+              <a:schemeClr val="accent1"/>
+            </a:effectRef>
+            <a:fontRef idx="minor">
+              <a:schemeClr val="lt1"/>
+            </a:fontRef>
+          </p:style>
+          <p:txBody>
+            <a:bodyPr tIns="108000" rtlCol="0" anchor="t"/>
+            <a:lstStyle/>
+            <a:p>
+              <a:pPr defTabSz="1219170">
+                <a:defRPr/>
+              </a:pPr>
+              <a:r>
+                <a:rPr kumimoji="1" lang="en-US" sz="1600" dirty="0">
+                  <a:solidFill>
+                    <a:srgbClr val="FFFFFF"/>
+                  </a:solidFill>
+                  <a:latin typeface="Arial" panose="020B0604020202020204" pitchFamily="34" charset="0"/>
+                  <a:cs typeface="Arial" panose="020B0604020202020204" pitchFamily="34" charset="0"/>
+                </a:rPr>
+                <a:t>DEVICE without Ethos-U</a:t>
+              </a:r>
+            </a:p>
+          </p:txBody>
+        </p:sp>
+        <p:sp>
+          <p:nvSpPr>
+            <p:cNvPr id="36" name="角丸四角形 7">
+              <a:extLst>
+                <a:ext uri="{FF2B5EF4-FFF2-40B4-BE49-F238E27FC236}">
+                  <a16:creationId xmlns:a16="http://schemas.microsoft.com/office/drawing/2014/main" id="{6BBBE024-73F8-B9C7-4BB1-9903544C7DDE}"/>
+                </a:ext>
+              </a:extLst>
+            </p:cNvPr>
+            <p:cNvSpPr>
+              <a:spLocks/>
+            </p:cNvSpPr>
+            <p:nvPr/>
+          </p:nvSpPr>
+          <p:spPr>
+            <a:xfrm>
+              <a:off x="3168584" y="2576367"/>
+              <a:ext cx="1169871" cy="1007207"/>
+            </a:xfrm>
+            <a:prstGeom prst="roundRect">
+              <a:avLst>
+                <a:gd name="adj" fmla="val 0"/>
+              </a:avLst>
+            </a:prstGeom>
+            <a:solidFill>
+              <a:schemeClr val="accent1"/>
+            </a:solidFill>
+            <a:ln>
+              <a:noFill/>
+            </a:ln>
+          </p:spPr>
+          <p:style>
+            <a:lnRef idx="0">
+              <a:scrgbClr r="0" g="0" b="0"/>
+            </a:lnRef>
+            <a:fillRef idx="0">
+              <a:scrgbClr r="0" g="0" b="0"/>
+            </a:fillRef>
+            <a:effectRef idx="0">
+              <a:scrgbClr r="0" g="0" b="0"/>
+            </a:effectRef>
+            <a:fontRef idx="minor">
+              <a:schemeClr val="lt1"/>
+            </a:fontRef>
+          </p:style>
+          <p:txBody>
+            <a:bodyPr lIns="0" rIns="0" rtlCol="0" anchor="ctr" anchorCtr="1"/>
+            <a:lstStyle/>
+            <a:p>
+              <a:pPr marL="0" marR="0" lvl="0" indent="0" algn="ctr" defTabSz="1218804" rtl="0" eaLnBrk="0" fontAlgn="base" latinLnBrk="0" hangingPunct="0">
+                <a:lnSpc>
+                  <a:spcPct val="100000"/>
+                </a:lnSpc>
+                <a:spcBef>
+                  <a:spcPct val="0"/>
+                </a:spcBef>
+                <a:spcAft>
+                  <a:spcPct val="0"/>
+                </a:spcAft>
+                <a:buClrTx/>
+                <a:buSzTx/>
+                <a:buFontTx/>
+                <a:buNone/>
+                <a:tabLst/>
+                <a:defRPr/>
+              </a:pPr>
+              <a:r>
+                <a:rPr kumimoji="1" lang="sv-SE" altLang="ja-JP" sz="1600" b="0" i="0" strike="noStrike" kern="1200" cap="none" spc="0" normalizeH="0" baseline="0" noProof="0" dirty="0">
+                  <a:ln>
+                    <a:noFill/>
+                  </a:ln>
+                  <a:solidFill>
+                    <a:prstClr val="white"/>
+                  </a:solidFill>
+                  <a:effectLst/>
+                  <a:uLnTx/>
+                  <a:uFillTx/>
+                  <a:latin typeface="Arial" panose="020B0604020202020204" pitchFamily="34" charset="0"/>
+                  <a:ea typeface="Lato Light" panose="020F0502020204030203" pitchFamily="34" charset="0"/>
+                  <a:cs typeface="Arial" panose="020B0604020202020204" pitchFamily="34" charset="0"/>
+                </a:rPr>
+                <a:t>CMSIS-NN</a:t>
+              </a:r>
+              <a:endParaRPr kumimoji="0" lang="en-US" sz="1600" b="0" i="0" strike="noStrike" kern="1200" cap="none" spc="0" normalizeH="0" baseline="0" noProof="0" dirty="0">
+                <a:ln>
+                  <a:noFill/>
+                </a:ln>
+                <a:solidFill>
+                  <a:prstClr val="white"/>
+                </a:solidFill>
+                <a:effectLst/>
+                <a:uLnTx/>
+                <a:uFillTx/>
+                <a:latin typeface="Arial" panose="020B0604020202020204" pitchFamily="34" charset="0"/>
+                <a:ea typeface="Lato Light" panose="020F0502020204030203" pitchFamily="34" charset="0"/>
+                <a:cs typeface="Arial" panose="020B0604020202020204" pitchFamily="34" charset="0"/>
+              </a:endParaRPr>
+            </a:p>
+            <a:p>
+              <a:pPr marL="0" marR="0" lvl="0" indent="0" algn="ctr" defTabSz="1218804" rtl="0" eaLnBrk="0" fontAlgn="base" latinLnBrk="0" hangingPunct="0">
+                <a:lnSpc>
+                  <a:spcPct val="100000"/>
+                </a:lnSpc>
+                <a:spcBef>
+                  <a:spcPct val="0"/>
+                </a:spcBef>
+                <a:spcAft>
+                  <a:spcPct val="0"/>
+                </a:spcAft>
+                <a:buClrTx/>
+                <a:buSzTx/>
+                <a:buFontTx/>
+                <a:buNone/>
+                <a:tabLst/>
+                <a:defRPr/>
+              </a:pPr>
+              <a:r>
+                <a:rPr kumimoji="1" lang="sv-SE" altLang="ja-JP" sz="1600" b="0" i="0" strike="noStrike" kern="1200" cap="none" spc="0" normalizeH="0" baseline="0" noProof="0" dirty="0">
+                  <a:ln>
+                    <a:noFill/>
+                  </a:ln>
+                  <a:solidFill>
+                    <a:prstClr val="white"/>
+                  </a:solidFill>
+                  <a:effectLst/>
+                  <a:uLnTx/>
+                  <a:uFillTx/>
+                  <a:latin typeface="Arial" panose="020B0604020202020204" pitchFamily="34" charset="0"/>
+                  <a:ea typeface="Lato Light" panose="020F0502020204030203" pitchFamily="34" charset="0"/>
+                  <a:cs typeface="Arial" panose="020B0604020202020204" pitchFamily="34" charset="0"/>
+                </a:rPr>
+                <a:t>Optimized Kernels</a:t>
+              </a:r>
+              <a:endParaRPr kumimoji="0" lang="en-US" altLang="ja-JP" sz="1600" b="0" i="0" strike="noStrike" kern="1200" cap="none" spc="0" normalizeH="0" baseline="0" noProof="0" dirty="0">
+                <a:ln>
+                  <a:noFill/>
+                </a:ln>
+                <a:solidFill>
+                  <a:prstClr val="white"/>
+                </a:solidFill>
+                <a:effectLst/>
+                <a:uLnTx/>
+                <a:uFillTx/>
+                <a:latin typeface="Arial" panose="020B0604020202020204" pitchFamily="34" charset="0"/>
+                <a:ea typeface="Lato Light" panose="020F0502020204030203" pitchFamily="34" charset="0"/>
+                <a:cs typeface="Arial" panose="020B0604020202020204" pitchFamily="34" charset="0"/>
+              </a:endParaRPr>
+            </a:p>
+          </p:txBody>
+        </p:sp>
+        <p:sp>
+          <p:nvSpPr>
+            <p:cNvPr id="37" name="Rectangle 36">
+              <a:extLst>
+                <a:ext uri="{FF2B5EF4-FFF2-40B4-BE49-F238E27FC236}">
+                  <a16:creationId xmlns:a16="http://schemas.microsoft.com/office/drawing/2014/main" id="{8C49957D-77F3-55EA-17EF-9B23AB39BC3B}"/>
+                </a:ext>
+              </a:extLst>
+            </p:cNvPr>
+            <p:cNvSpPr>
+              <a:spLocks/>
+            </p:cNvSpPr>
+            <p:nvPr/>
+          </p:nvSpPr>
+          <p:spPr>
+            <a:xfrm>
+              <a:off x="4663211" y="2582562"/>
+              <a:ext cx="1169871" cy="991024"/>
+            </a:xfrm>
+            <a:prstGeom prst="rect">
+              <a:avLst/>
+            </a:prstGeom>
+            <a:solidFill>
+              <a:schemeClr val="accent1"/>
+            </a:solidFill>
+            <a:ln>
+              <a:noFill/>
+            </a:ln>
+          </p:spPr>
+          <p:style>
+            <a:lnRef idx="0">
+              <a:scrgbClr r="0" g="0" b="0"/>
+            </a:lnRef>
+            <a:fillRef idx="0">
+              <a:scrgbClr r="0" g="0" b="0"/>
+            </a:fillRef>
+            <a:effectRef idx="0">
+              <a:scrgbClr r="0" g="0" b="0"/>
+            </a:effectRef>
+            <a:fontRef idx="minor">
+              <a:schemeClr val="lt1"/>
+            </a:fontRef>
+          </p:style>
+          <p:txBody>
+            <a:bodyPr rtlCol="0" anchor="ctr"/>
+            <a:lstStyle/>
+            <a:p>
+              <a:pPr marL="0" marR="0" lvl="0" indent="0" algn="ctr" defTabSz="1218804" rtl="0" eaLnBrk="0" fontAlgn="base" latinLnBrk="0" hangingPunct="0">
+                <a:lnSpc>
+                  <a:spcPct val="100000"/>
+                </a:lnSpc>
+                <a:spcBef>
+                  <a:spcPct val="0"/>
+                </a:spcBef>
+                <a:spcAft>
+                  <a:spcPct val="0"/>
+                </a:spcAft>
+                <a:buClrTx/>
+                <a:buSzTx/>
+                <a:buFontTx/>
+                <a:buNone/>
+                <a:tabLst/>
+                <a:defRPr/>
+              </a:pPr>
+              <a:r>
+                <a:rPr kumimoji="0" lang="en-GB" sz="1600" b="0" i="0" strike="noStrike" kern="1200" cap="none" spc="0" normalizeH="0" baseline="0" noProof="0" dirty="0">
+                  <a:ln>
+                    <a:noFill/>
+                  </a:ln>
+                  <a:solidFill>
+                    <a:prstClr val="white"/>
+                  </a:solidFill>
+                  <a:effectLst/>
+                  <a:uLnTx/>
+                  <a:uFillTx/>
+                  <a:latin typeface="Arial" panose="020B0604020202020204" pitchFamily="34" charset="0"/>
+                  <a:ea typeface="Lato Light" panose="020F0502020204030203" pitchFamily="34" charset="0"/>
+                  <a:cs typeface="Arial" panose="020B0604020202020204" pitchFamily="34" charset="0"/>
+                </a:rPr>
+                <a:t>Cortex-M</a:t>
+              </a:r>
+            </a:p>
+            <a:p>
+              <a:pPr marL="0" marR="0" lvl="0" indent="0" algn="ctr" defTabSz="1218804" rtl="0" eaLnBrk="0" fontAlgn="base" latinLnBrk="0" hangingPunct="0">
+                <a:lnSpc>
+                  <a:spcPct val="100000"/>
+                </a:lnSpc>
+                <a:spcBef>
+                  <a:spcPct val="0"/>
+                </a:spcBef>
+                <a:spcAft>
+                  <a:spcPct val="0"/>
+                </a:spcAft>
+                <a:buClrTx/>
+                <a:buSzTx/>
+                <a:buFontTx/>
+                <a:buNone/>
+                <a:tabLst/>
+                <a:defRPr/>
+              </a:pPr>
+              <a:r>
+                <a:rPr kumimoji="0" lang="en-GB" sz="1600" b="0" i="0" strike="noStrike" kern="1200" cap="none" spc="0" normalizeH="0" baseline="0" noProof="0" dirty="0">
+                  <a:ln>
+                    <a:noFill/>
+                  </a:ln>
+                  <a:solidFill>
+                    <a:prstClr val="white"/>
+                  </a:solidFill>
+                  <a:effectLst/>
+                  <a:uLnTx/>
+                  <a:uFillTx/>
+                  <a:latin typeface="Arial" panose="020B0604020202020204" pitchFamily="34" charset="0"/>
+                  <a:ea typeface="Lato Light" panose="020F0502020204030203" pitchFamily="34" charset="0"/>
+                  <a:cs typeface="Arial" panose="020B0604020202020204" pitchFamily="34" charset="0"/>
+                </a:rPr>
+                <a:t>CPU</a:t>
+              </a:r>
+            </a:p>
+          </p:txBody>
+        </p:sp>
+        <p:sp>
+          <p:nvSpPr>
+            <p:cNvPr id="39" name="Right Arrow 34">
+              <a:extLst>
+                <a:ext uri="{FF2B5EF4-FFF2-40B4-BE49-F238E27FC236}">
+                  <a16:creationId xmlns:a16="http://schemas.microsoft.com/office/drawing/2014/main" id="{3D67194A-E195-C210-13AC-168854671DD3}"/>
+                </a:ext>
+              </a:extLst>
+            </p:cNvPr>
+            <p:cNvSpPr>
+              <a:spLocks/>
+            </p:cNvSpPr>
+            <p:nvPr/>
+          </p:nvSpPr>
+          <p:spPr>
+            <a:xfrm>
+              <a:off x="4349873" y="2823683"/>
+              <a:ext cx="295860" cy="535780"/>
+            </a:xfrm>
+            <a:prstGeom prst="rightArrow">
+              <a:avLst/>
+            </a:prstGeom>
+            <a:solidFill>
+              <a:schemeClr val="bg1"/>
+            </a:solidFill>
+            <a:ln>
+              <a:solidFill>
+                <a:schemeClr val="tx2">
+                  <a:lumMod val="40000"/>
+                  <a:lumOff val="60000"/>
+                </a:schemeClr>
+              </a:solidFill>
+            </a:ln>
+          </p:spPr>
+          <p:style>
+            <a:lnRef idx="2">
+              <a:schemeClr val="accent1">
+                <a:shade val="50000"/>
+              </a:schemeClr>
+            </a:lnRef>
+            <a:fillRef idx="1">
+              <a:schemeClr val="accent1"/>
+            </a:fillRef>
+            <a:effectRef idx="0">
+              <a:schemeClr val="accent1"/>
+            </a:effectRef>
+            <a:fontRef idx="minor">
+              <a:schemeClr val="lt1"/>
+            </a:fontRef>
+          </p:style>
+          <p:txBody>
+            <a:bodyPr rtlCol="0" anchor="ctr"/>
+            <a:lstStyle/>
+            <a:p>
+              <a:pPr algn="ctr"/>
+              <a:endParaRPr lang="en-DE">
+                <a:latin typeface="Arial" panose="020B0604020202020204" pitchFamily="34" charset="0"/>
+                <a:cs typeface="Arial" panose="020B0604020202020204" pitchFamily="34" charset="0"/>
+              </a:endParaRPr>
+            </a:p>
+          </p:txBody>
+        </p:sp>
+        <p:sp>
+          <p:nvSpPr>
+            <p:cNvPr id="42" name="Right Arrow 5">
+              <a:extLst>
+                <a:ext uri="{FF2B5EF4-FFF2-40B4-BE49-F238E27FC236}">
+                  <a16:creationId xmlns:a16="http://schemas.microsoft.com/office/drawing/2014/main" id="{1B3E173C-9509-1FC1-6B49-2B69BA109024}"/>
+                </a:ext>
+              </a:extLst>
+            </p:cNvPr>
+            <p:cNvSpPr>
+              <a:spLocks/>
+            </p:cNvSpPr>
+            <p:nvPr/>
+          </p:nvSpPr>
+          <p:spPr>
+            <a:xfrm>
+              <a:off x="2866663" y="2836040"/>
+              <a:ext cx="295860" cy="535780"/>
+            </a:xfrm>
+            <a:prstGeom prst="rightArrow">
+              <a:avLst/>
+            </a:prstGeom>
+            <a:solidFill>
+              <a:schemeClr val="bg1"/>
+            </a:solidFill>
+            <a:ln>
+              <a:solidFill>
+                <a:schemeClr val="tx2">
+                  <a:lumMod val="40000"/>
+                  <a:lumOff val="60000"/>
+                </a:schemeClr>
+              </a:solidFill>
+            </a:ln>
+          </p:spPr>
+          <p:style>
+            <a:lnRef idx="2">
+              <a:schemeClr val="accent1">
+                <a:shade val="50000"/>
+              </a:schemeClr>
+            </a:lnRef>
+            <a:fillRef idx="1">
+              <a:schemeClr val="accent1"/>
+            </a:fillRef>
+            <a:effectRef idx="0">
+              <a:schemeClr val="accent1"/>
+            </a:effectRef>
+            <a:fontRef idx="minor">
+              <a:schemeClr val="lt1"/>
+            </a:fontRef>
+          </p:style>
+          <p:txBody>
+            <a:bodyPr rtlCol="0" anchor="ctr"/>
+            <a:lstStyle/>
+            <a:p>
+              <a:pPr algn="ctr"/>
+              <a:endParaRPr lang="en-DE">
+                <a:latin typeface="Arial" panose="020B0604020202020204" pitchFamily="34" charset="0"/>
+                <a:cs typeface="Arial" panose="020B0604020202020204" pitchFamily="34" charset="0"/>
+              </a:endParaRPr>
+            </a:p>
+          </p:txBody>
+        </p:sp>
+        <p:sp>
+          <p:nvSpPr>
+            <p:cNvPr id="44" name="角丸四角形 6">
+              <a:extLst>
+                <a:ext uri="{FF2B5EF4-FFF2-40B4-BE49-F238E27FC236}">
+                  <a16:creationId xmlns:a16="http://schemas.microsoft.com/office/drawing/2014/main" id="{58E55F26-B848-08F4-A818-8BB09E835E55}"/>
+                </a:ext>
+              </a:extLst>
+            </p:cNvPr>
+            <p:cNvSpPr>
+              <a:spLocks/>
+            </p:cNvSpPr>
+            <p:nvPr/>
+          </p:nvSpPr>
+          <p:spPr>
+            <a:xfrm rot="16200000">
+              <a:off x="1356631" y="3538943"/>
+              <a:ext cx="2465152" cy="540000"/>
+            </a:xfrm>
+            <a:prstGeom prst="roundRect">
+              <a:avLst>
+                <a:gd name="adj" fmla="val 0"/>
+              </a:avLst>
+            </a:prstGeom>
+            <a:solidFill>
+              <a:schemeClr val="accent4"/>
+            </a:solidFill>
+            <a:ln w="15875">
+              <a:solidFill>
+                <a:schemeClr val="accent4"/>
+              </a:solidFill>
+            </a:ln>
+          </p:spPr>
+          <p:style>
+            <a:lnRef idx="2">
+              <a:schemeClr val="accent4"/>
+            </a:lnRef>
+            <a:fillRef idx="1">
+              <a:schemeClr val="lt1"/>
+            </a:fillRef>
+            <a:effectRef idx="0">
+              <a:schemeClr val="accent4"/>
+            </a:effectRef>
+            <a:fontRef idx="minor">
+              <a:schemeClr val="dk1"/>
+            </a:fontRef>
+          </p:style>
+          <p:txBody>
+            <a:bodyPr rtlCol="0" anchor="ctr" anchorCtr="1"/>
+            <a:lstStyle/>
+            <a:p>
+              <a:pPr marL="0" marR="0" lvl="0" indent="0" algn="ctr" defTabSz="1218804" rtl="0" eaLnBrk="0" fontAlgn="base" latinLnBrk="0" hangingPunct="0">
+                <a:lnSpc>
+                  <a:spcPct val="100000"/>
+                </a:lnSpc>
+                <a:spcBef>
+                  <a:spcPct val="0"/>
+                </a:spcBef>
+                <a:spcAft>
+                  <a:spcPct val="0"/>
+                </a:spcAft>
+                <a:buClrTx/>
+                <a:buSzTx/>
+                <a:buFontTx/>
+                <a:buNone/>
+                <a:tabLst/>
+                <a:defRPr/>
+              </a:pPr>
+              <a:r>
+                <a:rPr kumimoji="1" lang="sv-SE" altLang="ja-JP" sz="1600">
+                  <a:solidFill>
+                    <a:sysClr val="windowText" lastClr="000000"/>
+                  </a:solidFill>
+                  <a:latin typeface="Arial" panose="020B0604020202020204" pitchFamily="34" charset="0"/>
+                  <a:ea typeface="Lato Light" panose="020F0502020204030203" pitchFamily="34" charset="0"/>
+                  <a:cs typeface="Arial" panose="020B0604020202020204" pitchFamily="34" charset="0"/>
+                </a:rPr>
+                <a:t>ML </a:t>
+              </a:r>
+              <a:r>
+                <a:rPr kumimoji="1" lang="sv-SE" altLang="ja-JP" sz="1600" err="1">
+                  <a:solidFill>
+                    <a:sysClr val="windowText" lastClr="000000"/>
+                  </a:solidFill>
+                  <a:latin typeface="Arial" panose="020B0604020202020204" pitchFamily="34" charset="0"/>
+                  <a:ea typeface="Lato Light" panose="020F0502020204030203" pitchFamily="34" charset="0"/>
+                  <a:cs typeface="Arial" panose="020B0604020202020204" pitchFamily="34" charset="0"/>
+                </a:rPr>
+                <a:t>Runtime</a:t>
+              </a:r>
+              <a:endParaRPr kumimoji="1" lang="ja-JP" altLang="en-US" sz="1600" b="0" i="0" strike="noStrike" kern="1200" cap="none" spc="0" normalizeH="0" baseline="0" noProof="0">
+                <a:ln>
+                  <a:noFill/>
+                </a:ln>
+                <a:solidFill>
+                  <a:sysClr val="windowText" lastClr="000000"/>
+                </a:solidFill>
+                <a:effectLst/>
+                <a:uLnTx/>
+                <a:uFillTx/>
+                <a:latin typeface="Arial" panose="020B0604020202020204" pitchFamily="34" charset="0"/>
+                <a:ea typeface="游ゴシック" panose="020B0400000000000000" pitchFamily="34" charset="-128"/>
+                <a:cs typeface="Arial" panose="020B0604020202020204" pitchFamily="34" charset="0"/>
+              </a:endParaRPr>
+            </a:p>
+          </p:txBody>
+        </p:sp>
+        <p:sp>
+          <p:nvSpPr>
+            <p:cNvPr id="45" name="Right Arrow 9">
+              <a:extLst>
+                <a:ext uri="{FF2B5EF4-FFF2-40B4-BE49-F238E27FC236}">
+                  <a16:creationId xmlns:a16="http://schemas.microsoft.com/office/drawing/2014/main" id="{8E95FA96-2E8D-1B64-BD01-8C4E31AB494D}"/>
+                </a:ext>
+              </a:extLst>
+            </p:cNvPr>
+            <p:cNvSpPr>
+              <a:spLocks/>
+            </p:cNvSpPr>
+            <p:nvPr/>
+          </p:nvSpPr>
+          <p:spPr>
+            <a:xfrm>
+              <a:off x="2043729" y="3573392"/>
+              <a:ext cx="270288" cy="535780"/>
+            </a:xfrm>
+            <a:prstGeom prst="rightArrow">
+              <a:avLst/>
+            </a:prstGeom>
+            <a:solidFill>
+              <a:schemeClr val="bg1"/>
+            </a:solidFill>
+            <a:ln>
+              <a:solidFill>
+                <a:schemeClr val="tx2">
+                  <a:lumMod val="40000"/>
+                  <a:lumOff val="60000"/>
+                </a:schemeClr>
+              </a:solidFill>
+            </a:ln>
+          </p:spPr>
+          <p:style>
+            <a:lnRef idx="2">
+              <a:schemeClr val="accent1">
+                <a:shade val="50000"/>
+              </a:schemeClr>
+            </a:lnRef>
+            <a:fillRef idx="1">
+              <a:schemeClr val="accent1"/>
+            </a:fillRef>
+            <a:effectRef idx="0">
+              <a:schemeClr val="accent1"/>
+            </a:effectRef>
+            <a:fontRef idx="minor">
+              <a:schemeClr val="lt1"/>
+            </a:fontRef>
+          </p:style>
+          <p:txBody>
+            <a:bodyPr rtlCol="0" anchor="ctr"/>
+            <a:lstStyle/>
+            <a:p>
+              <a:pPr algn="ctr"/>
+              <a:endParaRPr lang="en-DE">
+                <a:latin typeface="Arial" panose="020B0604020202020204" pitchFamily="34" charset="0"/>
+                <a:cs typeface="Arial" panose="020B0604020202020204" pitchFamily="34" charset="0"/>
+              </a:endParaRPr>
+            </a:p>
+          </p:txBody>
+        </p:sp>
+        <p:sp>
+          <p:nvSpPr>
+            <p:cNvPr id="46" name="角丸四角形 6">
+              <a:extLst>
+                <a:ext uri="{FF2B5EF4-FFF2-40B4-BE49-F238E27FC236}">
+                  <a16:creationId xmlns:a16="http://schemas.microsoft.com/office/drawing/2014/main" id="{5A2633CC-FA49-C38E-8FF7-4BB7478E5E53}"/>
+                </a:ext>
+              </a:extLst>
+            </p:cNvPr>
+            <p:cNvSpPr>
+              <a:spLocks/>
+            </p:cNvSpPr>
+            <p:nvPr/>
+          </p:nvSpPr>
+          <p:spPr>
+            <a:xfrm>
+              <a:off x="940923" y="3320008"/>
+              <a:ext cx="1098040" cy="977868"/>
+            </a:xfrm>
+            <a:prstGeom prst="roundRect">
+              <a:avLst>
+                <a:gd name="adj" fmla="val 0"/>
+              </a:avLst>
+            </a:prstGeom>
+            <a:solidFill>
+              <a:schemeClr val="accent1"/>
+            </a:solidFill>
+            <a:ln w="15875">
+              <a:noFill/>
+            </a:ln>
+          </p:spPr>
+          <p:style>
+            <a:lnRef idx="2">
+              <a:schemeClr val="accent4"/>
+            </a:lnRef>
+            <a:fillRef idx="1">
+              <a:schemeClr val="lt1"/>
+            </a:fillRef>
+            <a:effectRef idx="0">
+              <a:schemeClr val="accent4"/>
+            </a:effectRef>
+            <a:fontRef idx="minor">
+              <a:schemeClr val="dk1"/>
+            </a:fontRef>
+          </p:style>
+          <p:txBody>
+            <a:bodyPr lIns="0" tIns="60960" rIns="0" bIns="60960" rtlCol="0" anchor="ctr" anchorCtr="1"/>
+            <a:lstStyle/>
+            <a:p>
+              <a:pPr marL="0" marR="0" lvl="0" indent="0" algn="ctr" defTabSz="1218804" rtl="0" eaLnBrk="0" fontAlgn="base" latinLnBrk="0" hangingPunct="0">
+                <a:lnSpc>
+                  <a:spcPct val="100000"/>
+                </a:lnSpc>
+                <a:spcBef>
+                  <a:spcPct val="0"/>
+                </a:spcBef>
+                <a:spcAft>
+                  <a:spcPct val="0"/>
+                </a:spcAft>
+                <a:buClrTx/>
+                <a:buSzTx/>
+                <a:buFontTx/>
+                <a:buNone/>
+                <a:tabLst/>
+                <a:defRPr/>
+              </a:pPr>
+              <a:r>
+                <a:rPr kumimoji="1" lang="sv-SE" altLang="ja-JP" sz="1600" dirty="0">
+                  <a:solidFill>
+                    <a:srgbClr val="FFFFFF"/>
+                  </a:solidFill>
+                  <a:latin typeface="Arial" panose="020B0604020202020204" pitchFamily="34" charset="0"/>
+                  <a:ea typeface="Lato Light"/>
+                  <a:cs typeface="Arial" panose="020B0604020202020204" pitchFamily="34" charset="0"/>
+                </a:rPr>
+                <a:t>Optimized</a:t>
+              </a:r>
+              <a:br>
+                <a:rPr kumimoji="1" lang="sv-SE" altLang="ja-JP" sz="1600" b="0" i="0" strike="noStrike" kern="1200" cap="none" spc="0" normalizeH="0" baseline="0" noProof="0" dirty="0">
+                  <a:ln>
+                    <a:noFill/>
+                  </a:ln>
+                  <a:solidFill>
+                    <a:srgbClr val="FFFFFF"/>
+                  </a:solidFill>
+                  <a:effectLst/>
+                  <a:uLnTx/>
+                  <a:uFillTx/>
+                  <a:latin typeface="Arial" panose="020B0604020202020204" pitchFamily="34" charset="0"/>
+                  <a:ea typeface="Lato Light"/>
+                  <a:cs typeface="Arial" panose="020B0604020202020204" pitchFamily="34" charset="0"/>
+                </a:rPr>
+              </a:br>
+              <a:r>
+                <a:rPr kumimoji="1" lang="sv-SE" altLang="ja-JP" sz="1600" b="0" i="0" strike="noStrike" kern="1200" cap="none" spc="0" normalizeH="0" baseline="0" noProof="0" dirty="0">
+                  <a:ln>
+                    <a:noFill/>
+                  </a:ln>
+                  <a:solidFill>
+                    <a:srgbClr val="FFFFFF"/>
+                  </a:solidFill>
+                  <a:effectLst/>
+                  <a:uLnTx/>
+                  <a:uFillTx/>
+                  <a:latin typeface="Arial" panose="020B0604020202020204" pitchFamily="34" charset="0"/>
+                  <a:ea typeface="Lato Light"/>
+                  <a:cs typeface="Arial" panose="020B0604020202020204" pitchFamily="34" charset="0"/>
+                </a:rPr>
+                <a:t>ML Model</a:t>
+              </a:r>
+              <a:endParaRPr kumimoji="0" lang="sv-SE" altLang="ja-JP" sz="1600" b="0" i="0" strike="noStrike" kern="1200" cap="none" spc="0" normalizeH="0" baseline="0" noProof="0" dirty="0">
+                <a:ln>
+                  <a:noFill/>
+                </a:ln>
+                <a:solidFill>
+                  <a:srgbClr val="FFFFFF"/>
+                </a:solidFill>
+                <a:effectLst/>
+                <a:uLnTx/>
+                <a:uFillTx/>
+                <a:latin typeface="Arial" panose="020B0604020202020204" pitchFamily="34" charset="0"/>
+                <a:ea typeface="Lato Light"/>
+                <a:cs typeface="Arial" panose="020B0604020202020204" pitchFamily="34" charset="0"/>
+              </a:endParaRPr>
+            </a:p>
+          </p:txBody>
+        </p:sp>
+      </p:grpSp>
+    </p:spTree>
+    <p:extLst>
+      <p:ext uri="{BB962C8B-B14F-4D97-AF65-F5344CB8AC3E}">
+        <p14:creationId xmlns:p14="http://schemas.microsoft.com/office/powerpoint/2010/main" val="1992346745"/>
       </p:ext>
     </p:extLst>
   </p:cSld>

</xml_diff>